<commit_message>
docs: review pass v2.1 - fix skill/knowledge decision logic
The three-rule test read as "all pass => skill", but bad_plans / global_lessons
pass all three yet are knowledge. Reframe the three rules as exclusion-only
(necessary, not sufficient) and add the primary criterion: procedure/how-to =>
skill (optimized by rewording + eval), fact/lesson => knowledge (maintained by
add/correct entries); "consult the list" is a skill, "the list" is knowledge.
Document bad_plans / global_lessons as knowledge with a graduation path to
technique/ skills. Mirror the criterion onto PPT slide 5. Bump to v2.1.

https://claude.ai/code/session_013oAGMrzFKckS8vfkoJn8om
</commit_message>
<xml_diff>
--- a/docs/Team_Skill_Hub_Design_Slides.pptx
+++ b/docs/Team_Skill_Hub_Design_Slides.pptx
@@ -3792,7 +3792,7 @@
                 <a:ea typeface="Microsoft YaHei"/>
                 <a:cs typeface="Microsoft YaHei"/>
               </a:rPr>
-              <a:t>Draft v2.0  ·  2026-05  ·  研究 + 方案设计</a:t>
+              <a:t>Draft v2.1  ·  2026-05  ·  研究 + 方案设计</a:t>
             </a:r>
           </a:p>
         </p:txBody>
@@ -4978,7 +4978,7 @@
                 <a:ea typeface="Microsoft YaHei"/>
                 <a:cs typeface="Microsoft YaHei"/>
               </a:rPr>
-              <a:t>Team Skill Hub · Draft v2.0 · 2026-05</a:t>
+              <a:t>Team Skill Hub · Draft v2.1 · 2026-05</a:t>
             </a:r>
           </a:p>
         </p:txBody>
@@ -6383,7 +6383,7 @@
                 <a:ea typeface="Microsoft YaHei"/>
                 <a:cs typeface="Microsoft YaHei"/>
               </a:rPr>
-              <a:t>Team Skill Hub · Draft v2.0 · 2026-05</a:t>
+              <a:t>Team Skill Hub · Draft v2.1 · 2026-05</a:t>
             </a:r>
           </a:p>
         </p:txBody>
@@ -7559,7 +7559,7 @@
                 <a:ea typeface="Microsoft YaHei"/>
                 <a:cs typeface="Microsoft YaHei"/>
               </a:rPr>
-              <a:t>Team Skill Hub · Draft v2.0 · 2026-05</a:t>
+              <a:t>Team Skill Hub · Draft v2.1 · 2026-05</a:t>
             </a:r>
           </a:p>
         </p:txBody>
@@ -7753,7 +7753,7 @@
                 <a:ea typeface="Microsoft YaHei"/>
                 <a:cs typeface="Microsoft YaHei"/>
               </a:rPr>
-              <a:t>只有 3 个维度是真正的 skill 文件夹；file / function → knowledge</a:t>
+              <a:t>首要判据：做法/流程=skill，事实/教训=knowledge；只有 3 个维度是真正的 skill 文件夹</a:t>
             </a:r>
           </a:p>
         </p:txBody>
@@ -7810,8 +7810,74 @@
         </p:nvSpPr>
         <p:spPr>
           <a:xfrm>
-            <a:off x="548640" y="1325880"/>
-            <a:ext cx="2743200" cy="566928"/>
+            <a:off x="548640" y="1051560"/>
+            <a:ext cx="11091672" cy="384048"/>
+          </a:xfrm>
+          <a:prstGeom prst="roundRect">
+            <a:avLst>
+              <a:gd name="adj" fmla="val 12000"/>
+            </a:avLst>
+          </a:prstGeom>
+          <a:solidFill>
+            <a:srgbClr val="EEF2FF"/>
+          </a:solidFill>
+          <a:ln w="12700">
+            <a:solidFill>
+              <a:srgbClr val="4F46E5"/>
+            </a:solidFill>
+          </a:ln>
+          <a:effectLst/>
+        </p:spPr>
+        <p:style>
+          <a:lnRef idx="1">
+            <a:schemeClr val="accent1"/>
+          </a:lnRef>
+          <a:fillRef idx="3">
+            <a:schemeClr val="accent1"/>
+          </a:fillRef>
+          <a:effectRef idx="2">
+            <a:schemeClr val="accent1"/>
+          </a:effectRef>
+          <a:fontRef idx="minor">
+            <a:schemeClr val="lt1"/>
+          </a:fontRef>
+        </p:style>
+        <p:txBody>
+          <a:bodyPr rtlCol="0" anchor="ctr" wrap="square" lIns="73152" rIns="73152" tIns="27432" bIns="27432"/>
+          <a:lstStyle/>
+          <a:p>
+            <a:pPr algn="ctr">
+              <a:spcBef>
+                <a:spcPts val="0"/>
+              </a:spcBef>
+              <a:spcAft>
+                <a:spcPts val="300"/>
+              </a:spcAft>
+            </a:pPr>
+            <a:r>
+              <a:rPr sz="1100" b="1">
+                <a:solidFill>
+                  <a:srgbClr val="4F46E5"/>
+                </a:solidFill>
+                <a:latin typeface="Microsoft YaHei"/>
+                <a:ea typeface="Microsoft YaHei"/>
+                <a:cs typeface="Microsoft YaHei"/>
+              </a:rPr>
+              <a:t>判定：做法/流程 → skill（照着执行·改措辞调优·eval 衡量）　｜　事实/结论/教训 → knowledge（查阅·增删纠错条目）</a:t>
+            </a:r>
+          </a:p>
+        </p:txBody>
+      </p:sp>
+      <p:sp>
+        <p:nvSpPr>
+          <p:cNvPr id="8" name="Rounded Rectangle 7"/>
+          <p:cNvSpPr/>
+          <p:nvPr/>
+        </p:nvSpPr>
+        <p:spPr>
+          <a:xfrm>
+            <a:off x="548640" y="1627632"/>
+            <a:ext cx="2743200" cy="512064"/>
           </a:xfrm>
           <a:prstGeom prst="roundRect">
             <a:avLst>
@@ -7870,14 +7936,14 @@
       </p:sp>
       <p:sp>
         <p:nvSpPr>
-          <p:cNvPr id="8" name="Rounded Rectangle 7"/>
+          <p:cNvPr id="9" name="Rounded Rectangle 8"/>
           <p:cNvSpPr/>
           <p:nvPr/>
         </p:nvSpPr>
         <p:spPr>
           <a:xfrm>
-            <a:off x="548640" y="2039112"/>
-            <a:ext cx="2743200" cy="566928"/>
+            <a:off x="548640" y="2286000"/>
+            <a:ext cx="2743200" cy="512064"/>
           </a:xfrm>
           <a:prstGeom prst="roundRect">
             <a:avLst>
@@ -7936,14 +8002,14 @@
       </p:sp>
       <p:sp>
         <p:nvSpPr>
-          <p:cNvPr id="9" name="Rounded Rectangle 8"/>
+          <p:cNvPr id="10" name="Rounded Rectangle 9"/>
           <p:cNvSpPr/>
           <p:nvPr/>
         </p:nvSpPr>
         <p:spPr>
           <a:xfrm>
-            <a:off x="548640" y="2752344"/>
-            <a:ext cx="2743200" cy="566928"/>
+            <a:off x="548640" y="2944368"/>
+            <a:ext cx="2743200" cy="512064"/>
           </a:xfrm>
           <a:prstGeom prst="roundRect">
             <a:avLst>
@@ -8002,14 +8068,14 @@
       </p:sp>
       <p:sp>
         <p:nvSpPr>
-          <p:cNvPr id="10" name="Rounded Rectangle 9"/>
+          <p:cNvPr id="11" name="Rounded Rectangle 10"/>
           <p:cNvSpPr/>
           <p:nvPr/>
         </p:nvSpPr>
         <p:spPr>
           <a:xfrm>
-            <a:off x="548640" y="3465576"/>
-            <a:ext cx="2743200" cy="566928"/>
+            <a:off x="548640" y="3602735"/>
+            <a:ext cx="2743200" cy="512064"/>
           </a:xfrm>
           <a:prstGeom prst="roundRect">
             <a:avLst>
@@ -8068,14 +8134,14 @@
       </p:sp>
       <p:sp>
         <p:nvSpPr>
-          <p:cNvPr id="11" name="Rounded Rectangle 10"/>
+          <p:cNvPr id="12" name="Rounded Rectangle 11"/>
           <p:cNvSpPr/>
           <p:nvPr/>
         </p:nvSpPr>
         <p:spPr>
           <a:xfrm>
-            <a:off x="548640" y="4178808"/>
-            <a:ext cx="2743200" cy="566928"/>
+            <a:off x="548640" y="4261103"/>
+            <a:ext cx="2743200" cy="512064"/>
           </a:xfrm>
           <a:prstGeom prst="roundRect">
             <a:avLst>
@@ -8134,14 +8200,14 @@
       </p:sp>
       <p:sp>
         <p:nvSpPr>
-          <p:cNvPr id="12" name="Rounded Rectangle 11"/>
+          <p:cNvPr id="13" name="Rounded Rectangle 12"/>
           <p:cNvSpPr/>
           <p:nvPr/>
         </p:nvSpPr>
         <p:spPr>
           <a:xfrm>
-            <a:off x="548640" y="4892040"/>
-            <a:ext cx="2743200" cy="566928"/>
+            <a:off x="548640" y="4919471"/>
+            <a:ext cx="2743200" cy="512064"/>
           </a:xfrm>
           <a:prstGeom prst="roundRect">
             <a:avLst>
@@ -8200,14 +8266,14 @@
       </p:sp>
       <p:sp>
         <p:nvSpPr>
-          <p:cNvPr id="13" name="Rounded Rectangle 12"/>
+          <p:cNvPr id="14" name="Rounded Rectangle 13"/>
           <p:cNvSpPr/>
           <p:nvPr/>
         </p:nvSpPr>
         <p:spPr>
           <a:xfrm>
-            <a:off x="7589520" y="1371600"/>
-            <a:ext cx="4023360" cy="640080"/>
+            <a:off x="7589520" y="1627632"/>
+            <a:ext cx="4023360" cy="566928"/>
           </a:xfrm>
           <a:prstGeom prst="roundRect">
             <a:avLst>
@@ -8266,14 +8332,14 @@
       </p:sp>
       <p:sp>
         <p:nvSpPr>
-          <p:cNvPr id="14" name="Rounded Rectangle 13"/>
+          <p:cNvPr id="15" name="Rounded Rectangle 14"/>
           <p:cNvSpPr/>
           <p:nvPr/>
         </p:nvSpPr>
         <p:spPr>
           <a:xfrm>
-            <a:off x="7589520" y="2240280"/>
-            <a:ext cx="4023360" cy="640080"/>
+            <a:off x="7589520" y="2395728"/>
+            <a:ext cx="4023360" cy="566928"/>
           </a:xfrm>
           <a:prstGeom prst="roundRect">
             <a:avLst>
@@ -8332,14 +8398,14 @@
       </p:sp>
       <p:sp>
         <p:nvSpPr>
-          <p:cNvPr id="15" name="Rounded Rectangle 14"/>
+          <p:cNvPr id="16" name="Rounded Rectangle 15"/>
           <p:cNvSpPr/>
           <p:nvPr/>
         </p:nvSpPr>
         <p:spPr>
           <a:xfrm>
-            <a:off x="7589520" y="3108960"/>
-            <a:ext cx="4023360" cy="640080"/>
+            <a:off x="7589520" y="3163824"/>
+            <a:ext cx="4023360" cy="566928"/>
           </a:xfrm>
           <a:prstGeom prst="roundRect">
             <a:avLst>
@@ -8398,14 +8464,14 @@
       </p:sp>
       <p:sp>
         <p:nvSpPr>
-          <p:cNvPr id="16" name="Rounded Rectangle 15"/>
+          <p:cNvPr id="17" name="Rounded Rectangle 16"/>
           <p:cNvSpPr/>
           <p:nvPr/>
         </p:nvSpPr>
         <p:spPr>
           <a:xfrm>
-            <a:off x="7589520" y="4251960"/>
-            <a:ext cx="4023360" cy="640080"/>
+            <a:off x="7589520" y="4224528"/>
+            <a:ext cx="4023360" cy="566928"/>
           </a:xfrm>
           <a:prstGeom prst="roundRect">
             <a:avLst>
@@ -8464,14 +8530,14 @@
       </p:sp>
       <p:sp>
         <p:nvSpPr>
-          <p:cNvPr id="17" name="Rounded Rectangle 16"/>
+          <p:cNvPr id="18" name="Rounded Rectangle 17"/>
           <p:cNvSpPr/>
           <p:nvPr/>
         </p:nvSpPr>
         <p:spPr>
           <a:xfrm>
-            <a:off x="7589520" y="5120640"/>
-            <a:ext cx="4023360" cy="640080"/>
+            <a:off x="7589520" y="4992624"/>
+            <a:ext cx="4023360" cy="566928"/>
           </a:xfrm>
           <a:prstGeom prst="roundRect">
             <a:avLst>
@@ -8530,50 +8596,14 @@
       </p:sp>
       <p:cxnSp>
         <p:nvCxnSpPr>
-          <p:cNvPr id="18" name="Connector 17"/>
-          <p:cNvCxnSpPr/>
-          <p:nvPr/>
-        </p:nvCxnSpPr>
-        <p:spPr>
-          <a:xfrm>
-            <a:off x="3291840" y="1609344"/>
-            <a:ext cx="4297680" cy="82296"/>
-          </a:xfrm>
-          <a:prstGeom prst="line">
-            <a:avLst/>
-          </a:prstGeom>
-          <a:ln w="22225">
-            <a:solidFill>
-              <a:srgbClr val="2563EB"/>
-            </a:solidFill>
-            <a:tailEnd type="triangle" w="med" len="med"/>
-          </a:ln>
-        </p:spPr>
-        <p:style>
-          <a:lnRef idx="2">
-            <a:schemeClr val="accent1"/>
-          </a:lnRef>
-          <a:fillRef idx="0">
-            <a:schemeClr val="accent1"/>
-          </a:fillRef>
-          <a:effectRef idx="1">
-            <a:schemeClr val="accent1"/>
-          </a:effectRef>
-          <a:fontRef idx="minor">
-            <a:schemeClr val="tx1"/>
-          </a:fontRef>
-        </p:style>
-      </p:cxnSp>
-      <p:cxnSp>
-        <p:nvCxnSpPr>
           <p:cNvPr id="19" name="Connector 18"/>
           <p:cNvCxnSpPr/>
           <p:nvPr/>
         </p:nvCxnSpPr>
         <p:spPr>
           <a:xfrm>
-            <a:off x="3291840" y="2322576"/>
-            <a:ext cx="4297680" cy="237744"/>
+            <a:off x="3291840" y="1883664"/>
+            <a:ext cx="4297680" cy="27431"/>
           </a:xfrm>
           <a:prstGeom prst="line">
             <a:avLst/>
@@ -8608,8 +8638,8 @@
         </p:nvCxnSpPr>
         <p:spPr>
           <a:xfrm>
-            <a:off x="3291840" y="3035808"/>
-            <a:ext cx="4297680" cy="393192"/>
+            <a:off x="3291840" y="2542032"/>
+            <a:ext cx="4297680" cy="137160"/>
           </a:xfrm>
           <a:prstGeom prst="line">
             <a:avLst/>
@@ -8643,19 +8673,18 @@
           <p:nvPr/>
         </p:nvCxnSpPr>
         <p:spPr>
-          <a:xfrm flipV="1">
-            <a:off x="3291840" y="3429000"/>
-            <a:ext cx="4297680" cy="320039"/>
+          <a:xfrm>
+            <a:off x="3291840" y="3200400"/>
+            <a:ext cx="4297680" cy="246888"/>
           </a:xfrm>
           <a:prstGeom prst="line">
             <a:avLst/>
           </a:prstGeom>
           <a:ln w="22225">
             <a:solidFill>
-              <a:srgbClr val="6B7280"/>
+              <a:srgbClr val="2563EB"/>
             </a:solidFill>
             <a:tailEnd type="triangle" w="med" len="med"/>
-            <a:prstDash val="dash"/>
           </a:ln>
         </p:spPr>
         <p:style>
@@ -8680,18 +8709,19 @@
           <p:nvPr/>
         </p:nvCxnSpPr>
         <p:spPr>
-          <a:xfrm>
-            <a:off x="3291840" y="4462272"/>
-            <a:ext cx="4297680" cy="109728"/>
+          <a:xfrm flipV="1">
+            <a:off x="3291840" y="3447288"/>
+            <a:ext cx="4297680" cy="411480"/>
           </a:xfrm>
           <a:prstGeom prst="line">
             <a:avLst/>
           </a:prstGeom>
           <a:ln w="22225">
             <a:solidFill>
-              <a:srgbClr val="EA580C"/>
+              <a:srgbClr val="6B7280"/>
             </a:solidFill>
             <a:tailEnd type="triangle" w="med" len="med"/>
+            <a:prstDash val="dash"/>
           </a:ln>
         </p:spPr>
         <p:style>
@@ -8716,9 +8746,9 @@
           <p:nvPr/>
         </p:nvCxnSpPr>
         <p:spPr>
-          <a:xfrm>
-            <a:off x="3291840" y="5175504"/>
-            <a:ext cx="4297680" cy="265176"/>
+          <a:xfrm flipV="1">
+            <a:off x="3291840" y="4507992"/>
+            <a:ext cx="4297680" cy="9144"/>
           </a:xfrm>
           <a:prstGeom prst="line">
             <a:avLst/>
@@ -8745,15 +8775,51 @@
           </a:fontRef>
         </p:style>
       </p:cxnSp>
-      <p:sp>
-        <p:nvSpPr>
-          <p:cNvPr id="24" name="TextBox 23"/>
+      <p:cxnSp>
+        <p:nvCxnSpPr>
+          <p:cNvPr id="24" name="Connector 23"/>
+          <p:cNvCxnSpPr/>
+          <p:nvPr/>
+        </p:nvCxnSpPr>
+        <p:spPr>
+          <a:xfrm>
+            <a:off x="3291840" y="5175503"/>
+            <a:ext cx="4297680" cy="100585"/>
+          </a:xfrm>
+          <a:prstGeom prst="line">
+            <a:avLst/>
+          </a:prstGeom>
+          <a:ln w="22225">
+            <a:solidFill>
+              <a:srgbClr val="EA580C"/>
+            </a:solidFill>
+            <a:tailEnd type="triangle" w="med" len="med"/>
+          </a:ln>
+        </p:spPr>
+        <p:style>
+          <a:lnRef idx="2">
+            <a:schemeClr val="accent1"/>
+          </a:lnRef>
+          <a:fillRef idx="0">
+            <a:schemeClr val="accent1"/>
+          </a:fillRef>
+          <a:effectRef idx="1">
+            <a:schemeClr val="accent1"/>
+          </a:effectRef>
+          <a:fontRef idx="minor">
+            <a:schemeClr val="tx1"/>
+          </a:fontRef>
+        </p:style>
+      </p:cxnSp>
+      <p:sp>
+        <p:nvSpPr>
+          <p:cNvPr id="25" name="TextBox 24"/>
           <p:cNvSpPr txBox="1"/>
           <p:nvPr/>
         </p:nvSpPr>
         <p:spPr>
           <a:xfrm>
-            <a:off x="3657600" y="3611880"/>
+            <a:off x="3611880" y="3703320"/>
             <a:ext cx="3840480" cy="457200"/>
           </a:xfrm>
           <a:prstGeom prst="rect">
@@ -8812,13 +8878,13 @@
       </p:sp>
       <p:sp>
         <p:nvSpPr>
-          <p:cNvPr id="25" name="Rounded Rectangle 24"/>
+          <p:cNvPr id="26" name="Rounded Rectangle 25"/>
           <p:cNvSpPr/>
           <p:nvPr/>
         </p:nvSpPr>
         <p:spPr>
           <a:xfrm>
-            <a:off x="548640" y="5989320"/>
+            <a:off x="548640" y="5897880"/>
             <a:ext cx="11091672" cy="548640"/>
           </a:xfrm>
           <a:prstGeom prst="roundRect">
@@ -8878,7 +8944,7 @@
       </p:sp>
       <p:sp>
         <p:nvSpPr>
-          <p:cNvPr id="26" name="TextBox 25"/>
+          <p:cNvPr id="27" name="TextBox 26"/>
           <p:cNvSpPr txBox="1"/>
           <p:nvPr/>
         </p:nvSpPr>
@@ -8915,7 +8981,7 @@
                 <a:ea typeface="Microsoft YaHei"/>
                 <a:cs typeface="Microsoft YaHei"/>
               </a:rPr>
-              <a:t>Team Skill Hub · Draft v2.0 · 2026-05</a:t>
+              <a:t>Team Skill Hub · Draft v2.1 · 2026-05</a:t>
             </a:r>
           </a:p>
         </p:txBody>
@@ -10113,7 +10179,7 @@
                 <a:ea typeface="Microsoft YaHei"/>
                 <a:cs typeface="Microsoft YaHei"/>
               </a:rPr>
-              <a:t>Team Skill Hub · Draft v2.0 · 2026-05</a:t>
+              <a:t>Team Skill Hub · Draft v2.1 · 2026-05</a:t>
             </a:r>
           </a:p>
         </p:txBody>

</xml_diff>

<commit_message>
docs(slides): expand hub tree on layout slide with concrete examples
Slide 6 (完整工程目录 Layout) now expands hm-skill-hub/ with 1-2 concrete
examples under each area so it reads more concretely:
- skills/core: optimization-funnel, stage-gate-enforcement (+ a skill-folder
  anatomy line: SKILL.md/best_skill.md/evals/candidates/scorecards)
- skills/technique: hoist-loop-invariant, batch-coalescing
- skills/domain: mm-reclaim, hyperhold-io
- knowledge/global: lessons/ (G012_*), anti_patterns/ (A007_*)
- evidence: benchmarks/ (example .json), regressions/ (R031_*)
- eval: task_suites/ (mm_reclaim_suite), scorecards/ (example .md)

Re-laid out the slide: tall full-height hub tree on the left; .opencode/
tree + archetype-routing note + three rationale cards stacked on the right.
Verified all shapes in-bounds and the tree fits inside its card.

https://claude.ai/code/session_01SfNMKzdmMz69A2VBTPNR92
</commit_message>
<xml_diff>
--- a/docs/Team_Skill_Hub_Design_Slides.pptx
+++ b/docs/Team_Skill_Hub_Design_Slides.pptx
@@ -9277,8 +9277,8 @@
         </p:nvSpPr>
         <p:spPr>
           <a:xfrm>
-            <a:off x="411480" y="1115568"/>
-            <a:ext cx="6446520" cy="3584448"/>
+            <a:off x="411480" y="1078992"/>
+            <a:ext cx="6903720" cy="5257800"/>
           </a:xfrm>
           <a:prstGeom prst="roundRect">
             <a:avLst>
@@ -9325,8 +9325,8 @@
         </p:nvSpPr>
         <p:spPr>
           <a:xfrm>
-            <a:off x="566928" y="1188720"/>
-            <a:ext cx="6217920" cy="310896"/>
+            <a:off x="566928" y="1152144"/>
+            <a:ext cx="6675120" cy="292608"/>
           </a:xfrm>
           <a:prstGeom prst="rect">
             <a:avLst/>
@@ -9356,7 +9356,7 @@
                 <a:ea typeface="Microsoft YaHei"/>
                 <a:cs typeface="Microsoft YaHei"/>
               </a:rPr>
-              <a:t>① 中央资产仓 hm-skill-hub/ — 团队共享 · 版本化（只读消费）</a:t>
+              <a:t>① 中央资产仓 hm-skill-hub/ — 团队共享 · 版本化（举例展开）</a:t>
             </a:r>
           </a:p>
         </p:txBody>
@@ -9369,8 +9369,8 @@
         </p:nvSpPr>
         <p:spPr>
           <a:xfrm>
-            <a:off x="457200" y="1536192"/>
-            <a:ext cx="6400800" cy="3127248"/>
+            <a:off x="457200" y="1444752"/>
+            <a:ext cx="6858000" cy="4864608"/>
           </a:xfrm>
           <a:prstGeom prst="rect">
             <a:avLst/>
@@ -9388,11 +9388,11 @@
                 <a:spcPts val="0"/>
               </a:spcBef>
               <a:spcAft>
-                <a:spcPts val="150"/>
-              </a:spcAft>
-            </a:pPr>
-            <a:r>
-              <a:rPr sz="880" b="0">
+                <a:spcPts val="140"/>
+              </a:spcAft>
+            </a:pPr>
+            <a:r>
+              <a:rPr sz="850" b="0">
                 <a:solidFill>
                   <a:srgbClr val="1F2937"/>
                 </a:solidFill>
@@ -9400,10 +9400,10 @@
                 <a:ea typeface="Consolas"/>
                 <a:cs typeface="Consolas"/>
               </a:rPr>
-              <a:t>hm-skill-hub/                       </a:t>
-            </a:r>
-            <a:r>
-              <a:rPr sz="840" b="0">
+              <a:t>hm-skill-hub/                           </a:t>
+            </a:r>
+            <a:r>
+              <a:rPr sz="810" b="0">
                 <a:solidFill>
                   <a:srgbClr val="6B7280"/>
                 </a:solidFill>
@@ -9411,7 +9411,7 @@
                 <a:ea typeface="Microsoft YaHei"/>
                 <a:cs typeface="Microsoft YaHei"/>
               </a:rPr>
-              <a:t># 团队共享 · 语义化版本(semver)</a:t>
+              <a:t># 团队共享 · 版本化(semver)</a:t>
             </a:r>
           </a:p>
           <a:p>
@@ -9420,11 +9420,11 @@
                 <a:spcPts val="0"/>
               </a:spcBef>
               <a:spcAft>
-                <a:spcPts val="150"/>
-              </a:spcAft>
-            </a:pPr>
-            <a:r>
-              <a:rPr sz="880" b="0">
+                <a:spcPts val="140"/>
+              </a:spcAft>
+            </a:pPr>
+            <a:r>
+              <a:rPr sz="850" b="0">
                 <a:solidFill>
                   <a:srgbClr val="1F2937"/>
                 </a:solidFill>
@@ -9432,10 +9432,10 @@
                 <a:ea typeface="Consolas"/>
                 <a:cs typeface="Consolas"/>
               </a:rPr>
-              <a:t>├─ registry.yaml                    </a:t>
-            </a:r>
-            <a:r>
-              <a:rPr sz="840" b="0">
+              <a:t>├─ registry.yaml                        </a:t>
+            </a:r>
+            <a:r>
+              <a:rPr sz="810" b="0">
                 <a:solidFill>
                   <a:srgbClr val="6B7280"/>
                 </a:solidFill>
@@ -9443,7 +9443,7 @@
                 <a:ea typeface="Microsoft YaHei"/>
                 <a:cs typeface="Microsoft YaHei"/>
               </a:rPr>
-              <a:t># 总清单:技能/版本/评测状态/负责人</a:t>
+              <a:t># 总清单:技能/版本/评测/负责人</a:t>
             </a:r>
           </a:p>
           <a:p>
@@ -9452,11 +9452,11 @@
                 <a:spcPts val="0"/>
               </a:spcBef>
               <a:spcAft>
-                <a:spcPts val="150"/>
-              </a:spcAft>
-            </a:pPr>
-            <a:r>
-              <a:rPr sz="880" b="0">
+                <a:spcPts val="140"/>
+              </a:spcAft>
+            </a:pPr>
+            <a:r>
+              <a:rPr sz="850" b="0">
                 <a:solidFill>
                   <a:srgbClr val="1F2937"/>
                 </a:solidFill>
@@ -9464,10 +9464,10 @@
                 <a:ea typeface="Consolas"/>
                 <a:cs typeface="Consolas"/>
               </a:rPr>
-              <a:t>├─ schemas/                         </a:t>
-            </a:r>
-            <a:r>
-              <a:rPr sz="840" b="0">
+              <a:t>├─ schemas/                             </a:t>
+            </a:r>
+            <a:r>
+              <a:rPr sz="810" b="0">
                 <a:solidFill>
                   <a:srgbClr val="6B7280"/>
                 </a:solidFill>
@@ -9475,7 +9475,7 @@
                 <a:ea typeface="Microsoft YaHei"/>
                 <a:cs typeface="Microsoft YaHei"/>
               </a:rPr>
-              <a:t># 各类记录的格式约束(校验关卡用)</a:t>
+              <a:t># 各类记录的格式约束(校验用)</a:t>
             </a:r>
           </a:p>
           <a:p>
@@ -9484,11 +9484,11 @@
                 <a:spcPts val="0"/>
               </a:spcBef>
               <a:spcAft>
-                <a:spcPts val="150"/>
-              </a:spcAft>
-            </a:pPr>
-            <a:r>
-              <a:rPr sz="880" b="0">
+                <a:spcPts val="140"/>
+              </a:spcAft>
+            </a:pPr>
+            <a:r>
+              <a:rPr sz="850" b="0">
                 <a:solidFill>
                   <a:srgbClr val="1F2937"/>
                 </a:solidFill>
@@ -9496,10 +9496,10 @@
                 <a:ea typeface="Consolas"/>
                 <a:cs typeface="Consolas"/>
               </a:rPr>
-              <a:t>├─ skills/                          </a:t>
-            </a:r>
-            <a:r>
-              <a:rPr sz="840" b="0">
+              <a:t>├─ skills/                              </a:t>
+            </a:r>
+            <a:r>
+              <a:rPr sz="810" b="0">
                 <a:solidFill>
                   <a:srgbClr val="6B7280"/>
                 </a:solidFill>
@@ -9507,7 +9507,7 @@
                 <a:ea typeface="Microsoft YaHei"/>
                 <a:cs typeface="Microsoft YaHei"/>
               </a:rPr>
-              <a:t># 技能(引擎B)·内部布局见上一页</a:t>
+              <a:t># 技能(引擎B) · 三层结构见上一页</a:t>
             </a:r>
           </a:p>
           <a:p>
@@ -9516,11 +9516,11 @@
                 <a:spcPts val="0"/>
               </a:spcBef>
               <a:spcAft>
-                <a:spcPts val="150"/>
-              </a:spcAft>
-            </a:pPr>
-            <a:r>
-              <a:rPr sz="880" b="0">
+                <a:spcPts val="140"/>
+              </a:spcAft>
+            </a:pPr>
+            <a:r>
+              <a:rPr sz="850" b="0">
                 <a:solidFill>
                   <a:srgbClr val="1F2937"/>
                 </a:solidFill>
@@ -9528,10 +9528,10 @@
                 <a:ea typeface="Consolas"/>
                 <a:cs typeface="Consolas"/>
               </a:rPr>
-              <a:t>│   core/ technique/ domain/        </a:t>
-            </a:r>
-            <a:r>
-              <a:rPr sz="840" b="0">
+              <a:t>│  ├─ core/                             </a:t>
+            </a:r>
+            <a:r>
+              <a:rPr sz="810" b="0">
                 <a:solidFill>
                   <a:srgbClr val="6B7280"/>
                 </a:solidFill>
@@ -9539,7 +9539,7 @@
                 <a:ea typeface="Microsoft YaHei"/>
                 <a:cs typeface="Microsoft YaHei"/>
               </a:rPr>
-              <a:t># 三个真正的技能层 + _registry/</a:t>
+              <a:t># 流程·跨切面(全子系统通用)</a:t>
             </a:r>
           </a:p>
           <a:p>
@@ -9548,11 +9548,11 @@
                 <a:spcPts val="0"/>
               </a:spcBef>
               <a:spcAft>
-                <a:spcPts val="150"/>
-              </a:spcAft>
-            </a:pPr>
-            <a:r>
-              <a:rPr sz="880" b="0">
+                <a:spcPts val="140"/>
+              </a:spcAft>
+            </a:pPr>
+            <a:r>
+              <a:rPr sz="850" b="0">
                 <a:solidFill>
                   <a:srgbClr val="1F2937"/>
                 </a:solidFill>
@@ -9560,10 +9560,10 @@
                 <a:ea typeface="Consolas"/>
                 <a:cs typeface="Consolas"/>
               </a:rPr>
-              <a:t>├─ knowledge/                       </a:t>
-            </a:r>
-            <a:r>
-              <a:rPr sz="840" b="0">
+              <a:t>│  │  ├─ optimization-funnel/           </a:t>
+            </a:r>
+            <a:r>
+              <a:rPr sz="810" b="0">
                 <a:solidFill>
                   <a:srgbClr val="6B7280"/>
                 </a:solidFill>
@@ -9571,7 +9571,7 @@
                 <a:ea typeface="Microsoft YaHei"/>
                 <a:cs typeface="Microsoft YaHei"/>
               </a:rPr>
-              <a:t># 知识(引擎A·分层·每条一文件)</a:t>
+              <a:t># 例:优化漏斗主流程</a:t>
             </a:r>
           </a:p>
           <a:p>
@@ -9580,11 +9580,11 @@
                 <a:spcPts val="0"/>
               </a:spcBef>
               <a:spcAft>
-                <a:spcPts val="150"/>
-              </a:spcAft>
-            </a:pPr>
-            <a:r>
-              <a:rPr sz="880" b="0">
+                <a:spcPts val="140"/>
+              </a:spcAft>
+            </a:pPr>
+            <a:r>
+              <a:rPr sz="850" b="0">
                 <a:solidFill>
                   <a:srgbClr val="1F2937"/>
                 </a:solidFill>
@@ -9592,7 +9592,7 @@
                 <a:ea typeface="Consolas"/>
                 <a:cs typeface="Consolas"/>
               </a:rPr>
-              <a:t>│   global/{lessons,anti_patterns}/</a:t>
+              <a:t>│  │  │    SKILL.md · best_skill.md · evals/ · candidates/ · scorecards/</a:t>
             </a:r>
           </a:p>
           <a:p>
@@ -9601,11 +9601,11 @@
                 <a:spcPts val="0"/>
               </a:spcBef>
               <a:spcAft>
-                <a:spcPts val="150"/>
-              </a:spcAft>
-            </a:pPr>
-            <a:r>
-              <a:rPr sz="880" b="0">
+                <a:spcPts val="140"/>
+              </a:spcAft>
+            </a:pPr>
+            <a:r>
+              <a:rPr sz="850" b="0">
                 <a:solidFill>
                   <a:srgbClr val="1F2937"/>
                 </a:solidFill>
@@ -9613,7 +9613,18 @@
                 <a:ea typeface="Consolas"/>
                 <a:cs typeface="Consolas"/>
               </a:rPr>
-              <a:t>│   subsystems/&lt;s&gt;.md</a:t>
+              <a:t>│  │  └─ stage-gate-enforcement/        </a:t>
+            </a:r>
+            <a:r>
+              <a:rPr sz="810" b="0">
+                <a:solidFill>
+                  <a:srgbClr val="6B7280"/>
+                </a:solidFill>
+                <a:latin typeface="Microsoft YaHei"/>
+                <a:ea typeface="Microsoft YaHei"/>
+                <a:cs typeface="Microsoft YaHei"/>
+              </a:rPr>
+              <a:t># 例:阶段门禁强制</a:t>
             </a:r>
           </a:p>
           <a:p>
@@ -9622,11 +9633,11 @@
                 <a:spcPts val="0"/>
               </a:spcBef>
               <a:spcAft>
-                <a:spcPts val="150"/>
-              </a:spcAft>
-            </a:pPr>
-            <a:r>
-              <a:rPr sz="880" b="0">
+                <a:spcPts val="140"/>
+              </a:spcAft>
+            </a:pPr>
+            <a:r>
+              <a:rPr sz="850" b="0">
                 <a:solidFill>
                   <a:srgbClr val="1F2937"/>
                 </a:solidFill>
@@ -9634,7 +9645,18 @@
                 <a:ea typeface="Consolas"/>
                 <a:cs typeface="Consolas"/>
               </a:rPr>
-              <a:t>│   targets/&lt;slug&gt;/{facts,decisions,idea_ledger}</a:t>
+              <a:t>│  ├─ technique/                        </a:t>
+            </a:r>
+            <a:r>
+              <a:rPr sz="810" b="0">
+                <a:solidFill>
+                  <a:srgbClr val="6B7280"/>
+                </a:solidFill>
+                <a:latin typeface="Microsoft YaHei"/>
+                <a:ea typeface="Microsoft YaHei"/>
+                <a:cs typeface="Microsoft YaHei"/>
+              </a:rPr>
+              <a:t># 优化招式 · 按 mechanism 命名</a:t>
             </a:r>
           </a:p>
           <a:p>
@@ -9643,11 +9665,11 @@
                 <a:spcPts val="0"/>
               </a:spcBef>
               <a:spcAft>
-                <a:spcPts val="150"/>
-              </a:spcAft>
-            </a:pPr>
-            <a:r>
-              <a:rPr sz="880" b="0">
+                <a:spcPts val="140"/>
+              </a:spcAft>
+            </a:pPr>
+            <a:r>
+              <a:rPr sz="850" b="0">
                 <a:solidFill>
                   <a:srgbClr val="1F2937"/>
                 </a:solidFill>
@@ -9655,10 +9677,10 @@
                 <a:ea typeface="Consolas"/>
                 <a:cs typeface="Consolas"/>
               </a:rPr>
-              <a:t>│   index/                          </a:t>
-            </a:r>
-            <a:r>
-              <a:rPr sz="840" b="0">
+              <a:t>│  │  ├─ hoist-loop-invariant/          </a:t>
+            </a:r>
+            <a:r>
+              <a:rPr sz="810" b="0">
                 <a:solidFill>
                   <a:srgbClr val="6B7280"/>
                 </a:solidFill>
@@ -9666,7 +9688,7 @@
                 <a:ea typeface="Microsoft YaHei"/>
                 <a:cs typeface="Microsoft YaHei"/>
               </a:rPr>
-              <a:t># 向量检索索引</a:t>
+              <a:t># 例:循环不变量外提</a:t>
             </a:r>
           </a:p>
           <a:p>
@@ -9675,11 +9697,11 @@
                 <a:spcPts val="0"/>
               </a:spcBef>
               <a:spcAft>
-                <a:spcPts val="150"/>
-              </a:spcAft>
-            </a:pPr>
-            <a:r>
-              <a:rPr sz="880" b="0">
+                <a:spcPts val="140"/>
+              </a:spcAft>
+            </a:pPr>
+            <a:r>
+              <a:rPr sz="850" b="0">
                 <a:solidFill>
                   <a:srgbClr val="1F2937"/>
                 </a:solidFill>
@@ -9687,10 +9709,10 @@
                 <a:ea typeface="Consolas"/>
                 <a:cs typeface="Consolas"/>
               </a:rPr>
-              <a:t>├─ evidence/{benchmarks,regressions}/</a:t>
-            </a:r>
-            <a:r>
-              <a:rPr sz="840" b="0">
+              <a:t>│  │  └─ batch-coalescing/              </a:t>
+            </a:r>
+            <a:r>
+              <a:rPr sz="810" b="0">
                 <a:solidFill>
                   <a:srgbClr val="6B7280"/>
                 </a:solidFill>
@@ -9698,7 +9720,7 @@
                 <a:ea typeface="Microsoft YaHei"/>
                 <a:cs typeface="Microsoft YaHei"/>
               </a:rPr>
-              <a:t># 可复核的证据</a:t>
+              <a:t># 例:批量合并写</a:t>
             </a:r>
           </a:p>
           <a:p>
@@ -9707,11 +9729,11 @@
                 <a:spcPts val="0"/>
               </a:spcBef>
               <a:spcAft>
-                <a:spcPts val="150"/>
-              </a:spcAft>
-            </a:pPr>
-            <a:r>
-              <a:rPr sz="880" b="0">
+                <a:spcPts val="140"/>
+              </a:spcAft>
+            </a:pPr>
+            <a:r>
+              <a:rPr sz="850" b="0">
                 <a:solidFill>
                   <a:srgbClr val="1F2937"/>
                 </a:solidFill>
@@ -9719,10 +9741,10 @@
                 <a:ea typeface="Consolas"/>
                 <a:cs typeface="Consolas"/>
               </a:rPr>
-              <a:t>├─ eval/{task_suites,scorecards}/   </a:t>
-            </a:r>
-            <a:r>
-              <a:rPr sz="840" b="0">
+              <a:t>│  ├─ domain/                           </a:t>
+            </a:r>
+            <a:r>
+              <a:rPr sz="810" b="0">
                 <a:solidFill>
                   <a:srgbClr val="6B7280"/>
                 </a:solidFill>
@@ -9730,7 +9752,7 @@
                 <a:ea typeface="Microsoft YaHei"/>
                 <a:cs typeface="Microsoft YaHei"/>
               </a:rPr>
-              <a:t># 评测套件 + 评分卡</a:t>
+              <a:t># 按子系统(唯一触及代码结构)</a:t>
             </a:r>
           </a:p>
           <a:p>
@@ -9739,11 +9761,11 @@
                 <a:spcPts val="0"/>
               </a:spcBef>
               <a:spcAft>
-                <a:spcPts val="150"/>
-              </a:spcAft>
-            </a:pPr>
-            <a:r>
-              <a:rPr sz="880" b="0">
+                <a:spcPts val="140"/>
+              </a:spcAft>
+            </a:pPr>
+            <a:r>
+              <a:rPr sz="850" b="0">
                 <a:solidFill>
                   <a:srgbClr val="1F2937"/>
                 </a:solidFill>
@@ -9751,10 +9773,10 @@
                 <a:ea typeface="Consolas"/>
                 <a:cs typeface="Consolas"/>
               </a:rPr>
-              <a:t>├─ policies/*.md                    </a:t>
-            </a:r>
-            <a:r>
-              <a:rPr sz="840" b="0">
+              <a:t>│  │  ├─ mm-reclaim/                    </a:t>
+            </a:r>
+            <a:r>
+              <a:rPr sz="810" b="0">
                 <a:solidFill>
                   <a:srgbClr val="6B7280"/>
                 </a:solidFill>
@@ -9762,7 +9784,7 @@
                 <a:ea typeface="Microsoft YaHei"/>
                 <a:cs typeface="Microsoft YaHei"/>
               </a:rPr>
-              <a:t># promotion/merge/deprecation 规则</a:t>
+              <a:t># 例:内存回收(含 references/)</a:t>
             </a:r>
           </a:p>
           <a:p>
@@ -9771,11 +9793,11 @@
                 <a:spcPts val="0"/>
               </a:spcBef>
               <a:spcAft>
-                <a:spcPts val="150"/>
-              </a:spcAft>
-            </a:pPr>
-            <a:r>
-              <a:rPr sz="880" b="0">
+                <a:spcPts val="140"/>
+              </a:spcAft>
+            </a:pPr>
+            <a:r>
+              <a:rPr sz="850" b="0">
                 <a:solidFill>
                   <a:srgbClr val="1F2937"/>
                 </a:solidFill>
@@ -9783,10 +9805,10 @@
                 <a:ea typeface="Consolas"/>
                 <a:cs typeface="Consolas"/>
               </a:rPr>
-              <a:t>├─ staging/&lt;member&gt;/&lt;date&gt;/*.json   </a:t>
-            </a:r>
-            <a:r>
-              <a:rPr sz="840" b="0">
+              <a:t>│  │  └─ hyperhold-io/                  </a:t>
+            </a:r>
+            <a:r>
+              <a:rPr sz="810" b="0">
                 <a:solidFill>
                   <a:srgbClr val="6B7280"/>
                 </a:solidFill>
@@ -9794,7 +9816,7 @@
                 <a:ea typeface="Microsoft YaHei"/>
                 <a:cs typeface="Microsoft YaHei"/>
               </a:rPr>
-              <a:t># 入站候选(Tier1)</a:t>
+              <a:t># 例:hyperhold I/O 路径</a:t>
             </a:r>
           </a:p>
           <a:p>
@@ -9803,11 +9825,11 @@
                 <a:spcPts val="0"/>
               </a:spcBef>
               <a:spcAft>
-                <a:spcPts val="150"/>
-              </a:spcAft>
-            </a:pPr>
-            <a:r>
-              <a:rPr sz="880" b="0">
+                <a:spcPts val="140"/>
+              </a:spcAft>
+            </a:pPr>
+            <a:r>
+              <a:rPr sz="850" b="0">
                 <a:solidFill>
                   <a:srgbClr val="1F2937"/>
                 </a:solidFill>
@@ -9815,10 +9837,10 @@
                 <a:ea typeface="Consolas"/>
                 <a:cs typeface="Consolas"/>
               </a:rPr>
-              <a:t>├─ tools/*.py                       </a:t>
-            </a:r>
-            <a:r>
-              <a:rPr sz="840" b="0">
+              <a:t>│  └─ _registry/skills.yaml             </a:t>
+            </a:r>
+            <a:r>
+              <a:rPr sz="810" b="0">
                 <a:solidFill>
                   <a:srgbClr val="6B7280"/>
                 </a:solidFill>
@@ -9826,7 +9848,7 @@
                 <a:ea typeface="Microsoft YaHei"/>
                 <a:cs typeface="Microsoft YaHei"/>
               </a:rPr>
-              <a:t># sediment/run_evals/lint/dedup...</a:t>
+              <a:t># 全量索引 + 子系统选择器</a:t>
             </a:r>
           </a:p>
           <a:p>
@@ -9835,11 +9857,11 @@
                 <a:spcPts val="0"/>
               </a:spcBef>
               <a:spcAft>
-                <a:spcPts val="150"/>
-              </a:spcAft>
-            </a:pPr>
-            <a:r>
-              <a:rPr sz="880" b="0">
+                <a:spcPts val="140"/>
+              </a:spcAft>
+            </a:pPr>
+            <a:r>
+              <a:rPr sz="850" b="0">
                 <a:solidFill>
                   <a:srgbClr val="1F2937"/>
                 </a:solidFill>
@@ -9847,10 +9869,10 @@
                 <a:ea typeface="Consolas"/>
                 <a:cs typeface="Consolas"/>
               </a:rPr>
-              <a:t>└─ .github/workflows/ci.yml         </a:t>
-            </a:r>
-            <a:r>
-              <a:rPr sz="840" b="0">
+              <a:t>├─ knowledge/                           </a:t>
+            </a:r>
+            <a:r>
+              <a:rPr sz="810" b="0">
                 <a:solidFill>
                   <a:srgbClr val="6B7280"/>
                 </a:solidFill>
@@ -9858,7 +9880,380 @@
                 <a:ea typeface="Microsoft YaHei"/>
                 <a:cs typeface="Microsoft YaHei"/>
               </a:rPr>
-              <a:t># 校验+去敏+评测闸门+建索引</a:t>
+              <a:t># 知识(引擎A·分层·每条一文件)</a:t>
+            </a:r>
+          </a:p>
+          <a:p>
+            <a:pPr algn="l">
+              <a:spcBef>
+                <a:spcPts val="0"/>
+              </a:spcBef>
+              <a:spcAft>
+                <a:spcPts val="140"/>
+              </a:spcAft>
+            </a:pPr>
+            <a:r>
+              <a:rPr sz="850" b="0">
+                <a:solidFill>
+                  <a:srgbClr val="1F2937"/>
+                </a:solidFill>
+                <a:latin typeface="Consolas"/>
+                <a:ea typeface="Consolas"/>
+                <a:cs typeface="Consolas"/>
+              </a:rPr>
+              <a:t>│  ├─ global/                           </a:t>
+            </a:r>
+            <a:r>
+              <a:rPr sz="810" b="0">
+                <a:solidFill>
+                  <a:srgbClr val="6B7280"/>
+                </a:solidFill>
+                <a:latin typeface="Microsoft YaHei"/>
+                <a:ea typeface="Microsoft YaHei"/>
+                <a:cs typeface="Microsoft YaHei"/>
+              </a:rPr>
+              <a:t># 全局教训 / 反模式</a:t>
+            </a:r>
+          </a:p>
+          <a:p>
+            <a:pPr algn="l">
+              <a:spcBef>
+                <a:spcPts val="0"/>
+              </a:spcBef>
+              <a:spcAft>
+                <a:spcPts val="140"/>
+              </a:spcAft>
+            </a:pPr>
+            <a:r>
+              <a:rPr sz="850" b="0">
+                <a:solidFill>
+                  <a:srgbClr val="1F2937"/>
+                </a:solidFill>
+                <a:latin typeface="Consolas"/>
+                <a:ea typeface="Consolas"/>
+                <a:cs typeface="Consolas"/>
+              </a:rPr>
+              <a:t>│  │  ├─ lessons/                       </a:t>
+            </a:r>
+            <a:r>
+              <a:rPr sz="810" b="0">
+                <a:solidFill>
+                  <a:srgbClr val="6B7280"/>
+                </a:solidFill>
+                <a:latin typeface="Microsoft YaHei"/>
+                <a:ea typeface="Microsoft YaHei"/>
+                <a:cs typeface="Microsoft YaHei"/>
+              </a:rPr>
+              <a:t># 例:G012_reclaim-twice.md</a:t>
+            </a:r>
+          </a:p>
+          <a:p>
+            <a:pPr algn="l">
+              <a:spcBef>
+                <a:spcPts val="0"/>
+              </a:spcBef>
+              <a:spcAft>
+                <a:spcPts val="140"/>
+              </a:spcAft>
+            </a:pPr>
+            <a:r>
+              <a:rPr sz="850" b="0">
+                <a:solidFill>
+                  <a:srgbClr val="1F2937"/>
+                </a:solidFill>
+                <a:latin typeface="Consolas"/>
+                <a:ea typeface="Consolas"/>
+                <a:cs typeface="Consolas"/>
+              </a:rPr>
+              <a:t>│  │  └─ anti_patterns/                 </a:t>
+            </a:r>
+            <a:r>
+              <a:rPr sz="810" b="0">
+                <a:solidFill>
+                  <a:srgbClr val="6B7280"/>
+                </a:solidFill>
+                <a:latin typeface="Microsoft YaHei"/>
+                <a:ea typeface="Microsoft YaHei"/>
+                <a:cs typeface="Microsoft YaHei"/>
+              </a:rPr>
+              <a:t># 例:A007_busy-wait.md</a:t>
+            </a:r>
+          </a:p>
+          <a:p>
+            <a:pPr algn="l">
+              <a:spcBef>
+                <a:spcPts val="0"/>
+              </a:spcBef>
+              <a:spcAft>
+                <a:spcPts val="140"/>
+              </a:spcAft>
+            </a:pPr>
+            <a:r>
+              <a:rPr sz="850" b="0">
+                <a:solidFill>
+                  <a:srgbClr val="1F2937"/>
+                </a:solidFill>
+                <a:latin typeface="Consolas"/>
+                <a:ea typeface="Consolas"/>
+                <a:cs typeface="Consolas"/>
+              </a:rPr>
+              <a:t>│  ├─ subsystems/&lt;s&gt;.md  ·  targets/&lt;slug&gt;/{facts,decisions,idea_ledger}</a:t>
+            </a:r>
+          </a:p>
+          <a:p>
+            <a:pPr algn="l">
+              <a:spcBef>
+                <a:spcPts val="0"/>
+              </a:spcBef>
+              <a:spcAft>
+                <a:spcPts val="140"/>
+              </a:spcAft>
+            </a:pPr>
+            <a:r>
+              <a:rPr sz="850" b="0">
+                <a:solidFill>
+                  <a:srgbClr val="1F2937"/>
+                </a:solidFill>
+                <a:latin typeface="Consolas"/>
+                <a:ea typeface="Consolas"/>
+                <a:cs typeface="Consolas"/>
+              </a:rPr>
+              <a:t>│  └─ index/                            </a:t>
+            </a:r>
+            <a:r>
+              <a:rPr sz="810" b="0">
+                <a:solidFill>
+                  <a:srgbClr val="6B7280"/>
+                </a:solidFill>
+                <a:latin typeface="Microsoft YaHei"/>
+                <a:ea typeface="Microsoft YaHei"/>
+                <a:cs typeface="Microsoft YaHei"/>
+              </a:rPr>
+              <a:t># 向量检索索引</a:t>
+            </a:r>
+          </a:p>
+          <a:p>
+            <a:pPr algn="l">
+              <a:spcBef>
+                <a:spcPts val="0"/>
+              </a:spcBef>
+              <a:spcAft>
+                <a:spcPts val="140"/>
+              </a:spcAft>
+            </a:pPr>
+            <a:r>
+              <a:rPr sz="850" b="0">
+                <a:solidFill>
+                  <a:srgbClr val="1F2937"/>
+                </a:solidFill>
+                <a:latin typeface="Consolas"/>
+                <a:ea typeface="Consolas"/>
+                <a:cs typeface="Consolas"/>
+              </a:rPr>
+              <a:t>├─ evidence/                            </a:t>
+            </a:r>
+            <a:r>
+              <a:rPr sz="810" b="0">
+                <a:solidFill>
+                  <a:srgbClr val="6B7280"/>
+                </a:solidFill>
+                <a:latin typeface="Microsoft YaHei"/>
+                <a:ea typeface="Microsoft YaHei"/>
+                <a:cs typeface="Microsoft YaHei"/>
+              </a:rPr>
+              <a:t># 可复核证据(每条回链来源)</a:t>
+            </a:r>
+          </a:p>
+          <a:p>
+            <a:pPr algn="l">
+              <a:spcBef>
+                <a:spcPts val="0"/>
+              </a:spcBef>
+              <a:spcAft>
+                <a:spcPts val="140"/>
+              </a:spcAft>
+            </a:pPr>
+            <a:r>
+              <a:rPr sz="850" b="0">
+                <a:solidFill>
+                  <a:srgbClr val="1F2937"/>
+                </a:solidFill>
+                <a:latin typeface="Consolas"/>
+                <a:ea typeface="Consolas"/>
+                <a:cs typeface="Consolas"/>
+              </a:rPr>
+              <a:t>│  ├─ benchmarks/                       </a:t>
+            </a:r>
+            <a:r>
+              <a:rPr sz="810" b="0">
+                <a:solidFill>
+                  <a:srgbClr val="6B7280"/>
+                </a:solidFill>
+                <a:latin typeface="Microsoft YaHei"/>
+                <a:ea typeface="Microsoft YaHei"/>
+                <a:cs typeface="Microsoft YaHei"/>
+              </a:rPr>
+              <a:t># 例:mm-reclaim_2026Q2.json</a:t>
+            </a:r>
+          </a:p>
+          <a:p>
+            <a:pPr algn="l">
+              <a:spcBef>
+                <a:spcPts val="0"/>
+              </a:spcBef>
+              <a:spcAft>
+                <a:spcPts val="140"/>
+              </a:spcAft>
+            </a:pPr>
+            <a:r>
+              <a:rPr sz="850" b="0">
+                <a:solidFill>
+                  <a:srgbClr val="1F2937"/>
+                </a:solidFill>
+                <a:latin typeface="Consolas"/>
+                <a:ea typeface="Consolas"/>
+                <a:cs typeface="Consolas"/>
+              </a:rPr>
+              <a:t>│  └─ regressions/                      </a:t>
+            </a:r>
+            <a:r>
+              <a:rPr sz="810" b="0">
+                <a:solidFill>
+                  <a:srgbClr val="6B7280"/>
+                </a:solidFill>
+                <a:latin typeface="Microsoft YaHei"/>
+                <a:ea typeface="Microsoft YaHei"/>
+                <a:cs typeface="Microsoft YaHei"/>
+              </a:rPr>
+              <a:t># 例:R031_shrink_node.json</a:t>
+            </a:r>
+          </a:p>
+          <a:p>
+            <a:pPr algn="l">
+              <a:spcBef>
+                <a:spcPts val="0"/>
+              </a:spcBef>
+              <a:spcAft>
+                <a:spcPts val="140"/>
+              </a:spcAft>
+            </a:pPr>
+            <a:r>
+              <a:rPr sz="850" b="0">
+                <a:solidFill>
+                  <a:srgbClr val="1F2937"/>
+                </a:solidFill>
+                <a:latin typeface="Consolas"/>
+                <a:ea typeface="Consolas"/>
+                <a:cs typeface="Consolas"/>
+              </a:rPr>
+              <a:t>├─ eval/                                </a:t>
+            </a:r>
+            <a:r>
+              <a:rPr sz="810" b="0">
+                <a:solidFill>
+                  <a:srgbClr val="6B7280"/>
+                </a:solidFill>
+                <a:latin typeface="Microsoft YaHei"/>
+                <a:ea typeface="Microsoft YaHei"/>
+                <a:cs typeface="Microsoft YaHei"/>
+              </a:rPr>
+              <a:t># 评测资产(引擎B 的发布门)</a:t>
+            </a:r>
+          </a:p>
+          <a:p>
+            <a:pPr algn="l">
+              <a:spcBef>
+                <a:spcPts val="0"/>
+              </a:spcBef>
+              <a:spcAft>
+                <a:spcPts val="140"/>
+              </a:spcAft>
+            </a:pPr>
+            <a:r>
+              <a:rPr sz="850" b="0">
+                <a:solidFill>
+                  <a:srgbClr val="1F2937"/>
+                </a:solidFill>
+                <a:latin typeface="Consolas"/>
+                <a:ea typeface="Consolas"/>
+                <a:cs typeface="Consolas"/>
+              </a:rPr>
+              <a:t>│  ├─ task_suites/                      </a:t>
+            </a:r>
+            <a:r>
+              <a:rPr sz="810" b="0">
+                <a:solidFill>
+                  <a:srgbClr val="6B7280"/>
+                </a:solidFill>
+                <a:latin typeface="Microsoft YaHei"/>
+                <a:ea typeface="Microsoft YaHei"/>
+                <a:cs typeface="Microsoft YaHei"/>
+              </a:rPr>
+              <a:t># 例:mm_reclaim_suite/</a:t>
+            </a:r>
+          </a:p>
+          <a:p>
+            <a:pPr algn="l">
+              <a:spcBef>
+                <a:spcPts val="0"/>
+              </a:spcBef>
+              <a:spcAft>
+                <a:spcPts val="140"/>
+              </a:spcAft>
+            </a:pPr>
+            <a:r>
+              <a:rPr sz="850" b="0">
+                <a:solidFill>
+                  <a:srgbClr val="1F2937"/>
+                </a:solidFill>
+                <a:latin typeface="Consolas"/>
+                <a:ea typeface="Consolas"/>
+                <a:cs typeface="Consolas"/>
+              </a:rPr>
+              <a:t>│  └─ scorecards/                       </a:t>
+            </a:r>
+            <a:r>
+              <a:rPr sz="810" b="0">
+                <a:solidFill>
+                  <a:srgbClr val="6B7280"/>
+                </a:solidFill>
+                <a:latin typeface="Microsoft YaHei"/>
+                <a:ea typeface="Microsoft YaHei"/>
+                <a:cs typeface="Microsoft YaHei"/>
+              </a:rPr>
+              <a:t># 例:funnel_v3_scorecard.md</a:t>
+            </a:r>
+          </a:p>
+          <a:p>
+            <a:pPr algn="l">
+              <a:spcBef>
+                <a:spcPts val="0"/>
+              </a:spcBef>
+              <a:spcAft>
+                <a:spcPts val="140"/>
+              </a:spcAft>
+            </a:pPr>
+            <a:r>
+              <a:rPr sz="850" b="0">
+                <a:solidFill>
+                  <a:srgbClr val="1F2937"/>
+                </a:solidFill>
+                <a:latin typeface="Consolas"/>
+                <a:ea typeface="Consolas"/>
+                <a:cs typeface="Consolas"/>
+              </a:rPr>
+              <a:t>└─ policies/ staging/ tools/ .github/   </a:t>
+            </a:r>
+            <a:r>
+              <a:rPr sz="810" b="0">
+                <a:solidFill>
+                  <a:srgbClr val="6B7280"/>
+                </a:solidFill>
+                <a:latin typeface="Microsoft YaHei"/>
+                <a:ea typeface="Microsoft YaHei"/>
+                <a:cs typeface="Microsoft YaHei"/>
+              </a:rPr>
+              <a:t># 规则·入站候选·脚本·CI 门</a:t>
             </a:r>
           </a:p>
         </p:txBody>
@@ -9871,8 +10266,8 @@
         </p:nvSpPr>
         <p:spPr>
           <a:xfrm>
-            <a:off x="7040880" y="1115568"/>
-            <a:ext cx="4736592" cy="3584448"/>
+            <a:off x="7452360" y="1078992"/>
+            <a:ext cx="4325112" cy="2505456"/>
           </a:xfrm>
           <a:prstGeom prst="roundRect">
             <a:avLst>
@@ -9919,8 +10314,8 @@
         </p:nvSpPr>
         <p:spPr>
           <a:xfrm>
-            <a:off x="7196328" y="1188720"/>
-            <a:ext cx="4480560" cy="310896"/>
+            <a:off x="7589520" y="1152144"/>
+            <a:ext cx="4114800" cy="292608"/>
           </a:xfrm>
           <a:prstGeom prst="rect">
             <a:avLst/>
@@ -9950,7 +10345,7 @@
                 <a:ea typeface="Microsoft YaHei"/>
                 <a:cs typeface="Microsoft YaHei"/>
               </a:rPr>
-              <a:t>② 业务仓 .opencode/ — 每成员执行面（本地叠加 + 在途沉淀）</a:t>
+              <a:t>② 业务仓 .opencode/ — 每成员执行面</a:t>
             </a:r>
           </a:p>
         </p:txBody>
@@ -9963,8 +10358,8 @@
         </p:nvSpPr>
         <p:spPr>
           <a:xfrm>
-            <a:off x="7086600" y="1536192"/>
-            <a:ext cx="4663440" cy="2286000"/>
+            <a:off x="7498079" y="1444752"/>
+            <a:ext cx="4206240" cy="2103120"/>
           </a:xfrm>
           <a:prstGeom prst="rect">
             <a:avLst/>
@@ -9982,11 +10377,11 @@
                 <a:spcPts val="0"/>
               </a:spcBef>
               <a:spcAft>
-                <a:spcPts val="220"/>
-              </a:spcAft>
-            </a:pPr>
-            <a:r>
-              <a:rPr sz="880" b="0">
+                <a:spcPts val="170"/>
+              </a:spcAft>
+            </a:pPr>
+            <a:r>
+              <a:rPr sz="830" b="0">
                 <a:solidFill>
                   <a:srgbClr val="1F2937"/>
                 </a:solidFill>
@@ -9997,7 +10392,7 @@
               <a:t>.opencode/                 </a:t>
             </a:r>
             <a:r>
-              <a:rPr sz="840" b="0">
+              <a:rPr sz="790" b="0">
                 <a:solidFill>
                   <a:srgbClr val="6B7280"/>
                 </a:solidFill>
@@ -10005,7 +10400,7 @@
                 <a:ea typeface="Microsoft YaHei"/>
                 <a:cs typeface="Microsoft YaHei"/>
               </a:rPr>
-              <a:t># 在业务仓 hm-kernel-llm-opt 内</a:t>
+              <a:t># 在业务仓内 · 执行面</a:t>
             </a:r>
           </a:p>
           <a:p>
@@ -10014,11 +10409,11 @@
                 <a:spcPts val="0"/>
               </a:spcBef>
               <a:spcAft>
-                <a:spcPts val="220"/>
-              </a:spcAft>
-            </a:pPr>
-            <a:r>
-              <a:rPr sz="880" b="0">
+                <a:spcPts val="170"/>
+              </a:spcAft>
+            </a:pPr>
+            <a:r>
+              <a:rPr sz="830" b="0">
                 <a:solidFill>
                   <a:srgbClr val="1F2937"/>
                 </a:solidFill>
@@ -10029,7 +10424,7 @@
               <a:t>├─ hub/                    </a:t>
             </a:r>
             <a:r>
-              <a:rPr sz="840" b="0">
+              <a:rPr sz="790" b="0">
                 <a:solidFill>
                   <a:srgbClr val="6B7280"/>
                 </a:solidFill>
@@ -10037,7 +10432,7 @@
                 <a:ea typeface="Microsoft YaHei"/>
                 <a:cs typeface="Microsoft YaHei"/>
               </a:rPr>
-              <a:t># 子模块,锁定 hub 版本(只读)</a:t>
+              <a:t># 子模块·锁定版本(只读)</a:t>
             </a:r>
           </a:p>
           <a:p>
@@ -10046,11 +10441,11 @@
                 <a:spcPts val="0"/>
               </a:spcBef>
               <a:spcAft>
-                <a:spcPts val="220"/>
-              </a:spcAft>
-            </a:pPr>
-            <a:r>
-              <a:rPr sz="880" b="0">
+                <a:spcPts val="170"/>
+              </a:spcAft>
+            </a:pPr>
+            <a:r>
+              <a:rPr sz="830" b="0">
                 <a:solidFill>
                   <a:srgbClr val="1F2937"/>
                 </a:solidFill>
@@ -10061,7 +10456,7 @@
               <a:t>├─ local/                  </a:t>
             </a:r>
             <a:r>
-              <a:rPr sz="840" b="0">
+              <a:rPr sz="790" b="0">
                 <a:solidFill>
                   <a:srgbClr val="6B7280"/>
                 </a:solidFill>
@@ -10069,7 +10464,7 @@
                 <a:ea typeface="Microsoft YaHei"/>
                 <a:cs typeface="Microsoft YaHei"/>
               </a:rPr>
-              <a:t># 本成员执行面产物</a:t>
+              <a:t># 本成员执行产物</a:t>
             </a:r>
           </a:p>
           <a:p>
@@ -10078,11 +10473,11 @@
                 <a:spcPts val="0"/>
               </a:spcBef>
               <a:spcAft>
-                <a:spcPts val="220"/>
-              </a:spcAft>
-            </a:pPr>
-            <a:r>
-              <a:rPr sz="880" b="0">
+                <a:spcPts val="170"/>
+              </a:spcAft>
+            </a:pPr>
+            <a:r>
+              <a:rPr sz="830" b="0">
                 <a:solidFill>
                   <a:srgbClr val="1F2937"/>
                 </a:solidFill>
@@ -10093,7 +10488,7 @@
               <a:t>│   runs/&lt;run_id&gt;/         </a:t>
             </a:r>
             <a:r>
-              <a:rPr sz="840" b="0">
+              <a:rPr sz="790" b="0">
                 <a:solidFill>
                   <a:srgbClr val="6B7280"/>
                 </a:solidFill>
@@ -10101,7 +10496,7 @@
                 <a:ea typeface="Microsoft YaHei"/>
                 <a:cs typeface="Microsoft YaHei"/>
               </a:rPr>
-              <a:t># plans·reviews·bench·patches</a:t>
+              <a:t># plans/reviews/bench…</a:t>
             </a:r>
           </a:p>
           <a:p>
@@ -10110,11 +10505,11 @@
                 <a:spcPts val="0"/>
               </a:spcBef>
               <a:spcAft>
-                <a:spcPts val="220"/>
-              </a:spcAft>
-            </a:pPr>
-            <a:r>
-              <a:rPr sz="880" b="0">
+                <a:spcPts val="170"/>
+              </a:spcAft>
+            </a:pPr>
+            <a:r>
+              <a:rPr sz="830" b="0">
                 <a:solidFill>
                   <a:srgbClr val="1F2937"/>
                 </a:solidFill>
@@ -10125,7 +10520,7 @@
               <a:t>│     &lt;target&gt;_design.md   </a:t>
             </a:r>
             <a:r>
-              <a:rPr sz="840" b="0">
+              <a:rPr sz="790" b="0">
                 <a:solidFill>
                   <a:srgbClr val="6B7280"/>
                 </a:solidFill>
@@ -10142,11 +10537,11 @@
                 <a:spcPts val="0"/>
               </a:spcBef>
               <a:spcAft>
-                <a:spcPts val="220"/>
-              </a:spcAft>
-            </a:pPr>
-            <a:r>
-              <a:rPr sz="880" b="0">
+                <a:spcPts val="170"/>
+              </a:spcAft>
+            </a:pPr>
+            <a:r>
+              <a:rPr sz="830" b="0">
                 <a:solidFill>
                   <a:srgbClr val="1F2937"/>
                 </a:solidFill>
@@ -10157,7 +10552,7 @@
               <a:t>│   memory/                </a:t>
             </a:r>
             <a:r>
-              <a:rPr sz="840" b="0">
+              <a:rPr sz="790" b="0">
                 <a:solidFill>
                   <a:srgbClr val="6B7280"/>
                 </a:solidFill>
@@ -10165,7 +10560,7 @@
                 <a:ea typeface="Microsoft YaHei"/>
                 <a:cs typeface="Microsoft YaHei"/>
               </a:rPr>
-              <a:t># 在途工作记忆(Tier1)</a:t>
+              <a:t># 在途记忆(Tier1)</a:t>
             </a:r>
           </a:p>
           <a:p>
@@ -10174,11 +10569,11 @@
                 <a:spcPts val="0"/>
               </a:spcBef>
               <a:spcAft>
-                <a:spcPts val="220"/>
-              </a:spcAft>
-            </a:pPr>
-            <a:r>
-              <a:rPr sz="880" b="0">
+                <a:spcPts val="170"/>
+              </a:spcAft>
+            </a:pPr>
+            <a:r>
+              <a:rPr sz="830" b="0">
                 <a:solidFill>
                   <a:srgbClr val="1F2937"/>
                 </a:solidFill>
@@ -10189,7 +10584,7 @@
               <a:t>│   sediment_staging/      </a:t>
             </a:r>
             <a:r>
-              <a:rPr sz="840" b="0">
+              <a:rPr sz="790" b="0">
                 <a:solidFill>
                   <a:srgbClr val="6B7280"/>
                 </a:solidFill>
@@ -10206,11 +10601,11 @@
                 <a:spcPts val="0"/>
               </a:spcBef>
               <a:spcAft>
-                <a:spcPts val="220"/>
-              </a:spcAft>
-            </a:pPr>
-            <a:r>
-              <a:rPr sz="880" b="0">
+                <a:spcPts val="170"/>
+              </a:spcAft>
+            </a:pPr>
+            <a:r>
+              <a:rPr sz="830" b="0">
                 <a:solidFill>
                   <a:srgbClr val="1F2937"/>
                 </a:solidFill>
@@ -10221,7 +10616,7 @@
               <a:t>├─ state/current_task.json </a:t>
             </a:r>
             <a:r>
-              <a:rPr sz="840" b="0">
+              <a:rPr sz="790" b="0">
                 <a:solidFill>
                   <a:srgbClr val="6B7280"/>
                 </a:solidFill>
@@ -10238,11 +10633,11 @@
                 <a:spcPts val="0"/>
               </a:spcBef>
               <a:spcAft>
-                <a:spcPts val="220"/>
-              </a:spcAft>
-            </a:pPr>
-            <a:r>
-              <a:rPr sz="880" b="0">
+                <a:spcPts val="170"/>
+              </a:spcAft>
+            </a:pPr>
+            <a:r>
+              <a:rPr sz="830" b="0">
                 <a:solidFill>
                   <a:srgbClr val="1F2937"/>
                 </a:solidFill>
@@ -10253,7 +10648,7 @@
               <a:t>├─ skill-memory.lock       </a:t>
             </a:r>
             <a:r>
-              <a:rPr sz="840" b="0">
+              <a:rPr sz="790" b="0">
                 <a:solidFill>
                   <a:srgbClr val="6B7280"/>
                 </a:solidFill>
@@ -10261,7 +10656,7 @@
                 <a:ea typeface="Microsoft YaHei"/>
                 <a:cs typeface="Microsoft YaHei"/>
               </a:rPr>
-              <a:t># 锁定 hub 版本(semver+SHA)</a:t>
+              <a:t># 锁定版本(semver+SHA)</a:t>
             </a:r>
           </a:p>
           <a:p>
@@ -10270,11 +10665,11 @@
                 <a:spcPts val="0"/>
               </a:spcBef>
               <a:spcAft>
-                <a:spcPts val="220"/>
-              </a:spcAft>
-            </a:pPr>
-            <a:r>
-              <a:rPr sz="880" b="0">
+                <a:spcPts val="170"/>
+              </a:spcAft>
+            </a:pPr>
+            <a:r>
+              <a:rPr sz="830" b="0">
                 <a:solidFill>
                   <a:srgbClr val="1F2937"/>
                 </a:solidFill>
@@ -10285,7 +10680,7 @@
               <a:t>└─ resolver.py             </a:t>
             </a:r>
             <a:r>
-              <a:rPr sz="840" b="0">
+              <a:rPr sz="790" b="0">
                 <a:solidFill>
                   <a:srgbClr val="6B7280"/>
                 </a:solidFill>
@@ -10293,7 +10688,7 @@
                 <a:ea typeface="Microsoft YaHei"/>
                 <a:cs typeface="Microsoft YaHei"/>
               </a:rPr>
-              <a:t># 先 hub 共享,再叠加 local</a:t>
+              <a:t># 先 hub 再叠加 local</a:t>
             </a:r>
           </a:p>
         </p:txBody>
@@ -10306,8 +10701,8 @@
         </p:nvSpPr>
         <p:spPr>
           <a:xfrm>
-            <a:off x="7196328" y="3931920"/>
-            <a:ext cx="4425696" cy="676656"/>
+            <a:off x="7452360" y="3694176"/>
+            <a:ext cx="4325112" cy="841248"/>
           </a:xfrm>
           <a:prstGeom prst="roundRect">
             <a:avLst>
@@ -10372,7 +10767,7 @@
               </a:spcAft>
             </a:pPr>
             <a:r>
-              <a:rPr sz="900" b="0">
+              <a:rPr sz="880" b="0">
                 <a:solidFill>
                   <a:srgbClr val="6B7280"/>
                 </a:solidFill>
@@ -10387,58 +10782,14 @@
       </p:sp>
       <p:sp>
         <p:nvSpPr>
-          <p:cNvPr id="14" name="TextBox 13"/>
-          <p:cNvSpPr txBox="1"/>
-          <p:nvPr/>
-        </p:nvSpPr>
-        <p:spPr>
-          <a:xfrm>
-            <a:off x="457200" y="4773168"/>
-            <a:ext cx="7315200" cy="256032"/>
-          </a:xfrm>
-          <a:prstGeom prst="rect">
-            <a:avLst/>
-          </a:prstGeom>
-          <a:noFill/>
-        </p:spPr>
-        <p:txBody>
-          <a:bodyPr wrap="square" anchor="t" lIns="73152" rIns="73152" tIns="27432" bIns="27432">
-            <a:spAutoFit/>
-          </a:bodyPr>
-          <a:lstStyle/>
-          <a:p>
-            <a:pPr algn="l">
-              <a:spcBef>
-                <a:spcPts val="0"/>
-              </a:spcBef>
-              <a:spcAft>
-                <a:spcPts val="300"/>
-              </a:spcAft>
-            </a:pPr>
-            <a:r>
-              <a:rPr sz="1100" b="1">
-                <a:solidFill>
-                  <a:srgbClr val="0F1E3D"/>
-                </a:solidFill>
-                <a:latin typeface="Microsoft YaHei"/>
-                <a:ea typeface="Microsoft YaHei"/>
-                <a:cs typeface="Microsoft YaHei"/>
-              </a:rPr>
-              <a:t>布局设计要点</a:t>
-            </a:r>
-          </a:p>
-        </p:txBody>
-      </p:sp>
-      <p:sp>
-        <p:nvSpPr>
-          <p:cNvPr id="15" name="Rounded Rectangle 14"/>
+          <p:cNvPr id="14" name="Rounded Rectangle 13"/>
           <p:cNvSpPr/>
           <p:nvPr/>
         </p:nvSpPr>
         <p:spPr>
           <a:xfrm>
-            <a:off x="411480" y="5047488"/>
-            <a:ext cx="3657600" cy="1078992"/>
+            <a:off x="7452360" y="4645152"/>
+            <a:ext cx="4325112" cy="548640"/>
           </a:xfrm>
           <a:prstGeom prst="roundRect">
             <a:avLst>
@@ -10511,21 +10862,21 @@
                 <a:ea typeface="Microsoft YaHei"/>
                 <a:cs typeface="Microsoft YaHei"/>
               </a:rPr>
-              <a:t>hub 只读·共享·版本化；local 个人·在途·可丢弃。共享与个人互不污染。</a:t>
-            </a:r>
-          </a:p>
-        </p:txBody>
-      </p:sp>
-      <p:sp>
-        <p:nvSpPr>
-          <p:cNvPr id="16" name="Rounded Rectangle 15"/>
+              <a:t>hub 只读·共享·版本化；local 个人·在途</a:t>
+            </a:r>
+          </a:p>
+        </p:txBody>
+      </p:sp>
+      <p:sp>
+        <p:nvSpPr>
+          <p:cNvPr id="15" name="Rounded Rectangle 14"/>
           <p:cNvSpPr/>
           <p:nvPr/>
         </p:nvSpPr>
         <p:spPr>
           <a:xfrm>
-            <a:off x="4261104" y="5047488"/>
-            <a:ext cx="3657600" cy="1078992"/>
+            <a:off x="7452360" y="5230368"/>
+            <a:ext cx="4325112" cy="548640"/>
           </a:xfrm>
           <a:prstGeom prst="roundRect">
             <a:avLst>
@@ -10577,7 +10928,7 @@
                 <a:ea typeface="Microsoft YaHei"/>
                 <a:cs typeface="Microsoft YaHei"/>
               </a:rPr>
-              <a:t>每条知识 = 一文件 + 一稳定 ID</a:t>
+              <a:t>每条知识 = 一文件 + 稳定 ID</a:t>
             </a:r>
           </a:p>
           <a:p>
@@ -10598,21 +10949,21 @@
                 <a:ea typeface="Microsoft YaHei"/>
                 <a:cs typeface="Microsoft YaHei"/>
               </a:rPr>
-              <a:t>从根上规避 git 行级冲突；热点文件不再争用，合并全交给引擎 A。</a:t>
-            </a:r>
-          </a:p>
-        </p:txBody>
-      </p:sp>
-      <p:sp>
-        <p:nvSpPr>
-          <p:cNvPr id="17" name="Rounded Rectangle 16"/>
+              <a:t>规避 git 行级冲突，热点文件不争用</a:t>
+            </a:r>
+          </a:p>
+        </p:txBody>
+      </p:sp>
+      <p:sp>
+        <p:nvSpPr>
+          <p:cNvPr id="16" name="Rounded Rectangle 15"/>
           <p:cNvSpPr/>
           <p:nvPr/>
         </p:nvSpPr>
         <p:spPr>
           <a:xfrm>
-            <a:off x="8110727" y="5047488"/>
-            <a:ext cx="3657600" cy="1078992"/>
+            <a:off x="7452360" y="5815584"/>
+            <a:ext cx="4325112" cy="530352"/>
           </a:xfrm>
           <a:prstGeom prst="roundRect">
             <a:avLst>
@@ -10685,14 +11036,14 @@
                 <a:ea typeface="Microsoft YaHei"/>
                 <a:cs typeface="Microsoft YaHei"/>
               </a:rPr>
-              <a:t>锁定版本可复现、防漂移；本地留有副本，中央仓宕机也不阻塞。</a:t>
-            </a:r>
-          </a:p>
-        </p:txBody>
-      </p:sp>
-      <p:sp>
-        <p:nvSpPr>
-          <p:cNvPr id="18" name="TextBox 17"/>
+              <a:t>可复现·防漂移·中央仓宕机本地兜底</a:t>
+            </a:r>
+          </a:p>
+        </p:txBody>
+      </p:sp>
+      <p:sp>
+        <p:nvSpPr>
+          <p:cNvPr id="17" name="TextBox 16"/>
           <p:cNvSpPr txBox="1"/>
           <p:nvPr/>
         </p:nvSpPr>

</xml_diff>

<commit_message>
docs(slides): clarify eval/ vs evals/ and show optimization-funnel vertically
Two refinements on slide 6 (完整工程目录 Layout):
- The top-level eval/ and a skill's own evals/ were easy to confuse. Added a
  side-by-side callout: eval/ = team-shared assets (reusable task_suites/ +
  published scorecards/); evals/ = that single skill's binding (eval_id points
  to a suite) + its own held-out cases / scorecards.
- Show skills/core/optimization-funnel/ as a vertical zoom-in panel — one
  annotated line per entry (SKILL.md / best_skill.md / evals/ / candidates/ /
  scorecards/ / references/) instead of one cramped horizontal line.

Right column re-laid out into three stacked panels (.opencode/ tree, skill-
folder zoom, eval/-vs-evals/ compare). Verified all shapes in-bounds and that
both the hub tree and the wrapped cards fit.

https://claude.ai/code/session_01SfNMKzdmMz69A2VBTPNR92
</commit_message>
<xml_diff>
--- a/docs/Team_Skill_Hub_Design_Slides.pptx
+++ b/docs/Team_Skill_Hub_Design_Slides.pptx
@@ -9278,7 +9278,7 @@
         <p:spPr>
           <a:xfrm>
             <a:off x="411480" y="1078992"/>
-            <a:ext cx="6903720" cy="5257800"/>
+            <a:ext cx="6446520" cy="5138928"/>
           </a:xfrm>
           <a:prstGeom prst="roundRect">
             <a:avLst>
@@ -9326,7 +9326,7 @@
         <p:spPr>
           <a:xfrm>
             <a:off x="566928" y="1152144"/>
-            <a:ext cx="6675120" cy="292608"/>
+            <a:ext cx="6217920" cy="292608"/>
           </a:xfrm>
           <a:prstGeom prst="rect">
             <a:avLst/>
@@ -9370,7 +9370,7 @@
         <p:spPr>
           <a:xfrm>
             <a:off x="457200" y="1444752"/>
-            <a:ext cx="6858000" cy="4864608"/>
+            <a:ext cx="6400800" cy="4736592"/>
           </a:xfrm>
           <a:prstGeom prst="rect">
             <a:avLst/>
@@ -9392,7 +9392,7 @@
               </a:spcAft>
             </a:pPr>
             <a:r>
-              <a:rPr sz="850" b="0">
+              <a:rPr sz="900" b="0">
                 <a:solidFill>
                   <a:srgbClr val="1F2937"/>
                 </a:solidFill>
@@ -9403,7 +9403,7 @@
               <a:t>hm-skill-hub/                           </a:t>
             </a:r>
             <a:r>
-              <a:rPr sz="810" b="0">
+              <a:rPr sz="860" b="0">
                 <a:solidFill>
                   <a:srgbClr val="6B7280"/>
                 </a:solidFill>
@@ -9424,7 +9424,7 @@
               </a:spcAft>
             </a:pPr>
             <a:r>
-              <a:rPr sz="850" b="0">
+              <a:rPr sz="900" b="0">
                 <a:solidFill>
                   <a:srgbClr val="1F2937"/>
                 </a:solidFill>
@@ -9435,7 +9435,7 @@
               <a:t>├─ registry.yaml                        </a:t>
             </a:r>
             <a:r>
-              <a:rPr sz="810" b="0">
+              <a:rPr sz="860" b="0">
                 <a:solidFill>
                   <a:srgbClr val="6B7280"/>
                 </a:solidFill>
@@ -9456,7 +9456,7 @@
               </a:spcAft>
             </a:pPr>
             <a:r>
-              <a:rPr sz="850" b="0">
+              <a:rPr sz="900" b="0">
                 <a:solidFill>
                   <a:srgbClr val="1F2937"/>
                 </a:solidFill>
@@ -9467,7 +9467,7 @@
               <a:t>├─ schemas/                             </a:t>
             </a:r>
             <a:r>
-              <a:rPr sz="810" b="0">
+              <a:rPr sz="860" b="0">
                 <a:solidFill>
                   <a:srgbClr val="6B7280"/>
                 </a:solidFill>
@@ -9488,7 +9488,7 @@
               </a:spcAft>
             </a:pPr>
             <a:r>
-              <a:rPr sz="850" b="0">
+              <a:rPr sz="900" b="0">
                 <a:solidFill>
                   <a:srgbClr val="1F2937"/>
                 </a:solidFill>
@@ -9499,7 +9499,7 @@
               <a:t>├─ skills/                              </a:t>
             </a:r>
             <a:r>
-              <a:rPr sz="810" b="0">
+              <a:rPr sz="860" b="0">
                 <a:solidFill>
                   <a:srgbClr val="6B7280"/>
                 </a:solidFill>
@@ -9520,7 +9520,7 @@
               </a:spcAft>
             </a:pPr>
             <a:r>
-              <a:rPr sz="850" b="0">
+              <a:rPr sz="900" b="0">
                 <a:solidFill>
                   <a:srgbClr val="1F2937"/>
                 </a:solidFill>
@@ -9531,7 +9531,7 @@
               <a:t>│  ├─ core/                             </a:t>
             </a:r>
             <a:r>
-              <a:rPr sz="810" b="0">
+              <a:rPr sz="860" b="0">
                 <a:solidFill>
                   <a:srgbClr val="6B7280"/>
                 </a:solidFill>
@@ -9552,7 +9552,7 @@
               </a:spcAft>
             </a:pPr>
             <a:r>
-              <a:rPr sz="850" b="0">
+              <a:rPr sz="900" b="0">
                 <a:solidFill>
                   <a:srgbClr val="1F2937"/>
                 </a:solidFill>
@@ -9563,7 +9563,7 @@
               <a:t>│  │  ├─ optimization-funnel/           </a:t>
             </a:r>
             <a:r>
-              <a:rPr sz="810" b="0">
+              <a:rPr sz="860" b="0">
                 <a:solidFill>
                   <a:srgbClr val="6B7280"/>
                 </a:solidFill>
@@ -9571,7 +9571,7 @@
                 <a:ea typeface="Microsoft YaHei"/>
                 <a:cs typeface="Microsoft YaHei"/>
               </a:rPr>
-              <a:t># 例:优化漏斗主流程</a:t>
+              <a:t># 例:优化漏斗(见右侧放大)</a:t>
             </a:r>
           </a:p>
           <a:p>
@@ -9584,7 +9584,7 @@
               </a:spcAft>
             </a:pPr>
             <a:r>
-              <a:rPr sz="850" b="0">
+              <a:rPr sz="900" b="0">
                 <a:solidFill>
                   <a:srgbClr val="1F2937"/>
                 </a:solidFill>
@@ -9592,7 +9592,18 @@
                 <a:ea typeface="Consolas"/>
                 <a:cs typeface="Consolas"/>
               </a:rPr>
-              <a:t>│  │  │    SKILL.md · best_skill.md · evals/ · candidates/ · scorecards/</a:t>
+              <a:t>│  │  └─ stage-gate-enforcement/        </a:t>
+            </a:r>
+            <a:r>
+              <a:rPr sz="860" b="0">
+                <a:solidFill>
+                  <a:srgbClr val="6B7280"/>
+                </a:solidFill>
+                <a:latin typeface="Microsoft YaHei"/>
+                <a:ea typeface="Microsoft YaHei"/>
+                <a:cs typeface="Microsoft YaHei"/>
+              </a:rPr>
+              <a:t># 例:阶段门禁强制</a:t>
             </a:r>
           </a:p>
           <a:p>
@@ -9605,7 +9616,7 @@
               </a:spcAft>
             </a:pPr>
             <a:r>
-              <a:rPr sz="850" b="0">
+              <a:rPr sz="900" b="0">
                 <a:solidFill>
                   <a:srgbClr val="1F2937"/>
                 </a:solidFill>
@@ -9613,10 +9624,10 @@
                 <a:ea typeface="Consolas"/>
                 <a:cs typeface="Consolas"/>
               </a:rPr>
-              <a:t>│  │  └─ stage-gate-enforcement/        </a:t>
-            </a:r>
-            <a:r>
-              <a:rPr sz="810" b="0">
+              <a:t>│  ├─ technique/                        </a:t>
+            </a:r>
+            <a:r>
+              <a:rPr sz="860" b="0">
                 <a:solidFill>
                   <a:srgbClr val="6B7280"/>
                 </a:solidFill>
@@ -9624,7 +9635,7 @@
                 <a:ea typeface="Microsoft YaHei"/>
                 <a:cs typeface="Microsoft YaHei"/>
               </a:rPr>
-              <a:t># 例:阶段门禁强制</a:t>
+              <a:t># 优化招式 · 按 mechanism 命名</a:t>
             </a:r>
           </a:p>
           <a:p>
@@ -9637,7 +9648,7 @@
               </a:spcAft>
             </a:pPr>
             <a:r>
-              <a:rPr sz="850" b="0">
+              <a:rPr sz="900" b="0">
                 <a:solidFill>
                   <a:srgbClr val="1F2937"/>
                 </a:solidFill>
@@ -9645,10 +9656,10 @@
                 <a:ea typeface="Consolas"/>
                 <a:cs typeface="Consolas"/>
               </a:rPr>
-              <a:t>│  ├─ technique/                        </a:t>
-            </a:r>
-            <a:r>
-              <a:rPr sz="810" b="0">
+              <a:t>│  │  ├─ hoist-loop-invariant/          </a:t>
+            </a:r>
+            <a:r>
+              <a:rPr sz="860" b="0">
                 <a:solidFill>
                   <a:srgbClr val="6B7280"/>
                 </a:solidFill>
@@ -9656,7 +9667,7 @@
                 <a:ea typeface="Microsoft YaHei"/>
                 <a:cs typeface="Microsoft YaHei"/>
               </a:rPr>
-              <a:t># 优化招式 · 按 mechanism 命名</a:t>
+              <a:t># 例:循环不变量外提</a:t>
             </a:r>
           </a:p>
           <a:p>
@@ -9669,7 +9680,7 @@
               </a:spcAft>
             </a:pPr>
             <a:r>
-              <a:rPr sz="850" b="0">
+              <a:rPr sz="900" b="0">
                 <a:solidFill>
                   <a:srgbClr val="1F2937"/>
                 </a:solidFill>
@@ -9677,10 +9688,10 @@
                 <a:ea typeface="Consolas"/>
                 <a:cs typeface="Consolas"/>
               </a:rPr>
-              <a:t>│  │  ├─ hoist-loop-invariant/          </a:t>
-            </a:r>
-            <a:r>
-              <a:rPr sz="810" b="0">
+              <a:t>│  │  └─ batch-coalescing/              </a:t>
+            </a:r>
+            <a:r>
+              <a:rPr sz="860" b="0">
                 <a:solidFill>
                   <a:srgbClr val="6B7280"/>
                 </a:solidFill>
@@ -9688,7 +9699,7 @@
                 <a:ea typeface="Microsoft YaHei"/>
                 <a:cs typeface="Microsoft YaHei"/>
               </a:rPr>
-              <a:t># 例:循环不变量外提</a:t>
+              <a:t># 例:批量合并写</a:t>
             </a:r>
           </a:p>
           <a:p>
@@ -9701,7 +9712,7 @@
               </a:spcAft>
             </a:pPr>
             <a:r>
-              <a:rPr sz="850" b="0">
+              <a:rPr sz="900" b="0">
                 <a:solidFill>
                   <a:srgbClr val="1F2937"/>
                 </a:solidFill>
@@ -9709,10 +9720,10 @@
                 <a:ea typeface="Consolas"/>
                 <a:cs typeface="Consolas"/>
               </a:rPr>
-              <a:t>│  │  └─ batch-coalescing/              </a:t>
-            </a:r>
-            <a:r>
-              <a:rPr sz="810" b="0">
+              <a:t>│  ├─ domain/                           </a:t>
+            </a:r>
+            <a:r>
+              <a:rPr sz="860" b="0">
                 <a:solidFill>
                   <a:srgbClr val="6B7280"/>
                 </a:solidFill>
@@ -9720,7 +9731,7 @@
                 <a:ea typeface="Microsoft YaHei"/>
                 <a:cs typeface="Microsoft YaHei"/>
               </a:rPr>
-              <a:t># 例:批量合并写</a:t>
+              <a:t># 按子系统(唯一触及代码结构)</a:t>
             </a:r>
           </a:p>
           <a:p>
@@ -9733,7 +9744,7 @@
               </a:spcAft>
             </a:pPr>
             <a:r>
-              <a:rPr sz="850" b="0">
+              <a:rPr sz="900" b="0">
                 <a:solidFill>
                   <a:srgbClr val="1F2937"/>
                 </a:solidFill>
@@ -9741,10 +9752,10 @@
                 <a:ea typeface="Consolas"/>
                 <a:cs typeface="Consolas"/>
               </a:rPr>
-              <a:t>│  ├─ domain/                           </a:t>
-            </a:r>
-            <a:r>
-              <a:rPr sz="810" b="0">
+              <a:t>│  │  ├─ mm-reclaim/                    </a:t>
+            </a:r>
+            <a:r>
+              <a:rPr sz="860" b="0">
                 <a:solidFill>
                   <a:srgbClr val="6B7280"/>
                 </a:solidFill>
@@ -9752,7 +9763,7 @@
                 <a:ea typeface="Microsoft YaHei"/>
                 <a:cs typeface="Microsoft YaHei"/>
               </a:rPr>
-              <a:t># 按子系统(唯一触及代码结构)</a:t>
+              <a:t># 例:内存回收(含 references/)</a:t>
             </a:r>
           </a:p>
           <a:p>
@@ -9765,7 +9776,7 @@
               </a:spcAft>
             </a:pPr>
             <a:r>
-              <a:rPr sz="850" b="0">
+              <a:rPr sz="900" b="0">
                 <a:solidFill>
                   <a:srgbClr val="1F2937"/>
                 </a:solidFill>
@@ -9773,10 +9784,10 @@
                 <a:ea typeface="Consolas"/>
                 <a:cs typeface="Consolas"/>
               </a:rPr>
-              <a:t>│  │  ├─ mm-reclaim/                    </a:t>
-            </a:r>
-            <a:r>
-              <a:rPr sz="810" b="0">
+              <a:t>│  │  └─ hyperhold-io/                  </a:t>
+            </a:r>
+            <a:r>
+              <a:rPr sz="860" b="0">
                 <a:solidFill>
                   <a:srgbClr val="6B7280"/>
                 </a:solidFill>
@@ -9784,7 +9795,7 @@
                 <a:ea typeface="Microsoft YaHei"/>
                 <a:cs typeface="Microsoft YaHei"/>
               </a:rPr>
-              <a:t># 例:内存回收(含 references/)</a:t>
+              <a:t># 例:hyperhold I/O 路径</a:t>
             </a:r>
           </a:p>
           <a:p>
@@ -9797,7 +9808,7 @@
               </a:spcAft>
             </a:pPr>
             <a:r>
-              <a:rPr sz="850" b="0">
+              <a:rPr sz="900" b="0">
                 <a:solidFill>
                   <a:srgbClr val="1F2937"/>
                 </a:solidFill>
@@ -9805,10 +9816,10 @@
                 <a:ea typeface="Consolas"/>
                 <a:cs typeface="Consolas"/>
               </a:rPr>
-              <a:t>│  │  └─ hyperhold-io/                  </a:t>
-            </a:r>
-            <a:r>
-              <a:rPr sz="810" b="0">
+              <a:t>│  └─ _registry/skills.yaml             </a:t>
+            </a:r>
+            <a:r>
+              <a:rPr sz="860" b="0">
                 <a:solidFill>
                   <a:srgbClr val="6B7280"/>
                 </a:solidFill>
@@ -9816,7 +9827,7 @@
                 <a:ea typeface="Microsoft YaHei"/>
                 <a:cs typeface="Microsoft YaHei"/>
               </a:rPr>
-              <a:t># 例:hyperhold I/O 路径</a:t>
+              <a:t># 全量索引 + 子系统选择器</a:t>
             </a:r>
           </a:p>
           <a:p>
@@ -9829,7 +9840,7 @@
               </a:spcAft>
             </a:pPr>
             <a:r>
-              <a:rPr sz="850" b="0">
+              <a:rPr sz="900" b="0">
                 <a:solidFill>
                   <a:srgbClr val="1F2937"/>
                 </a:solidFill>
@@ -9837,10 +9848,10 @@
                 <a:ea typeface="Consolas"/>
                 <a:cs typeface="Consolas"/>
               </a:rPr>
-              <a:t>│  └─ _registry/skills.yaml             </a:t>
-            </a:r>
-            <a:r>
-              <a:rPr sz="810" b="0">
+              <a:t>├─ knowledge/                           </a:t>
+            </a:r>
+            <a:r>
+              <a:rPr sz="860" b="0">
                 <a:solidFill>
                   <a:srgbClr val="6B7280"/>
                 </a:solidFill>
@@ -9848,7 +9859,7 @@
                 <a:ea typeface="Microsoft YaHei"/>
                 <a:cs typeface="Microsoft YaHei"/>
               </a:rPr>
-              <a:t># 全量索引 + 子系统选择器</a:t>
+              <a:t># 知识(引擎A·分层·每条一文件)</a:t>
             </a:r>
           </a:p>
           <a:p>
@@ -9861,7 +9872,7 @@
               </a:spcAft>
             </a:pPr>
             <a:r>
-              <a:rPr sz="850" b="0">
+              <a:rPr sz="900" b="0">
                 <a:solidFill>
                   <a:srgbClr val="1F2937"/>
                 </a:solidFill>
@@ -9869,10 +9880,10 @@
                 <a:ea typeface="Consolas"/>
                 <a:cs typeface="Consolas"/>
               </a:rPr>
-              <a:t>├─ knowledge/                           </a:t>
-            </a:r>
-            <a:r>
-              <a:rPr sz="810" b="0">
+              <a:t>│  ├─ global/                           </a:t>
+            </a:r>
+            <a:r>
+              <a:rPr sz="860" b="0">
                 <a:solidFill>
                   <a:srgbClr val="6B7280"/>
                 </a:solidFill>
@@ -9880,7 +9891,7 @@
                 <a:ea typeface="Microsoft YaHei"/>
                 <a:cs typeface="Microsoft YaHei"/>
               </a:rPr>
-              <a:t># 知识(引擎A·分层·每条一文件)</a:t>
+              <a:t># 全局教训 / 反模式</a:t>
             </a:r>
           </a:p>
           <a:p>
@@ -9893,7 +9904,7 @@
               </a:spcAft>
             </a:pPr>
             <a:r>
-              <a:rPr sz="850" b="0">
+              <a:rPr sz="900" b="0">
                 <a:solidFill>
                   <a:srgbClr val="1F2937"/>
                 </a:solidFill>
@@ -9901,10 +9912,10 @@
                 <a:ea typeface="Consolas"/>
                 <a:cs typeface="Consolas"/>
               </a:rPr>
-              <a:t>│  ├─ global/                           </a:t>
-            </a:r>
-            <a:r>
-              <a:rPr sz="810" b="0">
+              <a:t>│  │  ├─ lessons/                       </a:t>
+            </a:r>
+            <a:r>
+              <a:rPr sz="860" b="0">
                 <a:solidFill>
                   <a:srgbClr val="6B7280"/>
                 </a:solidFill>
@@ -9912,7 +9923,7 @@
                 <a:ea typeface="Microsoft YaHei"/>
                 <a:cs typeface="Microsoft YaHei"/>
               </a:rPr>
-              <a:t># 全局教训 / 反模式</a:t>
+              <a:t># 例:G012_reclaim-twice.md</a:t>
             </a:r>
           </a:p>
           <a:p>
@@ -9925,7 +9936,7 @@
               </a:spcAft>
             </a:pPr>
             <a:r>
-              <a:rPr sz="850" b="0">
+              <a:rPr sz="900" b="0">
                 <a:solidFill>
                   <a:srgbClr val="1F2937"/>
                 </a:solidFill>
@@ -9933,10 +9944,10 @@
                 <a:ea typeface="Consolas"/>
                 <a:cs typeface="Consolas"/>
               </a:rPr>
-              <a:t>│  │  ├─ lessons/                       </a:t>
-            </a:r>
-            <a:r>
-              <a:rPr sz="810" b="0">
+              <a:t>│  │  └─ anti_patterns/                 </a:t>
+            </a:r>
+            <a:r>
+              <a:rPr sz="860" b="0">
                 <a:solidFill>
                   <a:srgbClr val="6B7280"/>
                 </a:solidFill>
@@ -9944,7 +9955,7 @@
                 <a:ea typeface="Microsoft YaHei"/>
                 <a:cs typeface="Microsoft YaHei"/>
               </a:rPr>
-              <a:t># 例:G012_reclaim-twice.md</a:t>
+              <a:t># 例:A007_busy-wait.md</a:t>
             </a:r>
           </a:p>
           <a:p>
@@ -9957,7 +9968,7 @@
               </a:spcAft>
             </a:pPr>
             <a:r>
-              <a:rPr sz="850" b="0">
+              <a:rPr sz="900" b="0">
                 <a:solidFill>
                   <a:srgbClr val="1F2937"/>
                 </a:solidFill>
@@ -9965,18 +9976,7 @@
                 <a:ea typeface="Consolas"/>
                 <a:cs typeface="Consolas"/>
               </a:rPr>
-              <a:t>│  │  └─ anti_patterns/                 </a:t>
-            </a:r>
-            <a:r>
-              <a:rPr sz="810" b="0">
-                <a:solidFill>
-                  <a:srgbClr val="6B7280"/>
-                </a:solidFill>
-                <a:latin typeface="Microsoft YaHei"/>
-                <a:ea typeface="Microsoft YaHei"/>
-                <a:cs typeface="Microsoft YaHei"/>
-              </a:rPr>
-              <a:t># 例:A007_busy-wait.md</a:t>
+              <a:t>│  ├─ subsystems/&lt;s&gt;.md  ·  targets/&lt;slug&gt;/{facts,decisions,idea_ledger}</a:t>
             </a:r>
           </a:p>
           <a:p>
@@ -9989,7 +9989,7 @@
               </a:spcAft>
             </a:pPr>
             <a:r>
-              <a:rPr sz="850" b="0">
+              <a:rPr sz="900" b="0">
                 <a:solidFill>
                   <a:srgbClr val="1F2937"/>
                 </a:solidFill>
@@ -9997,7 +9997,18 @@
                 <a:ea typeface="Consolas"/>
                 <a:cs typeface="Consolas"/>
               </a:rPr>
-              <a:t>│  ├─ subsystems/&lt;s&gt;.md  ·  targets/&lt;slug&gt;/{facts,decisions,idea_ledger}</a:t>
+              <a:t>│  └─ index/                            </a:t>
+            </a:r>
+            <a:r>
+              <a:rPr sz="860" b="0">
+                <a:solidFill>
+                  <a:srgbClr val="6B7280"/>
+                </a:solidFill>
+                <a:latin typeface="Microsoft YaHei"/>
+                <a:ea typeface="Microsoft YaHei"/>
+                <a:cs typeface="Microsoft YaHei"/>
+              </a:rPr>
+              <a:t># 向量检索索引</a:t>
             </a:r>
           </a:p>
           <a:p>
@@ -10010,7 +10021,7 @@
               </a:spcAft>
             </a:pPr>
             <a:r>
-              <a:rPr sz="850" b="0">
+              <a:rPr sz="900" b="0">
                 <a:solidFill>
                   <a:srgbClr val="1F2937"/>
                 </a:solidFill>
@@ -10018,10 +10029,10 @@
                 <a:ea typeface="Consolas"/>
                 <a:cs typeface="Consolas"/>
               </a:rPr>
-              <a:t>│  └─ index/                            </a:t>
-            </a:r>
-            <a:r>
-              <a:rPr sz="810" b="0">
+              <a:t>├─ evidence/                            </a:t>
+            </a:r>
+            <a:r>
+              <a:rPr sz="860" b="0">
                 <a:solidFill>
                   <a:srgbClr val="6B7280"/>
                 </a:solidFill>
@@ -10029,7 +10040,7 @@
                 <a:ea typeface="Microsoft YaHei"/>
                 <a:cs typeface="Microsoft YaHei"/>
               </a:rPr>
-              <a:t># 向量检索索引</a:t>
+              <a:t># 可复核证据(每条回链来源)</a:t>
             </a:r>
           </a:p>
           <a:p>
@@ -10042,7 +10053,7 @@
               </a:spcAft>
             </a:pPr>
             <a:r>
-              <a:rPr sz="850" b="0">
+              <a:rPr sz="900" b="0">
                 <a:solidFill>
                   <a:srgbClr val="1F2937"/>
                 </a:solidFill>
@@ -10050,10 +10061,10 @@
                 <a:ea typeface="Consolas"/>
                 <a:cs typeface="Consolas"/>
               </a:rPr>
-              <a:t>├─ evidence/                            </a:t>
-            </a:r>
-            <a:r>
-              <a:rPr sz="810" b="0">
+              <a:t>│  ├─ benchmarks/                       </a:t>
+            </a:r>
+            <a:r>
+              <a:rPr sz="860" b="0">
                 <a:solidFill>
                   <a:srgbClr val="6B7280"/>
                 </a:solidFill>
@@ -10061,7 +10072,7 @@
                 <a:ea typeface="Microsoft YaHei"/>
                 <a:cs typeface="Microsoft YaHei"/>
               </a:rPr>
-              <a:t># 可复核证据(每条回链来源)</a:t>
+              <a:t># 例:mm-reclaim_2026Q2.json</a:t>
             </a:r>
           </a:p>
           <a:p>
@@ -10074,7 +10085,7 @@
               </a:spcAft>
             </a:pPr>
             <a:r>
-              <a:rPr sz="850" b="0">
+              <a:rPr sz="900" b="0">
                 <a:solidFill>
                   <a:srgbClr val="1F2937"/>
                 </a:solidFill>
@@ -10082,10 +10093,10 @@
                 <a:ea typeface="Consolas"/>
                 <a:cs typeface="Consolas"/>
               </a:rPr>
-              <a:t>│  ├─ benchmarks/                       </a:t>
-            </a:r>
-            <a:r>
-              <a:rPr sz="810" b="0">
+              <a:t>│  └─ regressions/                      </a:t>
+            </a:r>
+            <a:r>
+              <a:rPr sz="860" b="0">
                 <a:solidFill>
                   <a:srgbClr val="6B7280"/>
                 </a:solidFill>
@@ -10093,7 +10104,7 @@
                 <a:ea typeface="Microsoft YaHei"/>
                 <a:cs typeface="Microsoft YaHei"/>
               </a:rPr>
-              <a:t># 例:mm-reclaim_2026Q2.json</a:t>
+              <a:t># 例:R031_shrink_node.json</a:t>
             </a:r>
           </a:p>
           <a:p>
@@ -10106,7 +10117,7 @@
               </a:spcAft>
             </a:pPr>
             <a:r>
-              <a:rPr sz="850" b="0">
+              <a:rPr sz="900" b="0">
                 <a:solidFill>
                   <a:srgbClr val="1F2937"/>
                 </a:solidFill>
@@ -10114,10 +10125,10 @@
                 <a:ea typeface="Consolas"/>
                 <a:cs typeface="Consolas"/>
               </a:rPr>
-              <a:t>│  └─ regressions/                      </a:t>
-            </a:r>
-            <a:r>
-              <a:rPr sz="810" b="0">
+              <a:t>├─ eval/                                </a:t>
+            </a:r>
+            <a:r>
+              <a:rPr sz="860" b="0">
                 <a:solidFill>
                   <a:srgbClr val="6B7280"/>
                 </a:solidFill>
@@ -10125,7 +10136,7 @@
                 <a:ea typeface="Microsoft YaHei"/>
                 <a:cs typeface="Microsoft YaHei"/>
               </a:rPr>
-              <a:t># 例:R031_shrink_node.json</a:t>
+              <a:t># 顶层评测资产·团队共享(见右下)</a:t>
             </a:r>
           </a:p>
           <a:p>
@@ -10138,7 +10149,7 @@
               </a:spcAft>
             </a:pPr>
             <a:r>
-              <a:rPr sz="850" b="0">
+              <a:rPr sz="900" b="0">
                 <a:solidFill>
                   <a:srgbClr val="1F2937"/>
                 </a:solidFill>
@@ -10146,10 +10157,10 @@
                 <a:ea typeface="Consolas"/>
                 <a:cs typeface="Consolas"/>
               </a:rPr>
-              <a:t>├─ eval/                                </a:t>
-            </a:r>
-            <a:r>
-              <a:rPr sz="810" b="0">
+              <a:t>│  ├─ task_suites/                      </a:t>
+            </a:r>
+            <a:r>
+              <a:rPr sz="860" b="0">
                 <a:solidFill>
                   <a:srgbClr val="6B7280"/>
                 </a:solidFill>
@@ -10157,7 +10168,7 @@
                 <a:ea typeface="Microsoft YaHei"/>
                 <a:cs typeface="Microsoft YaHei"/>
               </a:rPr>
-              <a:t># 评测资产(引擎B 的发布门)</a:t>
+              <a:t># 可复用任务集 例:mm_reclaim_suite/</a:t>
             </a:r>
           </a:p>
           <a:p>
@@ -10170,7 +10181,7 @@
               </a:spcAft>
             </a:pPr>
             <a:r>
-              <a:rPr sz="850" b="0">
+              <a:rPr sz="900" b="0">
                 <a:solidFill>
                   <a:srgbClr val="1F2937"/>
                 </a:solidFill>
@@ -10178,10 +10189,10 @@
                 <a:ea typeface="Consolas"/>
                 <a:cs typeface="Consolas"/>
               </a:rPr>
-              <a:t>│  ├─ task_suites/                      </a:t>
-            </a:r>
-            <a:r>
-              <a:rPr sz="810" b="0">
+              <a:t>│  └─ scorecards/                       </a:t>
+            </a:r>
+            <a:r>
+              <a:rPr sz="860" b="0">
                 <a:solidFill>
                   <a:srgbClr val="6B7280"/>
                 </a:solidFill>
@@ -10189,7 +10200,7 @@
                 <a:ea typeface="Microsoft YaHei"/>
                 <a:cs typeface="Microsoft YaHei"/>
               </a:rPr>
-              <a:t># 例:mm_reclaim_suite/</a:t>
+              <a:t># 发布级评分 例:funnel_v3_*.md</a:t>
             </a:r>
           </a:p>
           <a:p>
@@ -10202,7 +10213,7 @@
               </a:spcAft>
             </a:pPr>
             <a:r>
-              <a:rPr sz="850" b="0">
+              <a:rPr sz="900" b="0">
                 <a:solidFill>
                   <a:srgbClr val="1F2937"/>
                 </a:solidFill>
@@ -10210,42 +10221,10 @@
                 <a:ea typeface="Consolas"/>
                 <a:cs typeface="Consolas"/>
               </a:rPr>
-              <a:t>│  └─ scorecards/                       </a:t>
-            </a:r>
-            <a:r>
-              <a:rPr sz="810" b="0">
-                <a:solidFill>
-                  <a:srgbClr val="6B7280"/>
-                </a:solidFill>
-                <a:latin typeface="Microsoft YaHei"/>
-                <a:ea typeface="Microsoft YaHei"/>
-                <a:cs typeface="Microsoft YaHei"/>
-              </a:rPr>
-              <a:t># 例:funnel_v3_scorecard.md</a:t>
-            </a:r>
-          </a:p>
-          <a:p>
-            <a:pPr algn="l">
-              <a:spcBef>
-                <a:spcPts val="0"/>
-              </a:spcBef>
-              <a:spcAft>
-                <a:spcPts val="140"/>
-              </a:spcAft>
-            </a:pPr>
-            <a:r>
-              <a:rPr sz="850" b="0">
-                <a:solidFill>
-                  <a:srgbClr val="1F2937"/>
-                </a:solidFill>
-                <a:latin typeface="Consolas"/>
-                <a:ea typeface="Consolas"/>
-                <a:cs typeface="Consolas"/>
-              </a:rPr>
               <a:t>└─ policies/ staging/ tools/ .github/   </a:t>
             </a:r>
             <a:r>
-              <a:rPr sz="810" b="0">
+              <a:rPr sz="860" b="0">
                 <a:solidFill>
                   <a:srgbClr val="6B7280"/>
                 </a:solidFill>
@@ -10266,8 +10245,8 @@
         </p:nvSpPr>
         <p:spPr>
           <a:xfrm>
-            <a:off x="7452360" y="1078992"/>
-            <a:ext cx="4325112" cy="2505456"/>
+            <a:off x="6995160" y="1078992"/>
+            <a:ext cx="4782312" cy="2103120"/>
           </a:xfrm>
           <a:prstGeom prst="roundRect">
             <a:avLst>
@@ -10314,8 +10293,8 @@
         </p:nvSpPr>
         <p:spPr>
           <a:xfrm>
-            <a:off x="7589520" y="1152144"/>
-            <a:ext cx="4114800" cy="292608"/>
+            <a:off x="7132320" y="1133856"/>
+            <a:ext cx="4572000" cy="274320"/>
           </a:xfrm>
           <a:prstGeom prst="rect">
             <a:avLst/>
@@ -10358,8 +10337,8 @@
         </p:nvSpPr>
         <p:spPr>
           <a:xfrm>
-            <a:off x="7498079" y="1444752"/>
-            <a:ext cx="4206240" cy="2103120"/>
+            <a:off x="7059168" y="1426464"/>
+            <a:ext cx="4681728" cy="1755648"/>
           </a:xfrm>
           <a:prstGeom prst="rect">
             <a:avLst/>
@@ -10377,11 +10356,11 @@
                 <a:spcPts val="0"/>
               </a:spcBef>
               <a:spcAft>
-                <a:spcPts val="170"/>
-              </a:spcAft>
-            </a:pPr>
-            <a:r>
-              <a:rPr sz="830" b="0">
+                <a:spcPts val="130"/>
+              </a:spcAft>
+            </a:pPr>
+            <a:r>
+              <a:rPr sz="819" b="0">
                 <a:solidFill>
                   <a:srgbClr val="1F2937"/>
                 </a:solidFill>
@@ -10392,7 +10371,7 @@
               <a:t>.opencode/                 </a:t>
             </a:r>
             <a:r>
-              <a:rPr sz="790" b="0">
+              <a:rPr sz="779" b="0">
                 <a:solidFill>
                   <a:srgbClr val="6B7280"/>
                 </a:solidFill>
@@ -10409,11 +10388,11 @@
                 <a:spcPts val="0"/>
               </a:spcBef>
               <a:spcAft>
-                <a:spcPts val="170"/>
-              </a:spcAft>
-            </a:pPr>
-            <a:r>
-              <a:rPr sz="830" b="0">
+                <a:spcPts val="130"/>
+              </a:spcAft>
+            </a:pPr>
+            <a:r>
+              <a:rPr sz="819" b="0">
                 <a:solidFill>
                   <a:srgbClr val="1F2937"/>
                 </a:solidFill>
@@ -10424,7 +10403,7 @@
               <a:t>├─ hub/                    </a:t>
             </a:r>
             <a:r>
-              <a:rPr sz="790" b="0">
+              <a:rPr sz="779" b="0">
                 <a:solidFill>
                   <a:srgbClr val="6B7280"/>
                 </a:solidFill>
@@ -10441,11 +10420,11 @@
                 <a:spcPts val="0"/>
               </a:spcBef>
               <a:spcAft>
-                <a:spcPts val="170"/>
-              </a:spcAft>
-            </a:pPr>
-            <a:r>
-              <a:rPr sz="830" b="0">
+                <a:spcPts val="130"/>
+              </a:spcAft>
+            </a:pPr>
+            <a:r>
+              <a:rPr sz="819" b="0">
                 <a:solidFill>
                   <a:srgbClr val="1F2937"/>
                 </a:solidFill>
@@ -10456,7 +10435,7 @@
               <a:t>├─ local/                  </a:t>
             </a:r>
             <a:r>
-              <a:rPr sz="790" b="0">
+              <a:rPr sz="779" b="0">
                 <a:solidFill>
                   <a:srgbClr val="6B7280"/>
                 </a:solidFill>
@@ -10473,11 +10452,11 @@
                 <a:spcPts val="0"/>
               </a:spcBef>
               <a:spcAft>
-                <a:spcPts val="170"/>
-              </a:spcAft>
-            </a:pPr>
-            <a:r>
-              <a:rPr sz="830" b="0">
+                <a:spcPts val="130"/>
+              </a:spcAft>
+            </a:pPr>
+            <a:r>
+              <a:rPr sz="819" b="0">
                 <a:solidFill>
                   <a:srgbClr val="1F2937"/>
                 </a:solidFill>
@@ -10488,7 +10467,7 @@
               <a:t>│   runs/&lt;run_id&gt;/         </a:t>
             </a:r>
             <a:r>
-              <a:rPr sz="790" b="0">
+              <a:rPr sz="779" b="0">
                 <a:solidFill>
                   <a:srgbClr val="6B7280"/>
                 </a:solidFill>
@@ -10505,11 +10484,11 @@
                 <a:spcPts val="0"/>
               </a:spcBef>
               <a:spcAft>
-                <a:spcPts val="170"/>
-              </a:spcAft>
-            </a:pPr>
-            <a:r>
-              <a:rPr sz="830" b="0">
+                <a:spcPts val="130"/>
+              </a:spcAft>
+            </a:pPr>
+            <a:r>
+              <a:rPr sz="819" b="0">
                 <a:solidFill>
                   <a:srgbClr val="1F2937"/>
                 </a:solidFill>
@@ -10520,7 +10499,7 @@
               <a:t>│     &lt;target&gt;_design.md   </a:t>
             </a:r>
             <a:r>
-              <a:rPr sz="790" b="0">
+              <a:rPr sz="779" b="0">
                 <a:solidFill>
                   <a:srgbClr val="6B7280"/>
                 </a:solidFill>
@@ -10537,11 +10516,11 @@
                 <a:spcPts val="0"/>
               </a:spcBef>
               <a:spcAft>
-                <a:spcPts val="170"/>
-              </a:spcAft>
-            </a:pPr>
-            <a:r>
-              <a:rPr sz="830" b="0">
+                <a:spcPts val="130"/>
+              </a:spcAft>
+            </a:pPr>
+            <a:r>
+              <a:rPr sz="819" b="0">
                 <a:solidFill>
                   <a:srgbClr val="1F2937"/>
                 </a:solidFill>
@@ -10552,7 +10531,7 @@
               <a:t>│   memory/                </a:t>
             </a:r>
             <a:r>
-              <a:rPr sz="790" b="0">
+              <a:rPr sz="779" b="0">
                 <a:solidFill>
                   <a:srgbClr val="6B7280"/>
                 </a:solidFill>
@@ -10569,11 +10548,11 @@
                 <a:spcPts val="0"/>
               </a:spcBef>
               <a:spcAft>
-                <a:spcPts val="170"/>
-              </a:spcAft>
-            </a:pPr>
-            <a:r>
-              <a:rPr sz="830" b="0">
+                <a:spcPts val="130"/>
+              </a:spcAft>
+            </a:pPr>
+            <a:r>
+              <a:rPr sz="819" b="0">
                 <a:solidFill>
                   <a:srgbClr val="1F2937"/>
                 </a:solidFill>
@@ -10584,7 +10563,7 @@
               <a:t>│   sediment_staging/      </a:t>
             </a:r>
             <a:r>
-              <a:rPr sz="790" b="0">
+              <a:rPr sz="779" b="0">
                 <a:solidFill>
                   <a:srgbClr val="6B7280"/>
                 </a:solidFill>
@@ -10601,11 +10580,11 @@
                 <a:spcPts val="0"/>
               </a:spcBef>
               <a:spcAft>
-                <a:spcPts val="170"/>
-              </a:spcAft>
-            </a:pPr>
-            <a:r>
-              <a:rPr sz="830" b="0">
+                <a:spcPts val="130"/>
+              </a:spcAft>
+            </a:pPr>
+            <a:r>
+              <a:rPr sz="819" b="0">
                 <a:solidFill>
                   <a:srgbClr val="1F2937"/>
                 </a:solidFill>
@@ -10616,7 +10595,7 @@
               <a:t>├─ state/current_task.json </a:t>
             </a:r>
             <a:r>
-              <a:rPr sz="790" b="0">
+              <a:rPr sz="779" b="0">
                 <a:solidFill>
                   <a:srgbClr val="6B7280"/>
                 </a:solidFill>
@@ -10633,11 +10612,11 @@
                 <a:spcPts val="0"/>
               </a:spcBef>
               <a:spcAft>
-                <a:spcPts val="170"/>
-              </a:spcAft>
-            </a:pPr>
-            <a:r>
-              <a:rPr sz="830" b="0">
+                <a:spcPts val="130"/>
+              </a:spcAft>
+            </a:pPr>
+            <a:r>
+              <a:rPr sz="819" b="0">
                 <a:solidFill>
                   <a:srgbClr val="1F2937"/>
                 </a:solidFill>
@@ -10648,7 +10627,7 @@
               <a:t>├─ skill-memory.lock       </a:t>
             </a:r>
             <a:r>
-              <a:rPr sz="790" b="0">
+              <a:rPr sz="779" b="0">
                 <a:solidFill>
                   <a:srgbClr val="6B7280"/>
                 </a:solidFill>
@@ -10665,11 +10644,11 @@
                 <a:spcPts val="0"/>
               </a:spcBef>
               <a:spcAft>
-                <a:spcPts val="170"/>
-              </a:spcAft>
-            </a:pPr>
-            <a:r>
-              <a:rPr sz="830" b="0">
+                <a:spcPts val="130"/>
+              </a:spcAft>
+            </a:pPr>
+            <a:r>
+              <a:rPr sz="819" b="0">
                 <a:solidFill>
                   <a:srgbClr val="1F2937"/>
                 </a:solidFill>
@@ -10680,7 +10659,7 @@
               <a:t>└─ resolver.py             </a:t>
             </a:r>
             <a:r>
-              <a:rPr sz="790" b="0">
+              <a:rPr sz="779" b="0">
                 <a:solidFill>
                   <a:srgbClr val="6B7280"/>
                 </a:solidFill>
@@ -10701,20 +10680,20 @@
         </p:nvSpPr>
         <p:spPr>
           <a:xfrm>
-            <a:off x="7452360" y="3694176"/>
-            <a:ext cx="4325112" cy="841248"/>
+            <a:off x="6995160" y="3255264"/>
+            <a:ext cx="4782312" cy="1481328"/>
           </a:xfrm>
           <a:prstGeom prst="roundRect">
             <a:avLst>
-              <a:gd name="adj" fmla="val 8000"/>
+              <a:gd name="adj" fmla="val 4000"/>
             </a:avLst>
           </a:prstGeom>
           <a:solidFill>
-            <a:srgbClr val="F1F5F9"/>
+            <a:srgbClr val="F3FBFA"/>
           </a:solidFill>
           <a:ln w="12700">
             <a:solidFill>
-              <a:srgbClr val="CBD5E1"/>
+              <a:srgbClr val="0D9488"/>
             </a:solidFill>
           </a:ln>
           <a:effectLst/>
@@ -10734,10 +10713,36 @@
           </a:fontRef>
         </p:style>
         <p:txBody>
-          <a:bodyPr rtlCol="0" anchor="t" wrap="square" lIns="73152" rIns="73152" tIns="27432" bIns="27432"/>
-          <a:lstStyle/>
-          <a:p>
-            <a:pPr algn="ctr">
+          <a:bodyPr rtlCol="0" anchor="ctr"/>
+          <a:lstStyle/>
+          <a:p>
+            <a:pPr algn="ctr"/>
+          </a:p>
+        </p:txBody>
+      </p:sp>
+      <p:sp>
+        <p:nvSpPr>
+          <p:cNvPr id="14" name="TextBox 13"/>
+          <p:cNvSpPr txBox="1"/>
+          <p:nvPr/>
+        </p:nvSpPr>
+        <p:spPr>
+          <a:xfrm>
+            <a:off x="7132320" y="3310128"/>
+            <a:ext cx="4572000" cy="274320"/>
+          </a:xfrm>
+          <a:prstGeom prst="rect">
+            <a:avLst/>
+          </a:prstGeom>
+          <a:noFill/>
+        </p:spPr>
+        <p:txBody>
+          <a:bodyPr wrap="square" anchor="t" lIns="73152" rIns="73152" tIns="27432" bIns="27432">
+            <a:spAutoFit/>
+          </a:bodyPr>
+          <a:lstStyle/>
+          <a:p>
+            <a:pPr algn="l">
               <a:spcBef>
                 <a:spcPts val="0"/>
               </a:spcBef>
@@ -10746,19 +10751,257 @@
               </a:spcAft>
             </a:pPr>
             <a:r>
-              <a:rPr sz="1050" b="1">
+              <a:rPr sz="1000" b="1">
+                <a:solidFill>
+                  <a:srgbClr val="0D9488"/>
+                </a:solidFill>
+                <a:latin typeface="Microsoft YaHei"/>
+                <a:ea typeface="Microsoft YaHei"/>
+                <a:cs typeface="Microsoft YaHei"/>
+              </a:rPr>
+              <a:t>【放大】一个技能文件夹 = skills/core/optimization-funnel/</a:t>
+            </a:r>
+          </a:p>
+        </p:txBody>
+      </p:sp>
+      <p:sp>
+        <p:nvSpPr>
+          <p:cNvPr id="15" name="TextBox 14"/>
+          <p:cNvSpPr txBox="1"/>
+          <p:nvPr/>
+        </p:nvSpPr>
+        <p:spPr>
+          <a:xfrm>
+            <a:off x="7150608" y="3621024"/>
+            <a:ext cx="4572000" cy="1097280"/>
+          </a:xfrm>
+          <a:prstGeom prst="rect">
+            <a:avLst/>
+          </a:prstGeom>
+          <a:noFill/>
+        </p:spPr>
+        <p:txBody>
+          <a:bodyPr wrap="none" anchor="t" lIns="128016" rIns="54864" tIns="91440">
+            <a:spAutoFit/>
+          </a:bodyPr>
+          <a:lstStyle/>
+          <a:p>
+            <a:pPr algn="l">
+              <a:spcBef>
+                <a:spcPts val="0"/>
+              </a:spcBef>
+              <a:spcAft>
+                <a:spcPts val="140"/>
+              </a:spcAft>
+            </a:pPr>
+            <a:r>
+              <a:rPr sz="830" b="0">
                 <a:solidFill>
                   <a:srgbClr val="1F2937"/>
                 </a:solidFill>
-                <a:latin typeface="Microsoft YaHei"/>
-                <a:ea typeface="Microsoft YaHei"/>
-                <a:cs typeface="Microsoft YaHei"/>
-              </a:rPr>
-              <a:t>三类资产 → 唯一归宿</a:t>
-            </a:r>
-          </a:p>
-          <a:p>
-            <a:pPr algn="ctr">
+                <a:latin typeface="Consolas"/>
+                <a:ea typeface="Consolas"/>
+                <a:cs typeface="Consolas"/>
+              </a:rPr>
+              <a:t>SKILL.md      </a:t>
+            </a:r>
+            <a:r>
+              <a:rPr sz="790" b="0">
+                <a:solidFill>
+                  <a:srgbClr val="6B7280"/>
+                </a:solidFill>
+                <a:latin typeface="Microsoft YaHei"/>
+                <a:ea typeface="Microsoft YaHei"/>
+                <a:cs typeface="Microsoft YaHei"/>
+              </a:rPr>
+              <a:t># 选中即读:何时用 + 怎么用</a:t>
+            </a:r>
+          </a:p>
+          <a:p>
+            <a:pPr algn="l">
+              <a:spcBef>
+                <a:spcPts val="0"/>
+              </a:spcBef>
+              <a:spcAft>
+                <a:spcPts val="140"/>
+              </a:spcAft>
+            </a:pPr>
+            <a:r>
+              <a:rPr sz="830" b="0">
+                <a:solidFill>
+                  <a:srgbClr val="1F2937"/>
+                </a:solidFill>
+                <a:latin typeface="Consolas"/>
+                <a:ea typeface="Consolas"/>
+                <a:cs typeface="Consolas"/>
+              </a:rPr>
+              <a:t>best_skill.md </a:t>
+            </a:r>
+            <a:r>
+              <a:rPr sz="790" b="0">
+                <a:solidFill>
+                  <a:srgbClr val="6B7280"/>
+                </a:solidFill>
+                <a:latin typeface="Microsoft YaHei"/>
+                <a:ea typeface="Microsoft YaHei"/>
+                <a:cs typeface="Microsoft YaHei"/>
+              </a:rPr>
+              <a:t># SkillOpt 优化出的“正本”</a:t>
+            </a:r>
+          </a:p>
+          <a:p>
+            <a:pPr algn="l">
+              <a:spcBef>
+                <a:spcPts val="0"/>
+              </a:spcBef>
+              <a:spcAft>
+                <a:spcPts val="140"/>
+              </a:spcAft>
+            </a:pPr>
+            <a:r>
+              <a:rPr sz="830" b="0">
+                <a:solidFill>
+                  <a:srgbClr val="1F2937"/>
+                </a:solidFill>
+                <a:latin typeface="Consolas"/>
+                <a:ea typeface="Consolas"/>
+                <a:cs typeface="Consolas"/>
+              </a:rPr>
+              <a:t>evals/        </a:t>
+            </a:r>
+            <a:r>
+              <a:rPr sz="790" b="0">
+                <a:solidFill>
+                  <a:srgbClr val="6B7280"/>
+                </a:solidFill>
+                <a:latin typeface="Microsoft YaHei"/>
+                <a:ea typeface="Microsoft YaHei"/>
+                <a:cs typeface="Microsoft YaHei"/>
+              </a:rPr>
+              <a:t># 本技能评测:绑定哪套题 + 留出用例</a:t>
+            </a:r>
+          </a:p>
+          <a:p>
+            <a:pPr algn="l">
+              <a:spcBef>
+                <a:spcPts val="0"/>
+              </a:spcBef>
+              <a:spcAft>
+                <a:spcPts val="140"/>
+              </a:spcAft>
+            </a:pPr>
+            <a:r>
+              <a:rPr sz="830" b="0">
+                <a:solidFill>
+                  <a:srgbClr val="1F2937"/>
+                </a:solidFill>
+                <a:latin typeface="Consolas"/>
+                <a:ea typeface="Consolas"/>
+                <a:cs typeface="Consolas"/>
+              </a:rPr>
+              <a:t>candidates/   </a:t>
+            </a:r>
+            <a:r>
+              <a:rPr sz="790" b="0">
+                <a:solidFill>
+                  <a:srgbClr val="6B7280"/>
+                </a:solidFill>
+                <a:latin typeface="Microsoft YaHei"/>
+                <a:ea typeface="Microsoft YaHei"/>
+                <a:cs typeface="Microsoft YaHei"/>
+              </a:rPr>
+              <a:t># Pareto 前沿:互补候选</a:t>
+            </a:r>
+          </a:p>
+          <a:p>
+            <a:pPr algn="l">
+              <a:spcBef>
+                <a:spcPts val="0"/>
+              </a:spcBef>
+              <a:spcAft>
+                <a:spcPts val="140"/>
+              </a:spcAft>
+            </a:pPr>
+            <a:r>
+              <a:rPr sz="830" b="0">
+                <a:solidFill>
+                  <a:srgbClr val="1F2937"/>
+                </a:solidFill>
+                <a:latin typeface="Consolas"/>
+                <a:ea typeface="Consolas"/>
+                <a:cs typeface="Consolas"/>
+              </a:rPr>
+              <a:t>scorecards/   </a:t>
+            </a:r>
+            <a:r>
+              <a:rPr sz="790" b="0">
+                <a:solidFill>
+                  <a:srgbClr val="6B7280"/>
+                </a:solidFill>
+                <a:latin typeface="Microsoft YaHei"/>
+                <a:ea typeface="Microsoft YaHei"/>
+                <a:cs typeface="Microsoft YaHei"/>
+              </a:rPr>
+              <a:t># 本技能历次 A/B 跑分</a:t>
+            </a:r>
+          </a:p>
+          <a:p>
+            <a:pPr algn="l">
+              <a:spcBef>
+                <a:spcPts val="0"/>
+              </a:spcBef>
+              <a:spcAft>
+                <a:spcPts val="140"/>
+              </a:spcAft>
+            </a:pPr>
+            <a:r>
+              <a:rPr sz="830" b="0">
+                <a:solidFill>
+                  <a:srgbClr val="1F2937"/>
+                </a:solidFill>
+                <a:latin typeface="Consolas"/>
+                <a:ea typeface="Consolas"/>
+                <a:cs typeface="Consolas"/>
+              </a:rPr>
+              <a:t>references/   </a:t>
+            </a:r>
+            <a:r>
+              <a:rPr sz="790" b="0">
+                <a:solidFill>
+                  <a:srgbClr val="6B7280"/>
+                </a:solidFill>
+                <a:latin typeface="Microsoft YaHei"/>
+                <a:ea typeface="Microsoft YaHei"/>
+                <a:cs typeface="Microsoft YaHei"/>
+              </a:rPr>
+              <a:t># 重材料(按需加载)</a:t>
+            </a:r>
+          </a:p>
+        </p:txBody>
+      </p:sp>
+      <p:sp>
+        <p:nvSpPr>
+          <p:cNvPr id="16" name="TextBox 15"/>
+          <p:cNvSpPr txBox="1"/>
+          <p:nvPr/>
+        </p:nvSpPr>
+        <p:spPr>
+          <a:xfrm>
+            <a:off x="6995160" y="4809744"/>
+            <a:ext cx="4782312" cy="256032"/>
+          </a:xfrm>
+          <a:prstGeom prst="rect">
+            <a:avLst/>
+          </a:prstGeom>
+          <a:noFill/>
+        </p:spPr>
+        <p:txBody>
+          <a:bodyPr wrap="square" anchor="t" lIns="73152" rIns="73152" tIns="27432" bIns="27432">
+            <a:spAutoFit/>
+          </a:bodyPr>
+          <a:lstStyle/>
+          <a:p>
+            <a:pPr algn="l">
               <a:spcBef>
                 <a:spcPts val="0"/>
               </a:spcBef>
@@ -10767,29 +11010,29 @@
               </a:spcAft>
             </a:pPr>
             <a:r>
-              <a:rPr sz="880" b="0">
-                <a:solidFill>
-                  <a:srgbClr val="6B7280"/>
-                </a:solidFill>
-                <a:latin typeface="Microsoft YaHei"/>
-                <a:ea typeface="Microsoft YaHei"/>
-                <a:cs typeface="Microsoft YaHei"/>
-              </a:rPr>
-              <a:t>做法/流程→hub skills；事实/教训→hub knowledge；运行证据→local/</a:t>
-            </a:r>
-          </a:p>
-        </p:txBody>
-      </p:sp>
-      <p:sp>
-        <p:nvSpPr>
-          <p:cNvPr id="14" name="Rounded Rectangle 13"/>
+              <a:rPr sz="950" b="1">
+                <a:solidFill>
+                  <a:srgbClr val="0F1E3D"/>
+                </a:solidFill>
+                <a:latin typeface="Microsoft YaHei"/>
+                <a:ea typeface="Microsoft YaHei"/>
+                <a:cs typeface="Microsoft YaHei"/>
+              </a:rPr>
+              <a:t>易混淆：eval/（顶层共享题库） 与 evals/（技能内考卷）</a:t>
+            </a:r>
+          </a:p>
+        </p:txBody>
+      </p:sp>
+      <p:sp>
+        <p:nvSpPr>
+          <p:cNvPr id="17" name="Rounded Rectangle 16"/>
           <p:cNvSpPr/>
           <p:nvPr/>
         </p:nvSpPr>
         <p:spPr>
           <a:xfrm>
-            <a:off x="7452360" y="4645152"/>
-            <a:ext cx="4325112" cy="548640"/>
+            <a:off x="6995160" y="5084064"/>
+            <a:ext cx="2331720" cy="1225296"/>
           </a:xfrm>
           <a:prstGeom prst="roundRect">
             <a:avLst>
@@ -10841,7 +11084,7 @@
                 <a:ea typeface="Microsoft YaHei"/>
                 <a:cs typeface="Microsoft YaHei"/>
               </a:rPr>
-              <a:t>资产面 / 执行面分离</a:t>
+              <a:t>eval/  顶层 · 共享</a:t>
             </a:r>
           </a:p>
           <a:p>
@@ -10862,21 +11105,21 @@
                 <a:ea typeface="Microsoft YaHei"/>
                 <a:cs typeface="Microsoft YaHei"/>
               </a:rPr>
-              <a:t>hub 只读·共享·版本化；local 个人·在途</a:t>
-            </a:r>
-          </a:p>
-        </p:txBody>
-      </p:sp>
-      <p:sp>
-        <p:nvSpPr>
-          <p:cNvPr id="15" name="Rounded Rectangle 14"/>
+              <a:t>共享题库 task_suites/ + 发布评分 scorecards/</a:t>
+            </a:r>
+          </a:p>
+        </p:txBody>
+      </p:sp>
+      <p:sp>
+        <p:nvSpPr>
+          <p:cNvPr id="18" name="Rounded Rectangle 17"/>
           <p:cNvSpPr/>
           <p:nvPr/>
         </p:nvSpPr>
         <p:spPr>
           <a:xfrm>
-            <a:off x="7452360" y="5230368"/>
-            <a:ext cx="4325112" cy="548640"/>
+            <a:off x="9445752" y="5084064"/>
+            <a:ext cx="2331720" cy="1225296"/>
           </a:xfrm>
           <a:prstGeom prst="roundRect">
             <a:avLst>
@@ -10884,11 +11127,11 @@
             </a:avLst>
           </a:prstGeom>
           <a:solidFill>
-            <a:srgbClr val="FFECDC"/>
+            <a:srgbClr val="E2F7F3"/>
           </a:solidFill>
           <a:ln w="12700">
             <a:solidFill>
-              <a:srgbClr val="EA580C"/>
+              <a:srgbClr val="0D9488"/>
             </a:solidFill>
           </a:ln>
           <a:effectLst/>
@@ -10922,13 +11165,13 @@
             <a:r>
               <a:rPr sz="1100" b="1">
                 <a:solidFill>
-                  <a:srgbClr val="EA580C"/>
-                </a:solidFill>
-                <a:latin typeface="Microsoft YaHei"/>
-                <a:ea typeface="Microsoft YaHei"/>
-                <a:cs typeface="Microsoft YaHei"/>
-              </a:rPr>
-              <a:t>每条知识 = 一文件 + 稳定 ID</a:t>
+                  <a:srgbClr val="0D9488"/>
+                </a:solidFill>
+                <a:latin typeface="Microsoft YaHei"/>
+                <a:ea typeface="Microsoft YaHei"/>
+                <a:cs typeface="Microsoft YaHei"/>
+              </a:rPr>
+              <a:t>evals/  技能内 · 私有</a:t>
             </a:r>
           </a:p>
           <a:p>
@@ -10949,101 +11192,14 @@
                 <a:ea typeface="Microsoft YaHei"/>
                 <a:cs typeface="Microsoft YaHei"/>
               </a:rPr>
-              <a:t>规避 git 行级冲突，热点文件不争用</a:t>
-            </a:r>
-          </a:p>
-        </p:txBody>
-      </p:sp>
-      <p:sp>
-        <p:nvSpPr>
-          <p:cNvPr id="16" name="Rounded Rectangle 15"/>
-          <p:cNvSpPr/>
-          <p:nvPr/>
-        </p:nvSpPr>
-        <p:spPr>
-          <a:xfrm>
-            <a:off x="7452360" y="5815584"/>
-            <a:ext cx="4325112" cy="530352"/>
-          </a:xfrm>
-          <a:prstGeom prst="roundRect">
-            <a:avLst>
-              <a:gd name="adj" fmla="val 10000"/>
-            </a:avLst>
-          </a:prstGeom>
-          <a:solidFill>
-            <a:srgbClr val="DDF3E5"/>
-          </a:solidFill>
-          <a:ln w="12700">
-            <a:solidFill>
-              <a:srgbClr val="16A34A"/>
-            </a:solidFill>
-          </a:ln>
-          <a:effectLst/>
-        </p:spPr>
-        <p:style>
-          <a:lnRef idx="1">
-            <a:schemeClr val="accent1"/>
-          </a:lnRef>
-          <a:fillRef idx="3">
-            <a:schemeClr val="accent1"/>
-          </a:fillRef>
-          <a:effectRef idx="2">
-            <a:schemeClr val="accent1"/>
-          </a:effectRef>
-          <a:fontRef idx="minor">
-            <a:schemeClr val="lt1"/>
-          </a:fontRef>
-        </p:style>
-        <p:txBody>
-          <a:bodyPr rtlCol="0" anchor="t" wrap="square" lIns="73152" rIns="73152" tIns="27432" bIns="27432"/>
-          <a:lstStyle/>
-          <a:p>
-            <a:pPr algn="ctr">
-              <a:spcBef>
-                <a:spcPts val="0"/>
-              </a:spcBef>
-              <a:spcAft>
-                <a:spcPts val="300"/>
-              </a:spcAft>
-            </a:pPr>
-            <a:r>
-              <a:rPr sz="1100" b="1">
-                <a:solidFill>
-                  <a:srgbClr val="16A34A"/>
-                </a:solidFill>
-                <a:latin typeface="Microsoft YaHei"/>
-                <a:ea typeface="Microsoft YaHei"/>
-                <a:cs typeface="Microsoft YaHei"/>
-              </a:rPr>
-              <a:t>子模块锁定 + 版本锁文件</a:t>
-            </a:r>
-          </a:p>
-          <a:p>
-            <a:pPr algn="ctr">
-              <a:spcBef>
-                <a:spcPts val="0"/>
-              </a:spcBef>
-              <a:spcAft>
-                <a:spcPts val="300"/>
-              </a:spcAft>
-            </a:pPr>
-            <a:r>
-              <a:rPr sz="950" b="0">
-                <a:solidFill>
-                  <a:srgbClr val="1F2937"/>
-                </a:solidFill>
-                <a:latin typeface="Microsoft YaHei"/>
-                <a:ea typeface="Microsoft YaHei"/>
-                <a:cs typeface="Microsoft YaHei"/>
-              </a:rPr>
-              <a:t>可复现·防漂移·中央仓宕机本地兜底</a:t>
-            </a:r>
-          </a:p>
-        </p:txBody>
-      </p:sp>
-      <p:sp>
-        <p:nvSpPr>
-          <p:cNvPr id="17" name="TextBox 16"/>
+              <a:t>引用 eval_id 指向某 suite + 本技能用例/跑分</a:t>
+            </a:r>
+          </a:p>
+        </p:txBody>
+      </p:sp>
+      <p:sp>
+        <p:nvSpPr>
+          <p:cNvPr id="19" name="TextBox 18"/>
           <p:cNvSpPr txBox="1"/>
           <p:nvPr/>
         </p:nvSpPr>

</xml_diff>

<commit_message>
docs(slides): inline optimization-funnel expansion; restore right column
Per feedback, expand skills/core/optimization-funnel/ vertically inside the
left hub tree (one line per entry: SKILL.md / best_skill.md / evals/ /
candidates/ / scorecards/ / references/) instead of a separate right-side
zoom panel. The eval/ vs evals/ distinction now lives inline as cross-
referencing comments: skill-level evals/ = "技能内·私有评测"; top-level
eval/ = "顶层·团队共享评测(区别于技能内 evals/)".

Restore the right column to its prior content: .opencode/ tree + three-
archetype routing note + three layout-rationale cards. Hub tree set to 8.6pt
to fit all 33 lines; verified in-bounds and that the last line stays inside
its card.

https://claude.ai/code/session_01SfNMKzdmMz69A2VBTPNR92
</commit_message>
<xml_diff>
--- a/docs/Team_Skill_Hub_Design_Slides.pptx
+++ b/docs/Team_Skill_Hub_Design_Slides.pptx
@@ -9277,8 +9277,8 @@
         </p:nvSpPr>
         <p:spPr>
           <a:xfrm>
-            <a:off x="411480" y="1078992"/>
-            <a:ext cx="6446520" cy="5138928"/>
+            <a:off x="411480" y="1060704"/>
+            <a:ext cx="6903720" cy="5340096"/>
           </a:xfrm>
           <a:prstGeom prst="roundRect">
             <a:avLst>
@@ -9325,8 +9325,8 @@
         </p:nvSpPr>
         <p:spPr>
           <a:xfrm>
-            <a:off x="566928" y="1152144"/>
-            <a:ext cx="6217920" cy="292608"/>
+            <a:off x="566928" y="1115568"/>
+            <a:ext cx="6675120" cy="274320"/>
           </a:xfrm>
           <a:prstGeom prst="rect">
             <a:avLst/>
@@ -9348,7 +9348,7 @@
               </a:spcAft>
             </a:pPr>
             <a:r>
-              <a:rPr sz="1150" b="1">
+              <a:rPr sz="1100" b="1">
                 <a:solidFill>
                   <a:srgbClr val="4F46E5"/>
                 </a:solidFill>
@@ -9369,8 +9369,8 @@
         </p:nvSpPr>
         <p:spPr>
           <a:xfrm>
-            <a:off x="457200" y="1444752"/>
-            <a:ext cx="6400800" cy="4736592"/>
+            <a:off x="457200" y="1408176"/>
+            <a:ext cx="6858000" cy="4956048"/>
           </a:xfrm>
           <a:prstGeom prst="rect">
             <a:avLst/>
@@ -9388,11 +9388,11 @@
                 <a:spcPts val="0"/>
               </a:spcBef>
               <a:spcAft>
-                <a:spcPts val="140"/>
-              </a:spcAft>
-            </a:pPr>
-            <a:r>
-              <a:rPr sz="900" b="0">
+                <a:spcPts val="100"/>
+              </a:spcAft>
+            </a:pPr>
+            <a:r>
+              <a:rPr sz="860" b="0">
                 <a:solidFill>
                   <a:srgbClr val="1F2937"/>
                 </a:solidFill>
@@ -9403,28 +9403,28 @@
               <a:t>hm-skill-hub/                           </a:t>
             </a:r>
             <a:r>
+              <a:rPr sz="819" b="0">
+                <a:solidFill>
+                  <a:srgbClr val="6B7280"/>
+                </a:solidFill>
+                <a:latin typeface="Microsoft YaHei"/>
+                <a:ea typeface="Microsoft YaHei"/>
+                <a:cs typeface="Microsoft YaHei"/>
+              </a:rPr>
+              <a:t># 团队共享 · 版本化(semver)</a:t>
+            </a:r>
+          </a:p>
+          <a:p>
+            <a:pPr algn="l">
+              <a:spcBef>
+                <a:spcPts val="0"/>
+              </a:spcBef>
+              <a:spcAft>
+                <a:spcPts val="100"/>
+              </a:spcAft>
+            </a:pPr>
+            <a:r>
               <a:rPr sz="860" b="0">
-                <a:solidFill>
-                  <a:srgbClr val="6B7280"/>
-                </a:solidFill>
-                <a:latin typeface="Microsoft YaHei"/>
-                <a:ea typeface="Microsoft YaHei"/>
-                <a:cs typeface="Microsoft YaHei"/>
-              </a:rPr>
-              <a:t># 团队共享 · 版本化(semver)</a:t>
-            </a:r>
-          </a:p>
-          <a:p>
-            <a:pPr algn="l">
-              <a:spcBef>
-                <a:spcPts val="0"/>
-              </a:spcBef>
-              <a:spcAft>
-                <a:spcPts val="140"/>
-              </a:spcAft>
-            </a:pPr>
-            <a:r>
-              <a:rPr sz="900" b="0">
                 <a:solidFill>
                   <a:srgbClr val="1F2937"/>
                 </a:solidFill>
@@ -9435,28 +9435,28 @@
               <a:t>├─ registry.yaml                        </a:t>
             </a:r>
             <a:r>
+              <a:rPr sz="819" b="0">
+                <a:solidFill>
+                  <a:srgbClr val="6B7280"/>
+                </a:solidFill>
+                <a:latin typeface="Microsoft YaHei"/>
+                <a:ea typeface="Microsoft YaHei"/>
+                <a:cs typeface="Microsoft YaHei"/>
+              </a:rPr>
+              <a:t># 总清单:技能/版本/评测/负责人</a:t>
+            </a:r>
+          </a:p>
+          <a:p>
+            <a:pPr algn="l">
+              <a:spcBef>
+                <a:spcPts val="0"/>
+              </a:spcBef>
+              <a:spcAft>
+                <a:spcPts val="100"/>
+              </a:spcAft>
+            </a:pPr>
+            <a:r>
               <a:rPr sz="860" b="0">
-                <a:solidFill>
-                  <a:srgbClr val="6B7280"/>
-                </a:solidFill>
-                <a:latin typeface="Microsoft YaHei"/>
-                <a:ea typeface="Microsoft YaHei"/>
-                <a:cs typeface="Microsoft YaHei"/>
-              </a:rPr>
-              <a:t># 总清单:技能/版本/评测/负责人</a:t>
-            </a:r>
-          </a:p>
-          <a:p>
-            <a:pPr algn="l">
-              <a:spcBef>
-                <a:spcPts val="0"/>
-              </a:spcBef>
-              <a:spcAft>
-                <a:spcPts val="140"/>
-              </a:spcAft>
-            </a:pPr>
-            <a:r>
-              <a:rPr sz="900" b="0">
                 <a:solidFill>
                   <a:srgbClr val="1F2937"/>
                 </a:solidFill>
@@ -9467,28 +9467,28 @@
               <a:t>├─ schemas/                             </a:t>
             </a:r>
             <a:r>
+              <a:rPr sz="819" b="0">
+                <a:solidFill>
+                  <a:srgbClr val="6B7280"/>
+                </a:solidFill>
+                <a:latin typeface="Microsoft YaHei"/>
+                <a:ea typeface="Microsoft YaHei"/>
+                <a:cs typeface="Microsoft YaHei"/>
+              </a:rPr>
+              <a:t># 各类记录的格式约束(校验用)</a:t>
+            </a:r>
+          </a:p>
+          <a:p>
+            <a:pPr algn="l">
+              <a:spcBef>
+                <a:spcPts val="0"/>
+              </a:spcBef>
+              <a:spcAft>
+                <a:spcPts val="100"/>
+              </a:spcAft>
+            </a:pPr>
+            <a:r>
               <a:rPr sz="860" b="0">
-                <a:solidFill>
-                  <a:srgbClr val="6B7280"/>
-                </a:solidFill>
-                <a:latin typeface="Microsoft YaHei"/>
-                <a:ea typeface="Microsoft YaHei"/>
-                <a:cs typeface="Microsoft YaHei"/>
-              </a:rPr>
-              <a:t># 各类记录的格式约束(校验用)</a:t>
-            </a:r>
-          </a:p>
-          <a:p>
-            <a:pPr algn="l">
-              <a:spcBef>
-                <a:spcPts val="0"/>
-              </a:spcBef>
-              <a:spcAft>
-                <a:spcPts val="140"/>
-              </a:spcAft>
-            </a:pPr>
-            <a:r>
-              <a:rPr sz="900" b="0">
                 <a:solidFill>
                   <a:srgbClr val="1F2937"/>
                 </a:solidFill>
@@ -9499,28 +9499,28 @@
               <a:t>├─ skills/                              </a:t>
             </a:r>
             <a:r>
+              <a:rPr sz="819" b="0">
+                <a:solidFill>
+                  <a:srgbClr val="6B7280"/>
+                </a:solidFill>
+                <a:latin typeface="Microsoft YaHei"/>
+                <a:ea typeface="Microsoft YaHei"/>
+                <a:cs typeface="Microsoft YaHei"/>
+              </a:rPr>
+              <a:t># 技能(引擎B) · 三层结构见上一页</a:t>
+            </a:r>
+          </a:p>
+          <a:p>
+            <a:pPr algn="l">
+              <a:spcBef>
+                <a:spcPts val="0"/>
+              </a:spcBef>
+              <a:spcAft>
+                <a:spcPts val="100"/>
+              </a:spcAft>
+            </a:pPr>
+            <a:r>
               <a:rPr sz="860" b="0">
-                <a:solidFill>
-                  <a:srgbClr val="6B7280"/>
-                </a:solidFill>
-                <a:latin typeface="Microsoft YaHei"/>
-                <a:ea typeface="Microsoft YaHei"/>
-                <a:cs typeface="Microsoft YaHei"/>
-              </a:rPr>
-              <a:t># 技能(引擎B) · 三层结构见上一页</a:t>
-            </a:r>
-          </a:p>
-          <a:p>
-            <a:pPr algn="l">
-              <a:spcBef>
-                <a:spcPts val="0"/>
-              </a:spcBef>
-              <a:spcAft>
-                <a:spcPts val="140"/>
-              </a:spcAft>
-            </a:pPr>
-            <a:r>
-              <a:rPr sz="900" b="0">
                 <a:solidFill>
                   <a:srgbClr val="1F2937"/>
                 </a:solidFill>
@@ -9531,28 +9531,28 @@
               <a:t>│  ├─ core/                             </a:t>
             </a:r>
             <a:r>
+              <a:rPr sz="819" b="0">
+                <a:solidFill>
+                  <a:srgbClr val="6B7280"/>
+                </a:solidFill>
+                <a:latin typeface="Microsoft YaHei"/>
+                <a:ea typeface="Microsoft YaHei"/>
+                <a:cs typeface="Microsoft YaHei"/>
+              </a:rPr>
+              <a:t># 流程·跨切面(全子系统通用)</a:t>
+            </a:r>
+          </a:p>
+          <a:p>
+            <a:pPr algn="l">
+              <a:spcBef>
+                <a:spcPts val="0"/>
+              </a:spcBef>
+              <a:spcAft>
+                <a:spcPts val="100"/>
+              </a:spcAft>
+            </a:pPr>
+            <a:r>
               <a:rPr sz="860" b="0">
-                <a:solidFill>
-                  <a:srgbClr val="6B7280"/>
-                </a:solidFill>
-                <a:latin typeface="Microsoft YaHei"/>
-                <a:ea typeface="Microsoft YaHei"/>
-                <a:cs typeface="Microsoft YaHei"/>
-              </a:rPr>
-              <a:t># 流程·跨切面(全子系统通用)</a:t>
-            </a:r>
-          </a:p>
-          <a:p>
-            <a:pPr algn="l">
-              <a:spcBef>
-                <a:spcPts val="0"/>
-              </a:spcBef>
-              <a:spcAft>
-                <a:spcPts val="140"/>
-              </a:spcAft>
-            </a:pPr>
-            <a:r>
-              <a:rPr sz="900" b="0">
                 <a:solidFill>
                   <a:srgbClr val="1F2937"/>
                 </a:solidFill>
@@ -9563,28 +9563,28 @@
               <a:t>│  │  ├─ optimization-funnel/           </a:t>
             </a:r>
             <a:r>
+              <a:rPr sz="819" b="0">
+                <a:solidFill>
+                  <a:srgbClr val="6B7280"/>
+                </a:solidFill>
+                <a:latin typeface="Microsoft YaHei"/>
+                <a:ea typeface="Microsoft YaHei"/>
+                <a:cs typeface="Microsoft YaHei"/>
+              </a:rPr>
+              <a:t># 例:优化漏斗主流程 — 文件夹内容如下</a:t>
+            </a:r>
+          </a:p>
+          <a:p>
+            <a:pPr algn="l">
+              <a:spcBef>
+                <a:spcPts val="0"/>
+              </a:spcBef>
+              <a:spcAft>
+                <a:spcPts val="100"/>
+              </a:spcAft>
+            </a:pPr>
+            <a:r>
               <a:rPr sz="860" b="0">
-                <a:solidFill>
-                  <a:srgbClr val="6B7280"/>
-                </a:solidFill>
-                <a:latin typeface="Microsoft YaHei"/>
-                <a:ea typeface="Microsoft YaHei"/>
-                <a:cs typeface="Microsoft YaHei"/>
-              </a:rPr>
-              <a:t># 例:优化漏斗(见右侧放大)</a:t>
-            </a:r>
-          </a:p>
-          <a:p>
-            <a:pPr algn="l">
-              <a:spcBef>
-                <a:spcPts val="0"/>
-              </a:spcBef>
-              <a:spcAft>
-                <a:spcPts val="140"/>
-              </a:spcAft>
-            </a:pPr>
-            <a:r>
-              <a:rPr sz="900" b="0">
                 <a:solidFill>
                   <a:srgbClr val="1F2937"/>
                 </a:solidFill>
@@ -9592,31 +9592,31 @@
                 <a:ea typeface="Consolas"/>
                 <a:cs typeface="Consolas"/>
               </a:rPr>
-              <a:t>│  │  └─ stage-gate-enforcement/        </a:t>
-            </a:r>
+              <a:t>│  │  │   ├─ SKILL.md                   </a:t>
+            </a:r>
+            <a:r>
+              <a:rPr sz="819" b="0">
+                <a:solidFill>
+                  <a:srgbClr val="6B7280"/>
+                </a:solidFill>
+                <a:latin typeface="Microsoft YaHei"/>
+                <a:ea typeface="Microsoft YaHei"/>
+                <a:cs typeface="Microsoft YaHei"/>
+              </a:rPr>
+              <a:t># 选中即读:何时用 + 怎么用</a:t>
+            </a:r>
+          </a:p>
+          <a:p>
+            <a:pPr algn="l">
+              <a:spcBef>
+                <a:spcPts val="0"/>
+              </a:spcBef>
+              <a:spcAft>
+                <a:spcPts val="100"/>
+              </a:spcAft>
+            </a:pPr>
             <a:r>
               <a:rPr sz="860" b="0">
-                <a:solidFill>
-                  <a:srgbClr val="6B7280"/>
-                </a:solidFill>
-                <a:latin typeface="Microsoft YaHei"/>
-                <a:ea typeface="Microsoft YaHei"/>
-                <a:cs typeface="Microsoft YaHei"/>
-              </a:rPr>
-              <a:t># 例:阶段门禁强制</a:t>
-            </a:r>
-          </a:p>
-          <a:p>
-            <a:pPr algn="l">
-              <a:spcBef>
-                <a:spcPts val="0"/>
-              </a:spcBef>
-              <a:spcAft>
-                <a:spcPts val="140"/>
-              </a:spcAft>
-            </a:pPr>
-            <a:r>
-              <a:rPr sz="900" b="0">
                 <a:solidFill>
                   <a:srgbClr val="1F2937"/>
                 </a:solidFill>
@@ -9624,31 +9624,31 @@
                 <a:ea typeface="Consolas"/>
                 <a:cs typeface="Consolas"/>
               </a:rPr>
-              <a:t>│  ├─ technique/                        </a:t>
-            </a:r>
+              <a:t>│  │  │   ├─ best_skill.md              </a:t>
+            </a:r>
+            <a:r>
+              <a:rPr sz="819" b="0">
+                <a:solidFill>
+                  <a:srgbClr val="6B7280"/>
+                </a:solidFill>
+                <a:latin typeface="Microsoft YaHei"/>
+                <a:ea typeface="Microsoft YaHei"/>
+                <a:cs typeface="Microsoft YaHei"/>
+              </a:rPr>
+              <a:t># SkillOpt 优化出的“正本”</a:t>
+            </a:r>
+          </a:p>
+          <a:p>
+            <a:pPr algn="l">
+              <a:spcBef>
+                <a:spcPts val="0"/>
+              </a:spcBef>
+              <a:spcAft>
+                <a:spcPts val="100"/>
+              </a:spcAft>
+            </a:pPr>
             <a:r>
               <a:rPr sz="860" b="0">
-                <a:solidFill>
-                  <a:srgbClr val="6B7280"/>
-                </a:solidFill>
-                <a:latin typeface="Microsoft YaHei"/>
-                <a:ea typeface="Microsoft YaHei"/>
-                <a:cs typeface="Microsoft YaHei"/>
-              </a:rPr>
-              <a:t># 优化招式 · 按 mechanism 命名</a:t>
-            </a:r>
-          </a:p>
-          <a:p>
-            <a:pPr algn="l">
-              <a:spcBef>
-                <a:spcPts val="0"/>
-              </a:spcBef>
-              <a:spcAft>
-                <a:spcPts val="140"/>
-              </a:spcAft>
-            </a:pPr>
-            <a:r>
-              <a:rPr sz="900" b="0">
                 <a:solidFill>
                   <a:srgbClr val="1F2937"/>
                 </a:solidFill>
@@ -9656,31 +9656,31 @@
                 <a:ea typeface="Consolas"/>
                 <a:cs typeface="Consolas"/>
               </a:rPr>
-              <a:t>│  │  ├─ hoist-loop-invariant/          </a:t>
-            </a:r>
+              <a:t>│  │  │   ├─ evals/                     </a:t>
+            </a:r>
+            <a:r>
+              <a:rPr sz="819" b="0">
+                <a:solidFill>
+                  <a:srgbClr val="6B7280"/>
+                </a:solidFill>
+                <a:latin typeface="Microsoft YaHei"/>
+                <a:ea typeface="Microsoft YaHei"/>
+                <a:cs typeface="Microsoft YaHei"/>
+              </a:rPr>
+              <a:t># 技能内·私有评测:用哪套题 + 留出用例</a:t>
+            </a:r>
+          </a:p>
+          <a:p>
+            <a:pPr algn="l">
+              <a:spcBef>
+                <a:spcPts val="0"/>
+              </a:spcBef>
+              <a:spcAft>
+                <a:spcPts val="100"/>
+              </a:spcAft>
+            </a:pPr>
             <a:r>
               <a:rPr sz="860" b="0">
-                <a:solidFill>
-                  <a:srgbClr val="6B7280"/>
-                </a:solidFill>
-                <a:latin typeface="Microsoft YaHei"/>
-                <a:ea typeface="Microsoft YaHei"/>
-                <a:cs typeface="Microsoft YaHei"/>
-              </a:rPr>
-              <a:t># 例:循环不变量外提</a:t>
-            </a:r>
-          </a:p>
-          <a:p>
-            <a:pPr algn="l">
-              <a:spcBef>
-                <a:spcPts val="0"/>
-              </a:spcBef>
-              <a:spcAft>
-                <a:spcPts val="140"/>
-              </a:spcAft>
-            </a:pPr>
-            <a:r>
-              <a:rPr sz="900" b="0">
                 <a:solidFill>
                   <a:srgbClr val="1F2937"/>
                 </a:solidFill>
@@ -9688,31 +9688,31 @@
                 <a:ea typeface="Consolas"/>
                 <a:cs typeface="Consolas"/>
               </a:rPr>
-              <a:t>│  │  └─ batch-coalescing/              </a:t>
-            </a:r>
+              <a:t>│  │  │   ├─ candidates/                </a:t>
+            </a:r>
+            <a:r>
+              <a:rPr sz="819" b="0">
+                <a:solidFill>
+                  <a:srgbClr val="6B7280"/>
+                </a:solidFill>
+                <a:latin typeface="Microsoft YaHei"/>
+                <a:ea typeface="Microsoft YaHei"/>
+                <a:cs typeface="Microsoft YaHei"/>
+              </a:rPr>
+              <a:t># Pareto 前沿:互补候选</a:t>
+            </a:r>
+          </a:p>
+          <a:p>
+            <a:pPr algn="l">
+              <a:spcBef>
+                <a:spcPts val="0"/>
+              </a:spcBef>
+              <a:spcAft>
+                <a:spcPts val="100"/>
+              </a:spcAft>
+            </a:pPr>
             <a:r>
               <a:rPr sz="860" b="0">
-                <a:solidFill>
-                  <a:srgbClr val="6B7280"/>
-                </a:solidFill>
-                <a:latin typeface="Microsoft YaHei"/>
-                <a:ea typeface="Microsoft YaHei"/>
-                <a:cs typeface="Microsoft YaHei"/>
-              </a:rPr>
-              <a:t># 例:批量合并写</a:t>
-            </a:r>
-          </a:p>
-          <a:p>
-            <a:pPr algn="l">
-              <a:spcBef>
-                <a:spcPts val="0"/>
-              </a:spcBef>
-              <a:spcAft>
-                <a:spcPts val="140"/>
-              </a:spcAft>
-            </a:pPr>
-            <a:r>
-              <a:rPr sz="900" b="0">
                 <a:solidFill>
                   <a:srgbClr val="1F2937"/>
                 </a:solidFill>
@@ -9720,31 +9720,31 @@
                 <a:ea typeface="Consolas"/>
                 <a:cs typeface="Consolas"/>
               </a:rPr>
-              <a:t>│  ├─ domain/                           </a:t>
-            </a:r>
+              <a:t>│  │  │   ├─ scorecards/                </a:t>
+            </a:r>
+            <a:r>
+              <a:rPr sz="819" b="0">
+                <a:solidFill>
+                  <a:srgbClr val="6B7280"/>
+                </a:solidFill>
+                <a:latin typeface="Microsoft YaHei"/>
+                <a:ea typeface="Microsoft YaHei"/>
+                <a:cs typeface="Microsoft YaHei"/>
+              </a:rPr>
+              <a:t># 本技能历次 A/B 跑分</a:t>
+            </a:r>
+          </a:p>
+          <a:p>
+            <a:pPr algn="l">
+              <a:spcBef>
+                <a:spcPts val="0"/>
+              </a:spcBef>
+              <a:spcAft>
+                <a:spcPts val="100"/>
+              </a:spcAft>
+            </a:pPr>
             <a:r>
               <a:rPr sz="860" b="0">
-                <a:solidFill>
-                  <a:srgbClr val="6B7280"/>
-                </a:solidFill>
-                <a:latin typeface="Microsoft YaHei"/>
-                <a:ea typeface="Microsoft YaHei"/>
-                <a:cs typeface="Microsoft YaHei"/>
-              </a:rPr>
-              <a:t># 按子系统(唯一触及代码结构)</a:t>
-            </a:r>
-          </a:p>
-          <a:p>
-            <a:pPr algn="l">
-              <a:spcBef>
-                <a:spcPts val="0"/>
-              </a:spcBef>
-              <a:spcAft>
-                <a:spcPts val="140"/>
-              </a:spcAft>
-            </a:pPr>
-            <a:r>
-              <a:rPr sz="900" b="0">
                 <a:solidFill>
                   <a:srgbClr val="1F2937"/>
                 </a:solidFill>
@@ -9752,31 +9752,31 @@
                 <a:ea typeface="Consolas"/>
                 <a:cs typeface="Consolas"/>
               </a:rPr>
-              <a:t>│  │  ├─ mm-reclaim/                    </a:t>
-            </a:r>
+              <a:t>│  │  │   └─ references/                </a:t>
+            </a:r>
+            <a:r>
+              <a:rPr sz="819" b="0">
+                <a:solidFill>
+                  <a:srgbClr val="6B7280"/>
+                </a:solidFill>
+                <a:latin typeface="Microsoft YaHei"/>
+                <a:ea typeface="Microsoft YaHei"/>
+                <a:cs typeface="Microsoft YaHei"/>
+              </a:rPr>
+              <a:t># 重材料(按需加载)</a:t>
+            </a:r>
+          </a:p>
+          <a:p>
+            <a:pPr algn="l">
+              <a:spcBef>
+                <a:spcPts val="0"/>
+              </a:spcBef>
+              <a:spcAft>
+                <a:spcPts val="100"/>
+              </a:spcAft>
+            </a:pPr>
             <a:r>
               <a:rPr sz="860" b="0">
-                <a:solidFill>
-                  <a:srgbClr val="6B7280"/>
-                </a:solidFill>
-                <a:latin typeface="Microsoft YaHei"/>
-                <a:ea typeface="Microsoft YaHei"/>
-                <a:cs typeface="Microsoft YaHei"/>
-              </a:rPr>
-              <a:t># 例:内存回收(含 references/)</a:t>
-            </a:r>
-          </a:p>
-          <a:p>
-            <a:pPr algn="l">
-              <a:spcBef>
-                <a:spcPts val="0"/>
-              </a:spcBef>
-              <a:spcAft>
-                <a:spcPts val="140"/>
-              </a:spcAft>
-            </a:pPr>
-            <a:r>
-              <a:rPr sz="900" b="0">
                 <a:solidFill>
                   <a:srgbClr val="1F2937"/>
                 </a:solidFill>
@@ -9784,31 +9784,31 @@
                 <a:ea typeface="Consolas"/>
                 <a:cs typeface="Consolas"/>
               </a:rPr>
-              <a:t>│  │  └─ hyperhold-io/                  </a:t>
-            </a:r>
+              <a:t>│  │  └─ stage-gate-enforcement/        </a:t>
+            </a:r>
+            <a:r>
+              <a:rPr sz="819" b="0">
+                <a:solidFill>
+                  <a:srgbClr val="6B7280"/>
+                </a:solidFill>
+                <a:latin typeface="Microsoft YaHei"/>
+                <a:ea typeface="Microsoft YaHei"/>
+                <a:cs typeface="Microsoft YaHei"/>
+              </a:rPr>
+              <a:t># 例:阶段门禁强制</a:t>
+            </a:r>
+          </a:p>
+          <a:p>
+            <a:pPr algn="l">
+              <a:spcBef>
+                <a:spcPts val="0"/>
+              </a:spcBef>
+              <a:spcAft>
+                <a:spcPts val="100"/>
+              </a:spcAft>
+            </a:pPr>
             <a:r>
               <a:rPr sz="860" b="0">
-                <a:solidFill>
-                  <a:srgbClr val="6B7280"/>
-                </a:solidFill>
-                <a:latin typeface="Microsoft YaHei"/>
-                <a:ea typeface="Microsoft YaHei"/>
-                <a:cs typeface="Microsoft YaHei"/>
-              </a:rPr>
-              <a:t># 例:hyperhold I/O 路径</a:t>
-            </a:r>
-          </a:p>
-          <a:p>
-            <a:pPr algn="l">
-              <a:spcBef>
-                <a:spcPts val="0"/>
-              </a:spcBef>
-              <a:spcAft>
-                <a:spcPts val="140"/>
-              </a:spcAft>
-            </a:pPr>
-            <a:r>
-              <a:rPr sz="900" b="0">
                 <a:solidFill>
                   <a:srgbClr val="1F2937"/>
                 </a:solidFill>
@@ -9816,31 +9816,31 @@
                 <a:ea typeface="Consolas"/>
                 <a:cs typeface="Consolas"/>
               </a:rPr>
-              <a:t>│  └─ _registry/skills.yaml             </a:t>
-            </a:r>
+              <a:t>│  ├─ technique/                        </a:t>
+            </a:r>
+            <a:r>
+              <a:rPr sz="819" b="0">
+                <a:solidFill>
+                  <a:srgbClr val="6B7280"/>
+                </a:solidFill>
+                <a:latin typeface="Microsoft YaHei"/>
+                <a:ea typeface="Microsoft YaHei"/>
+                <a:cs typeface="Microsoft YaHei"/>
+              </a:rPr>
+              <a:t># 优化招式 · 按 mechanism 命名</a:t>
+            </a:r>
+          </a:p>
+          <a:p>
+            <a:pPr algn="l">
+              <a:spcBef>
+                <a:spcPts val="0"/>
+              </a:spcBef>
+              <a:spcAft>
+                <a:spcPts val="100"/>
+              </a:spcAft>
+            </a:pPr>
             <a:r>
               <a:rPr sz="860" b="0">
-                <a:solidFill>
-                  <a:srgbClr val="6B7280"/>
-                </a:solidFill>
-                <a:latin typeface="Microsoft YaHei"/>
-                <a:ea typeface="Microsoft YaHei"/>
-                <a:cs typeface="Microsoft YaHei"/>
-              </a:rPr>
-              <a:t># 全量索引 + 子系统选择器</a:t>
-            </a:r>
-          </a:p>
-          <a:p>
-            <a:pPr algn="l">
-              <a:spcBef>
-                <a:spcPts val="0"/>
-              </a:spcBef>
-              <a:spcAft>
-                <a:spcPts val="140"/>
-              </a:spcAft>
-            </a:pPr>
-            <a:r>
-              <a:rPr sz="900" b="0">
                 <a:solidFill>
                   <a:srgbClr val="1F2937"/>
                 </a:solidFill>
@@ -9848,31 +9848,31 @@
                 <a:ea typeface="Consolas"/>
                 <a:cs typeface="Consolas"/>
               </a:rPr>
-              <a:t>├─ knowledge/                           </a:t>
-            </a:r>
+              <a:t>│  │  ├─ hoist-loop-invariant/          </a:t>
+            </a:r>
+            <a:r>
+              <a:rPr sz="819" b="0">
+                <a:solidFill>
+                  <a:srgbClr val="6B7280"/>
+                </a:solidFill>
+                <a:latin typeface="Microsoft YaHei"/>
+                <a:ea typeface="Microsoft YaHei"/>
+                <a:cs typeface="Microsoft YaHei"/>
+              </a:rPr>
+              <a:t># 例:循环不变量外提</a:t>
+            </a:r>
+          </a:p>
+          <a:p>
+            <a:pPr algn="l">
+              <a:spcBef>
+                <a:spcPts val="0"/>
+              </a:spcBef>
+              <a:spcAft>
+                <a:spcPts val="100"/>
+              </a:spcAft>
+            </a:pPr>
             <a:r>
               <a:rPr sz="860" b="0">
-                <a:solidFill>
-                  <a:srgbClr val="6B7280"/>
-                </a:solidFill>
-                <a:latin typeface="Microsoft YaHei"/>
-                <a:ea typeface="Microsoft YaHei"/>
-                <a:cs typeface="Microsoft YaHei"/>
-              </a:rPr>
-              <a:t># 知识(引擎A·分层·每条一文件)</a:t>
-            </a:r>
-          </a:p>
-          <a:p>
-            <a:pPr algn="l">
-              <a:spcBef>
-                <a:spcPts val="0"/>
-              </a:spcBef>
-              <a:spcAft>
-                <a:spcPts val="140"/>
-              </a:spcAft>
-            </a:pPr>
-            <a:r>
-              <a:rPr sz="900" b="0">
                 <a:solidFill>
                   <a:srgbClr val="1F2937"/>
                 </a:solidFill>
@@ -9880,31 +9880,31 @@
                 <a:ea typeface="Consolas"/>
                 <a:cs typeface="Consolas"/>
               </a:rPr>
-              <a:t>│  ├─ global/                           </a:t>
-            </a:r>
+              <a:t>│  │  └─ batch-coalescing/              </a:t>
+            </a:r>
+            <a:r>
+              <a:rPr sz="819" b="0">
+                <a:solidFill>
+                  <a:srgbClr val="6B7280"/>
+                </a:solidFill>
+                <a:latin typeface="Microsoft YaHei"/>
+                <a:ea typeface="Microsoft YaHei"/>
+                <a:cs typeface="Microsoft YaHei"/>
+              </a:rPr>
+              <a:t># 例:批量合并写</a:t>
+            </a:r>
+          </a:p>
+          <a:p>
+            <a:pPr algn="l">
+              <a:spcBef>
+                <a:spcPts val="0"/>
+              </a:spcBef>
+              <a:spcAft>
+                <a:spcPts val="100"/>
+              </a:spcAft>
+            </a:pPr>
             <a:r>
               <a:rPr sz="860" b="0">
-                <a:solidFill>
-                  <a:srgbClr val="6B7280"/>
-                </a:solidFill>
-                <a:latin typeface="Microsoft YaHei"/>
-                <a:ea typeface="Microsoft YaHei"/>
-                <a:cs typeface="Microsoft YaHei"/>
-              </a:rPr>
-              <a:t># 全局教训 / 反模式</a:t>
-            </a:r>
-          </a:p>
-          <a:p>
-            <a:pPr algn="l">
-              <a:spcBef>
-                <a:spcPts val="0"/>
-              </a:spcBef>
-              <a:spcAft>
-                <a:spcPts val="140"/>
-              </a:spcAft>
-            </a:pPr>
-            <a:r>
-              <a:rPr sz="900" b="0">
                 <a:solidFill>
                   <a:srgbClr val="1F2937"/>
                 </a:solidFill>
@@ -9912,31 +9912,31 @@
                 <a:ea typeface="Consolas"/>
                 <a:cs typeface="Consolas"/>
               </a:rPr>
-              <a:t>│  │  ├─ lessons/                       </a:t>
-            </a:r>
+              <a:t>│  ├─ domain/                           </a:t>
+            </a:r>
+            <a:r>
+              <a:rPr sz="819" b="0">
+                <a:solidFill>
+                  <a:srgbClr val="6B7280"/>
+                </a:solidFill>
+                <a:latin typeface="Microsoft YaHei"/>
+                <a:ea typeface="Microsoft YaHei"/>
+                <a:cs typeface="Microsoft YaHei"/>
+              </a:rPr>
+              <a:t># 按子系统(唯一触及代码结构)</a:t>
+            </a:r>
+          </a:p>
+          <a:p>
+            <a:pPr algn="l">
+              <a:spcBef>
+                <a:spcPts val="0"/>
+              </a:spcBef>
+              <a:spcAft>
+                <a:spcPts val="100"/>
+              </a:spcAft>
+            </a:pPr>
             <a:r>
               <a:rPr sz="860" b="0">
-                <a:solidFill>
-                  <a:srgbClr val="6B7280"/>
-                </a:solidFill>
-                <a:latin typeface="Microsoft YaHei"/>
-                <a:ea typeface="Microsoft YaHei"/>
-                <a:cs typeface="Microsoft YaHei"/>
-              </a:rPr>
-              <a:t># 例:G012_reclaim-twice.md</a:t>
-            </a:r>
-          </a:p>
-          <a:p>
-            <a:pPr algn="l">
-              <a:spcBef>
-                <a:spcPts val="0"/>
-              </a:spcBef>
-              <a:spcAft>
-                <a:spcPts val="140"/>
-              </a:spcAft>
-            </a:pPr>
-            <a:r>
-              <a:rPr sz="900" b="0">
                 <a:solidFill>
                   <a:srgbClr val="1F2937"/>
                 </a:solidFill>
@@ -9944,31 +9944,31 @@
                 <a:ea typeface="Consolas"/>
                 <a:cs typeface="Consolas"/>
               </a:rPr>
-              <a:t>│  │  └─ anti_patterns/                 </a:t>
-            </a:r>
+              <a:t>│  │  ├─ mm-reclaim/                    </a:t>
+            </a:r>
+            <a:r>
+              <a:rPr sz="819" b="0">
+                <a:solidFill>
+                  <a:srgbClr val="6B7280"/>
+                </a:solidFill>
+                <a:latin typeface="Microsoft YaHei"/>
+                <a:ea typeface="Microsoft YaHei"/>
+                <a:cs typeface="Microsoft YaHei"/>
+              </a:rPr>
+              <a:t># 例:内存回收(含 references/)</a:t>
+            </a:r>
+          </a:p>
+          <a:p>
+            <a:pPr algn="l">
+              <a:spcBef>
+                <a:spcPts val="0"/>
+              </a:spcBef>
+              <a:spcAft>
+                <a:spcPts val="100"/>
+              </a:spcAft>
+            </a:pPr>
             <a:r>
               <a:rPr sz="860" b="0">
-                <a:solidFill>
-                  <a:srgbClr val="6B7280"/>
-                </a:solidFill>
-                <a:latin typeface="Microsoft YaHei"/>
-                <a:ea typeface="Microsoft YaHei"/>
-                <a:cs typeface="Microsoft YaHei"/>
-              </a:rPr>
-              <a:t># 例:A007_busy-wait.md</a:t>
-            </a:r>
-          </a:p>
-          <a:p>
-            <a:pPr algn="l">
-              <a:spcBef>
-                <a:spcPts val="0"/>
-              </a:spcBef>
-              <a:spcAft>
-                <a:spcPts val="140"/>
-              </a:spcAft>
-            </a:pPr>
-            <a:r>
-              <a:rPr sz="900" b="0">
                 <a:solidFill>
                   <a:srgbClr val="1F2937"/>
                 </a:solidFill>
@@ -9976,7 +9976,18 @@
                 <a:ea typeface="Consolas"/>
                 <a:cs typeface="Consolas"/>
               </a:rPr>
-              <a:t>│  ├─ subsystems/&lt;s&gt;.md  ·  targets/&lt;slug&gt;/{facts,decisions,idea_ledger}</a:t>
+              <a:t>│  │  └─ hyperhold-io/                  </a:t>
+            </a:r>
+            <a:r>
+              <a:rPr sz="819" b="0">
+                <a:solidFill>
+                  <a:srgbClr val="6B7280"/>
+                </a:solidFill>
+                <a:latin typeface="Microsoft YaHei"/>
+                <a:ea typeface="Microsoft YaHei"/>
+                <a:cs typeface="Microsoft YaHei"/>
+              </a:rPr>
+              <a:t># 例:hyperhold I/O 路径</a:t>
             </a:r>
           </a:p>
           <a:p>
@@ -9985,11 +9996,11 @@
                 <a:spcPts val="0"/>
               </a:spcBef>
               <a:spcAft>
-                <a:spcPts val="140"/>
-              </a:spcAft>
-            </a:pPr>
-            <a:r>
-              <a:rPr sz="900" b="0">
+                <a:spcPts val="100"/>
+              </a:spcAft>
+            </a:pPr>
+            <a:r>
+              <a:rPr sz="860" b="0">
                 <a:solidFill>
                   <a:srgbClr val="1F2937"/>
                 </a:solidFill>
@@ -9997,31 +10008,31 @@
                 <a:ea typeface="Consolas"/>
                 <a:cs typeface="Consolas"/>
               </a:rPr>
-              <a:t>│  └─ index/                            </a:t>
-            </a:r>
+              <a:t>│  └─ _registry/skills.yaml             </a:t>
+            </a:r>
+            <a:r>
+              <a:rPr sz="819" b="0">
+                <a:solidFill>
+                  <a:srgbClr val="6B7280"/>
+                </a:solidFill>
+                <a:latin typeface="Microsoft YaHei"/>
+                <a:ea typeface="Microsoft YaHei"/>
+                <a:cs typeface="Microsoft YaHei"/>
+              </a:rPr>
+              <a:t># 全量索引 + 子系统选择器</a:t>
+            </a:r>
+          </a:p>
+          <a:p>
+            <a:pPr algn="l">
+              <a:spcBef>
+                <a:spcPts val="0"/>
+              </a:spcBef>
+              <a:spcAft>
+                <a:spcPts val="100"/>
+              </a:spcAft>
+            </a:pPr>
             <a:r>
               <a:rPr sz="860" b="0">
-                <a:solidFill>
-                  <a:srgbClr val="6B7280"/>
-                </a:solidFill>
-                <a:latin typeface="Microsoft YaHei"/>
-                <a:ea typeface="Microsoft YaHei"/>
-                <a:cs typeface="Microsoft YaHei"/>
-              </a:rPr>
-              <a:t># 向量检索索引</a:t>
-            </a:r>
-          </a:p>
-          <a:p>
-            <a:pPr algn="l">
-              <a:spcBef>
-                <a:spcPts val="0"/>
-              </a:spcBef>
-              <a:spcAft>
-                <a:spcPts val="140"/>
-              </a:spcAft>
-            </a:pPr>
-            <a:r>
-              <a:rPr sz="900" b="0">
                 <a:solidFill>
                   <a:srgbClr val="1F2937"/>
                 </a:solidFill>
@@ -10029,31 +10040,31 @@
                 <a:ea typeface="Consolas"/>
                 <a:cs typeface="Consolas"/>
               </a:rPr>
-              <a:t>├─ evidence/                            </a:t>
-            </a:r>
+              <a:t>├─ knowledge/                           </a:t>
+            </a:r>
+            <a:r>
+              <a:rPr sz="819" b="0">
+                <a:solidFill>
+                  <a:srgbClr val="6B7280"/>
+                </a:solidFill>
+                <a:latin typeface="Microsoft YaHei"/>
+                <a:ea typeface="Microsoft YaHei"/>
+                <a:cs typeface="Microsoft YaHei"/>
+              </a:rPr>
+              <a:t># 知识(引擎A·分层·每条一文件)</a:t>
+            </a:r>
+          </a:p>
+          <a:p>
+            <a:pPr algn="l">
+              <a:spcBef>
+                <a:spcPts val="0"/>
+              </a:spcBef>
+              <a:spcAft>
+                <a:spcPts val="100"/>
+              </a:spcAft>
+            </a:pPr>
             <a:r>
               <a:rPr sz="860" b="0">
-                <a:solidFill>
-                  <a:srgbClr val="6B7280"/>
-                </a:solidFill>
-                <a:latin typeface="Microsoft YaHei"/>
-                <a:ea typeface="Microsoft YaHei"/>
-                <a:cs typeface="Microsoft YaHei"/>
-              </a:rPr>
-              <a:t># 可复核证据(每条回链来源)</a:t>
-            </a:r>
-          </a:p>
-          <a:p>
-            <a:pPr algn="l">
-              <a:spcBef>
-                <a:spcPts val="0"/>
-              </a:spcBef>
-              <a:spcAft>
-                <a:spcPts val="140"/>
-              </a:spcAft>
-            </a:pPr>
-            <a:r>
-              <a:rPr sz="900" b="0">
                 <a:solidFill>
                   <a:srgbClr val="1F2937"/>
                 </a:solidFill>
@@ -10061,31 +10072,31 @@
                 <a:ea typeface="Consolas"/>
                 <a:cs typeface="Consolas"/>
               </a:rPr>
-              <a:t>│  ├─ benchmarks/                       </a:t>
-            </a:r>
+              <a:t>│  ├─ global/                           </a:t>
+            </a:r>
+            <a:r>
+              <a:rPr sz="819" b="0">
+                <a:solidFill>
+                  <a:srgbClr val="6B7280"/>
+                </a:solidFill>
+                <a:latin typeface="Microsoft YaHei"/>
+                <a:ea typeface="Microsoft YaHei"/>
+                <a:cs typeface="Microsoft YaHei"/>
+              </a:rPr>
+              <a:t># 全局教训 / 反模式</a:t>
+            </a:r>
+          </a:p>
+          <a:p>
+            <a:pPr algn="l">
+              <a:spcBef>
+                <a:spcPts val="0"/>
+              </a:spcBef>
+              <a:spcAft>
+                <a:spcPts val="100"/>
+              </a:spcAft>
+            </a:pPr>
             <a:r>
               <a:rPr sz="860" b="0">
-                <a:solidFill>
-                  <a:srgbClr val="6B7280"/>
-                </a:solidFill>
-                <a:latin typeface="Microsoft YaHei"/>
-                <a:ea typeface="Microsoft YaHei"/>
-                <a:cs typeface="Microsoft YaHei"/>
-              </a:rPr>
-              <a:t># 例:mm-reclaim_2026Q2.json</a:t>
-            </a:r>
-          </a:p>
-          <a:p>
-            <a:pPr algn="l">
-              <a:spcBef>
-                <a:spcPts val="0"/>
-              </a:spcBef>
-              <a:spcAft>
-                <a:spcPts val="140"/>
-              </a:spcAft>
-            </a:pPr>
-            <a:r>
-              <a:rPr sz="900" b="0">
                 <a:solidFill>
                   <a:srgbClr val="1F2937"/>
                 </a:solidFill>
@@ -10093,31 +10104,31 @@
                 <a:ea typeface="Consolas"/>
                 <a:cs typeface="Consolas"/>
               </a:rPr>
-              <a:t>│  └─ regressions/                      </a:t>
-            </a:r>
+              <a:t>│  │  ├─ lessons/                       </a:t>
+            </a:r>
+            <a:r>
+              <a:rPr sz="819" b="0">
+                <a:solidFill>
+                  <a:srgbClr val="6B7280"/>
+                </a:solidFill>
+                <a:latin typeface="Microsoft YaHei"/>
+                <a:ea typeface="Microsoft YaHei"/>
+                <a:cs typeface="Microsoft YaHei"/>
+              </a:rPr>
+              <a:t># 例:G012_reclaim-twice.md</a:t>
+            </a:r>
+          </a:p>
+          <a:p>
+            <a:pPr algn="l">
+              <a:spcBef>
+                <a:spcPts val="0"/>
+              </a:spcBef>
+              <a:spcAft>
+                <a:spcPts val="100"/>
+              </a:spcAft>
+            </a:pPr>
             <a:r>
               <a:rPr sz="860" b="0">
-                <a:solidFill>
-                  <a:srgbClr val="6B7280"/>
-                </a:solidFill>
-                <a:latin typeface="Microsoft YaHei"/>
-                <a:ea typeface="Microsoft YaHei"/>
-                <a:cs typeface="Microsoft YaHei"/>
-              </a:rPr>
-              <a:t># 例:R031_shrink_node.json</a:t>
-            </a:r>
-          </a:p>
-          <a:p>
-            <a:pPr algn="l">
-              <a:spcBef>
-                <a:spcPts val="0"/>
-              </a:spcBef>
-              <a:spcAft>
-                <a:spcPts val="140"/>
-              </a:spcAft>
-            </a:pPr>
-            <a:r>
-              <a:rPr sz="900" b="0">
                 <a:solidFill>
                   <a:srgbClr val="1F2937"/>
                 </a:solidFill>
@@ -10125,31 +10136,31 @@
                 <a:ea typeface="Consolas"/>
                 <a:cs typeface="Consolas"/>
               </a:rPr>
-              <a:t>├─ eval/                                </a:t>
-            </a:r>
+              <a:t>│  │  └─ anti_patterns/                 </a:t>
+            </a:r>
+            <a:r>
+              <a:rPr sz="819" b="0">
+                <a:solidFill>
+                  <a:srgbClr val="6B7280"/>
+                </a:solidFill>
+                <a:latin typeface="Microsoft YaHei"/>
+                <a:ea typeface="Microsoft YaHei"/>
+                <a:cs typeface="Microsoft YaHei"/>
+              </a:rPr>
+              <a:t># 例:A007_busy-wait.md</a:t>
+            </a:r>
+          </a:p>
+          <a:p>
+            <a:pPr algn="l">
+              <a:spcBef>
+                <a:spcPts val="0"/>
+              </a:spcBef>
+              <a:spcAft>
+                <a:spcPts val="100"/>
+              </a:spcAft>
+            </a:pPr>
             <a:r>
               <a:rPr sz="860" b="0">
-                <a:solidFill>
-                  <a:srgbClr val="6B7280"/>
-                </a:solidFill>
-                <a:latin typeface="Microsoft YaHei"/>
-                <a:ea typeface="Microsoft YaHei"/>
-                <a:cs typeface="Microsoft YaHei"/>
-              </a:rPr>
-              <a:t># 顶层评测资产·团队共享(见右下)</a:t>
-            </a:r>
-          </a:p>
-          <a:p>
-            <a:pPr algn="l">
-              <a:spcBef>
-                <a:spcPts val="0"/>
-              </a:spcBef>
-              <a:spcAft>
-                <a:spcPts val="140"/>
-              </a:spcAft>
-            </a:pPr>
-            <a:r>
-              <a:rPr sz="900" b="0">
                 <a:solidFill>
                   <a:srgbClr val="1F2937"/>
                 </a:solidFill>
@@ -10157,31 +10168,20 @@
                 <a:ea typeface="Consolas"/>
                 <a:cs typeface="Consolas"/>
               </a:rPr>
-              <a:t>│  ├─ task_suites/                      </a:t>
-            </a:r>
+              <a:t>│  ├─ subsystems/&lt;s&gt;.md  ·  targets/&lt;slug&gt;/{facts,decisions,idea_ledger}</a:t>
+            </a:r>
+          </a:p>
+          <a:p>
+            <a:pPr algn="l">
+              <a:spcBef>
+                <a:spcPts val="0"/>
+              </a:spcBef>
+              <a:spcAft>
+                <a:spcPts val="100"/>
+              </a:spcAft>
+            </a:pPr>
             <a:r>
               <a:rPr sz="860" b="0">
-                <a:solidFill>
-                  <a:srgbClr val="6B7280"/>
-                </a:solidFill>
-                <a:latin typeface="Microsoft YaHei"/>
-                <a:ea typeface="Microsoft YaHei"/>
-                <a:cs typeface="Microsoft YaHei"/>
-              </a:rPr>
-              <a:t># 可复用任务集 例:mm_reclaim_suite/</a:t>
-            </a:r>
-          </a:p>
-          <a:p>
-            <a:pPr algn="l">
-              <a:spcBef>
-                <a:spcPts val="0"/>
-              </a:spcBef>
-              <a:spcAft>
-                <a:spcPts val="140"/>
-              </a:spcAft>
-            </a:pPr>
-            <a:r>
-              <a:rPr sz="900" b="0">
                 <a:solidFill>
                   <a:srgbClr val="1F2937"/>
                 </a:solidFill>
@@ -10189,31 +10189,31 @@
                 <a:ea typeface="Consolas"/>
                 <a:cs typeface="Consolas"/>
               </a:rPr>
-              <a:t>│  └─ scorecards/                       </a:t>
-            </a:r>
+              <a:t>│  └─ index/                            </a:t>
+            </a:r>
+            <a:r>
+              <a:rPr sz="819" b="0">
+                <a:solidFill>
+                  <a:srgbClr val="6B7280"/>
+                </a:solidFill>
+                <a:latin typeface="Microsoft YaHei"/>
+                <a:ea typeface="Microsoft YaHei"/>
+                <a:cs typeface="Microsoft YaHei"/>
+              </a:rPr>
+              <a:t># 向量检索索引</a:t>
+            </a:r>
+          </a:p>
+          <a:p>
+            <a:pPr algn="l">
+              <a:spcBef>
+                <a:spcPts val="0"/>
+              </a:spcBef>
+              <a:spcAft>
+                <a:spcPts val="100"/>
+              </a:spcAft>
+            </a:pPr>
             <a:r>
               <a:rPr sz="860" b="0">
-                <a:solidFill>
-                  <a:srgbClr val="6B7280"/>
-                </a:solidFill>
-                <a:latin typeface="Microsoft YaHei"/>
-                <a:ea typeface="Microsoft YaHei"/>
-                <a:cs typeface="Microsoft YaHei"/>
-              </a:rPr>
-              <a:t># 发布级评分 例:funnel_v3_*.md</a:t>
-            </a:r>
-          </a:p>
-          <a:p>
-            <a:pPr algn="l">
-              <a:spcBef>
-                <a:spcPts val="0"/>
-              </a:spcBef>
-              <a:spcAft>
-                <a:spcPts val="140"/>
-              </a:spcAft>
-            </a:pPr>
-            <a:r>
-              <a:rPr sz="900" b="0">
                 <a:solidFill>
                   <a:srgbClr val="1F2937"/>
                 </a:solidFill>
@@ -10221,10 +10221,202 @@
                 <a:ea typeface="Consolas"/>
                 <a:cs typeface="Consolas"/>
               </a:rPr>
+              <a:t>├─ evidence/                            </a:t>
+            </a:r>
+            <a:r>
+              <a:rPr sz="819" b="0">
+                <a:solidFill>
+                  <a:srgbClr val="6B7280"/>
+                </a:solidFill>
+                <a:latin typeface="Microsoft YaHei"/>
+                <a:ea typeface="Microsoft YaHei"/>
+                <a:cs typeface="Microsoft YaHei"/>
+              </a:rPr>
+              <a:t># 可复核证据(每条回链来源)</a:t>
+            </a:r>
+          </a:p>
+          <a:p>
+            <a:pPr algn="l">
+              <a:spcBef>
+                <a:spcPts val="0"/>
+              </a:spcBef>
+              <a:spcAft>
+                <a:spcPts val="100"/>
+              </a:spcAft>
+            </a:pPr>
+            <a:r>
+              <a:rPr sz="860" b="0">
+                <a:solidFill>
+                  <a:srgbClr val="1F2937"/>
+                </a:solidFill>
+                <a:latin typeface="Consolas"/>
+                <a:ea typeface="Consolas"/>
+                <a:cs typeface="Consolas"/>
+              </a:rPr>
+              <a:t>│  ├─ benchmarks/                       </a:t>
+            </a:r>
+            <a:r>
+              <a:rPr sz="819" b="0">
+                <a:solidFill>
+                  <a:srgbClr val="6B7280"/>
+                </a:solidFill>
+                <a:latin typeface="Microsoft YaHei"/>
+                <a:ea typeface="Microsoft YaHei"/>
+                <a:cs typeface="Microsoft YaHei"/>
+              </a:rPr>
+              <a:t># 例:mm-reclaim_2026Q2.json</a:t>
+            </a:r>
+          </a:p>
+          <a:p>
+            <a:pPr algn="l">
+              <a:spcBef>
+                <a:spcPts val="0"/>
+              </a:spcBef>
+              <a:spcAft>
+                <a:spcPts val="100"/>
+              </a:spcAft>
+            </a:pPr>
+            <a:r>
+              <a:rPr sz="860" b="0">
+                <a:solidFill>
+                  <a:srgbClr val="1F2937"/>
+                </a:solidFill>
+                <a:latin typeface="Consolas"/>
+                <a:ea typeface="Consolas"/>
+                <a:cs typeface="Consolas"/>
+              </a:rPr>
+              <a:t>│  └─ regressions/                      </a:t>
+            </a:r>
+            <a:r>
+              <a:rPr sz="819" b="0">
+                <a:solidFill>
+                  <a:srgbClr val="6B7280"/>
+                </a:solidFill>
+                <a:latin typeface="Microsoft YaHei"/>
+                <a:ea typeface="Microsoft YaHei"/>
+                <a:cs typeface="Microsoft YaHei"/>
+              </a:rPr>
+              <a:t># 例:R031_shrink_node.json</a:t>
+            </a:r>
+          </a:p>
+          <a:p>
+            <a:pPr algn="l">
+              <a:spcBef>
+                <a:spcPts val="0"/>
+              </a:spcBef>
+              <a:spcAft>
+                <a:spcPts val="100"/>
+              </a:spcAft>
+            </a:pPr>
+            <a:r>
+              <a:rPr sz="860" b="0">
+                <a:solidFill>
+                  <a:srgbClr val="1F2937"/>
+                </a:solidFill>
+                <a:latin typeface="Consolas"/>
+                <a:ea typeface="Consolas"/>
+                <a:cs typeface="Consolas"/>
+              </a:rPr>
+              <a:t>├─ eval/                                </a:t>
+            </a:r>
+            <a:r>
+              <a:rPr sz="819" b="0">
+                <a:solidFill>
+                  <a:srgbClr val="6B7280"/>
+                </a:solidFill>
+                <a:latin typeface="Microsoft YaHei"/>
+                <a:ea typeface="Microsoft YaHei"/>
+                <a:cs typeface="Microsoft YaHei"/>
+              </a:rPr>
+              <a:t># 顶层·团队共享评测(区别于技能内 evals/)</a:t>
+            </a:r>
+          </a:p>
+          <a:p>
+            <a:pPr algn="l">
+              <a:spcBef>
+                <a:spcPts val="0"/>
+              </a:spcBef>
+              <a:spcAft>
+                <a:spcPts val="100"/>
+              </a:spcAft>
+            </a:pPr>
+            <a:r>
+              <a:rPr sz="860" b="0">
+                <a:solidFill>
+                  <a:srgbClr val="1F2937"/>
+                </a:solidFill>
+                <a:latin typeface="Consolas"/>
+                <a:ea typeface="Consolas"/>
+                <a:cs typeface="Consolas"/>
+              </a:rPr>
+              <a:t>│  ├─ task_suites/                      </a:t>
+            </a:r>
+            <a:r>
+              <a:rPr sz="819" b="0">
+                <a:solidFill>
+                  <a:srgbClr val="6B7280"/>
+                </a:solidFill>
+                <a:latin typeface="Microsoft YaHei"/>
+                <a:ea typeface="Microsoft YaHei"/>
+                <a:cs typeface="Microsoft YaHei"/>
+              </a:rPr>
+              <a:t># 可复用任务集 例:mm_reclaim_suite/</a:t>
+            </a:r>
+          </a:p>
+          <a:p>
+            <a:pPr algn="l">
+              <a:spcBef>
+                <a:spcPts val="0"/>
+              </a:spcBef>
+              <a:spcAft>
+                <a:spcPts val="100"/>
+              </a:spcAft>
+            </a:pPr>
+            <a:r>
+              <a:rPr sz="860" b="0">
+                <a:solidFill>
+                  <a:srgbClr val="1F2937"/>
+                </a:solidFill>
+                <a:latin typeface="Consolas"/>
+                <a:ea typeface="Consolas"/>
+                <a:cs typeface="Consolas"/>
+              </a:rPr>
+              <a:t>│  └─ scorecards/                       </a:t>
+            </a:r>
+            <a:r>
+              <a:rPr sz="819" b="0">
+                <a:solidFill>
+                  <a:srgbClr val="6B7280"/>
+                </a:solidFill>
+                <a:latin typeface="Microsoft YaHei"/>
+                <a:ea typeface="Microsoft YaHei"/>
+                <a:cs typeface="Microsoft YaHei"/>
+              </a:rPr>
+              <a:t># 发布级评分 例:funnel_v3_*.md</a:t>
+            </a:r>
+          </a:p>
+          <a:p>
+            <a:pPr algn="l">
+              <a:spcBef>
+                <a:spcPts val="0"/>
+              </a:spcBef>
+              <a:spcAft>
+                <a:spcPts val="100"/>
+              </a:spcAft>
+            </a:pPr>
+            <a:r>
+              <a:rPr sz="860" b="0">
+                <a:solidFill>
+                  <a:srgbClr val="1F2937"/>
+                </a:solidFill>
+                <a:latin typeface="Consolas"/>
+                <a:ea typeface="Consolas"/>
+                <a:cs typeface="Consolas"/>
+              </a:rPr>
               <a:t>└─ policies/ staging/ tools/ .github/   </a:t>
             </a:r>
             <a:r>
-              <a:rPr sz="860" b="0">
+              <a:rPr sz="819" b="0">
                 <a:solidFill>
                   <a:srgbClr val="6B7280"/>
                 </a:solidFill>
@@ -10245,8 +10437,8 @@
         </p:nvSpPr>
         <p:spPr>
           <a:xfrm>
-            <a:off x="6995160" y="1078992"/>
-            <a:ext cx="4782312" cy="2103120"/>
+            <a:off x="7452360" y="1078992"/>
+            <a:ext cx="4325112" cy="2505456"/>
           </a:xfrm>
           <a:prstGeom prst="roundRect">
             <a:avLst>
@@ -10293,8 +10485,8 @@
         </p:nvSpPr>
         <p:spPr>
           <a:xfrm>
-            <a:off x="7132320" y="1133856"/>
-            <a:ext cx="4572000" cy="274320"/>
+            <a:off x="7589520" y="1152144"/>
+            <a:ext cx="4114800" cy="292608"/>
           </a:xfrm>
           <a:prstGeom prst="rect">
             <a:avLst/>
@@ -10337,8 +10529,8 @@
         </p:nvSpPr>
         <p:spPr>
           <a:xfrm>
-            <a:off x="7059168" y="1426464"/>
-            <a:ext cx="4681728" cy="1755648"/>
+            <a:off x="7498079" y="1444752"/>
+            <a:ext cx="4206240" cy="2103120"/>
           </a:xfrm>
           <a:prstGeom prst="rect">
             <a:avLst/>
@@ -10356,11 +10548,11 @@
                 <a:spcPts val="0"/>
               </a:spcBef>
               <a:spcAft>
-                <a:spcPts val="130"/>
-              </a:spcAft>
-            </a:pPr>
-            <a:r>
-              <a:rPr sz="819" b="0">
+                <a:spcPts val="170"/>
+              </a:spcAft>
+            </a:pPr>
+            <a:r>
+              <a:rPr sz="830" b="0">
                 <a:solidFill>
                   <a:srgbClr val="1F2937"/>
                 </a:solidFill>
@@ -10371,7 +10563,7 @@
               <a:t>.opencode/                 </a:t>
             </a:r>
             <a:r>
-              <a:rPr sz="779" b="0">
+              <a:rPr sz="790" b="0">
                 <a:solidFill>
                   <a:srgbClr val="6B7280"/>
                 </a:solidFill>
@@ -10388,11 +10580,11 @@
                 <a:spcPts val="0"/>
               </a:spcBef>
               <a:spcAft>
-                <a:spcPts val="130"/>
-              </a:spcAft>
-            </a:pPr>
-            <a:r>
-              <a:rPr sz="819" b="0">
+                <a:spcPts val="170"/>
+              </a:spcAft>
+            </a:pPr>
+            <a:r>
+              <a:rPr sz="830" b="0">
                 <a:solidFill>
                   <a:srgbClr val="1F2937"/>
                 </a:solidFill>
@@ -10403,7 +10595,7 @@
               <a:t>├─ hub/                    </a:t>
             </a:r>
             <a:r>
-              <a:rPr sz="779" b="0">
+              <a:rPr sz="790" b="0">
                 <a:solidFill>
                   <a:srgbClr val="6B7280"/>
                 </a:solidFill>
@@ -10420,11 +10612,11 @@
                 <a:spcPts val="0"/>
               </a:spcBef>
               <a:spcAft>
-                <a:spcPts val="130"/>
-              </a:spcAft>
-            </a:pPr>
-            <a:r>
-              <a:rPr sz="819" b="0">
+                <a:spcPts val="170"/>
+              </a:spcAft>
+            </a:pPr>
+            <a:r>
+              <a:rPr sz="830" b="0">
                 <a:solidFill>
                   <a:srgbClr val="1F2937"/>
                 </a:solidFill>
@@ -10435,7 +10627,7 @@
               <a:t>├─ local/                  </a:t>
             </a:r>
             <a:r>
-              <a:rPr sz="779" b="0">
+              <a:rPr sz="790" b="0">
                 <a:solidFill>
                   <a:srgbClr val="6B7280"/>
                 </a:solidFill>
@@ -10452,11 +10644,11 @@
                 <a:spcPts val="0"/>
               </a:spcBef>
               <a:spcAft>
-                <a:spcPts val="130"/>
-              </a:spcAft>
-            </a:pPr>
-            <a:r>
-              <a:rPr sz="819" b="0">
+                <a:spcPts val="170"/>
+              </a:spcAft>
+            </a:pPr>
+            <a:r>
+              <a:rPr sz="830" b="0">
                 <a:solidFill>
                   <a:srgbClr val="1F2937"/>
                 </a:solidFill>
@@ -10467,7 +10659,7 @@
               <a:t>│   runs/&lt;run_id&gt;/         </a:t>
             </a:r>
             <a:r>
-              <a:rPr sz="779" b="0">
+              <a:rPr sz="790" b="0">
                 <a:solidFill>
                   <a:srgbClr val="6B7280"/>
                 </a:solidFill>
@@ -10484,11 +10676,11 @@
                 <a:spcPts val="0"/>
               </a:spcBef>
               <a:spcAft>
-                <a:spcPts val="130"/>
-              </a:spcAft>
-            </a:pPr>
-            <a:r>
-              <a:rPr sz="819" b="0">
+                <a:spcPts val="170"/>
+              </a:spcAft>
+            </a:pPr>
+            <a:r>
+              <a:rPr sz="830" b="0">
                 <a:solidFill>
                   <a:srgbClr val="1F2937"/>
                 </a:solidFill>
@@ -10499,7 +10691,7 @@
               <a:t>│     &lt;target&gt;_design.md   </a:t>
             </a:r>
             <a:r>
-              <a:rPr sz="779" b="0">
+              <a:rPr sz="790" b="0">
                 <a:solidFill>
                   <a:srgbClr val="6B7280"/>
                 </a:solidFill>
@@ -10516,11 +10708,11 @@
                 <a:spcPts val="0"/>
               </a:spcBef>
               <a:spcAft>
-                <a:spcPts val="130"/>
-              </a:spcAft>
-            </a:pPr>
-            <a:r>
-              <a:rPr sz="819" b="0">
+                <a:spcPts val="170"/>
+              </a:spcAft>
+            </a:pPr>
+            <a:r>
+              <a:rPr sz="830" b="0">
                 <a:solidFill>
                   <a:srgbClr val="1F2937"/>
                 </a:solidFill>
@@ -10531,7 +10723,7 @@
               <a:t>│   memory/                </a:t>
             </a:r>
             <a:r>
-              <a:rPr sz="779" b="0">
+              <a:rPr sz="790" b="0">
                 <a:solidFill>
                   <a:srgbClr val="6B7280"/>
                 </a:solidFill>
@@ -10548,11 +10740,11 @@
                 <a:spcPts val="0"/>
               </a:spcBef>
               <a:spcAft>
-                <a:spcPts val="130"/>
-              </a:spcAft>
-            </a:pPr>
-            <a:r>
-              <a:rPr sz="819" b="0">
+                <a:spcPts val="170"/>
+              </a:spcAft>
+            </a:pPr>
+            <a:r>
+              <a:rPr sz="830" b="0">
                 <a:solidFill>
                   <a:srgbClr val="1F2937"/>
                 </a:solidFill>
@@ -10563,7 +10755,7 @@
               <a:t>│   sediment_staging/      </a:t>
             </a:r>
             <a:r>
-              <a:rPr sz="779" b="0">
+              <a:rPr sz="790" b="0">
                 <a:solidFill>
                   <a:srgbClr val="6B7280"/>
                 </a:solidFill>
@@ -10580,11 +10772,11 @@
                 <a:spcPts val="0"/>
               </a:spcBef>
               <a:spcAft>
-                <a:spcPts val="130"/>
-              </a:spcAft>
-            </a:pPr>
-            <a:r>
-              <a:rPr sz="819" b="0">
+                <a:spcPts val="170"/>
+              </a:spcAft>
+            </a:pPr>
+            <a:r>
+              <a:rPr sz="830" b="0">
                 <a:solidFill>
                   <a:srgbClr val="1F2937"/>
                 </a:solidFill>
@@ -10595,7 +10787,7 @@
               <a:t>├─ state/current_task.json </a:t>
             </a:r>
             <a:r>
-              <a:rPr sz="779" b="0">
+              <a:rPr sz="790" b="0">
                 <a:solidFill>
                   <a:srgbClr val="6B7280"/>
                 </a:solidFill>
@@ -10612,11 +10804,11 @@
                 <a:spcPts val="0"/>
               </a:spcBef>
               <a:spcAft>
-                <a:spcPts val="130"/>
-              </a:spcAft>
-            </a:pPr>
-            <a:r>
-              <a:rPr sz="819" b="0">
+                <a:spcPts val="170"/>
+              </a:spcAft>
+            </a:pPr>
+            <a:r>
+              <a:rPr sz="830" b="0">
                 <a:solidFill>
                   <a:srgbClr val="1F2937"/>
                 </a:solidFill>
@@ -10627,7 +10819,7 @@
               <a:t>├─ skill-memory.lock       </a:t>
             </a:r>
             <a:r>
-              <a:rPr sz="779" b="0">
+              <a:rPr sz="790" b="0">
                 <a:solidFill>
                   <a:srgbClr val="6B7280"/>
                 </a:solidFill>
@@ -10644,11 +10836,11 @@
                 <a:spcPts val="0"/>
               </a:spcBef>
               <a:spcAft>
-                <a:spcPts val="130"/>
-              </a:spcAft>
-            </a:pPr>
-            <a:r>
-              <a:rPr sz="819" b="0">
+                <a:spcPts val="170"/>
+              </a:spcAft>
+            </a:pPr>
+            <a:r>
+              <a:rPr sz="830" b="0">
                 <a:solidFill>
                   <a:srgbClr val="1F2937"/>
                 </a:solidFill>
@@ -10659,7 +10851,7 @@
               <a:t>└─ resolver.py             </a:t>
             </a:r>
             <a:r>
-              <a:rPr sz="779" b="0">
+              <a:rPr sz="790" b="0">
                 <a:solidFill>
                   <a:srgbClr val="6B7280"/>
                 </a:solidFill>
@@ -10680,20 +10872,20 @@
         </p:nvSpPr>
         <p:spPr>
           <a:xfrm>
-            <a:off x="6995160" y="3255264"/>
-            <a:ext cx="4782312" cy="1481328"/>
+            <a:off x="7452360" y="3694176"/>
+            <a:ext cx="4325112" cy="841248"/>
           </a:xfrm>
           <a:prstGeom prst="roundRect">
             <a:avLst>
-              <a:gd name="adj" fmla="val 4000"/>
+              <a:gd name="adj" fmla="val 8000"/>
             </a:avLst>
           </a:prstGeom>
           <a:solidFill>
-            <a:srgbClr val="F3FBFA"/>
+            <a:srgbClr val="F1F5F9"/>
           </a:solidFill>
           <a:ln w="12700">
             <a:solidFill>
-              <a:srgbClr val="0D9488"/>
+              <a:srgbClr val="CBD5E1"/>
             </a:solidFill>
           </a:ln>
           <a:effectLst/>
@@ -10713,100 +10905,40 @@
           </a:fontRef>
         </p:style>
         <p:txBody>
-          <a:bodyPr rtlCol="0" anchor="ctr"/>
-          <a:lstStyle/>
-          <a:p>
-            <a:pPr algn="ctr"/>
-          </a:p>
-        </p:txBody>
-      </p:sp>
-      <p:sp>
-        <p:nvSpPr>
-          <p:cNvPr id="14" name="TextBox 13"/>
-          <p:cNvSpPr txBox="1"/>
-          <p:nvPr/>
-        </p:nvSpPr>
-        <p:spPr>
-          <a:xfrm>
-            <a:off x="7132320" y="3310128"/>
-            <a:ext cx="4572000" cy="274320"/>
-          </a:xfrm>
-          <a:prstGeom prst="rect">
-            <a:avLst/>
-          </a:prstGeom>
-          <a:noFill/>
-        </p:spPr>
-        <p:txBody>
-          <a:bodyPr wrap="square" anchor="t" lIns="73152" rIns="73152" tIns="27432" bIns="27432">
-            <a:spAutoFit/>
-          </a:bodyPr>
-          <a:lstStyle/>
-          <a:p>
-            <a:pPr algn="l">
-              <a:spcBef>
-                <a:spcPts val="0"/>
-              </a:spcBef>
-              <a:spcAft>
-                <a:spcPts val="300"/>
-              </a:spcAft>
-            </a:pPr>
-            <a:r>
-              <a:rPr sz="1000" b="1">
-                <a:solidFill>
-                  <a:srgbClr val="0D9488"/>
-                </a:solidFill>
-                <a:latin typeface="Microsoft YaHei"/>
-                <a:ea typeface="Microsoft YaHei"/>
-                <a:cs typeface="Microsoft YaHei"/>
-              </a:rPr>
-              <a:t>【放大】一个技能文件夹 = skills/core/optimization-funnel/</a:t>
-            </a:r>
-          </a:p>
-        </p:txBody>
-      </p:sp>
-      <p:sp>
-        <p:nvSpPr>
-          <p:cNvPr id="15" name="TextBox 14"/>
-          <p:cNvSpPr txBox="1"/>
-          <p:nvPr/>
-        </p:nvSpPr>
-        <p:spPr>
-          <a:xfrm>
-            <a:off x="7150608" y="3621024"/>
-            <a:ext cx="4572000" cy="1097280"/>
-          </a:xfrm>
-          <a:prstGeom prst="rect">
-            <a:avLst/>
-          </a:prstGeom>
-          <a:noFill/>
-        </p:spPr>
-        <p:txBody>
-          <a:bodyPr wrap="none" anchor="t" lIns="128016" rIns="54864" tIns="91440">
-            <a:spAutoFit/>
-          </a:bodyPr>
-          <a:lstStyle/>
-          <a:p>
-            <a:pPr algn="l">
-              <a:spcBef>
-                <a:spcPts val="0"/>
-              </a:spcBef>
-              <a:spcAft>
-                <a:spcPts val="140"/>
-              </a:spcAft>
-            </a:pPr>
-            <a:r>
-              <a:rPr sz="830" b="0">
+          <a:bodyPr rtlCol="0" anchor="t" wrap="square" lIns="73152" rIns="73152" tIns="27432" bIns="27432"/>
+          <a:lstStyle/>
+          <a:p>
+            <a:pPr algn="ctr">
+              <a:spcBef>
+                <a:spcPts val="0"/>
+              </a:spcBef>
+              <a:spcAft>
+                <a:spcPts val="300"/>
+              </a:spcAft>
+            </a:pPr>
+            <a:r>
+              <a:rPr sz="1050" b="1">
                 <a:solidFill>
                   <a:srgbClr val="1F2937"/>
                 </a:solidFill>
-                <a:latin typeface="Consolas"/>
-                <a:ea typeface="Consolas"/>
-                <a:cs typeface="Consolas"/>
-              </a:rPr>
-              <a:t>SKILL.md      </a:t>
-            </a:r>
-            <a:r>
-              <a:rPr sz="790" b="0">
+                <a:latin typeface="Microsoft YaHei"/>
+                <a:ea typeface="Microsoft YaHei"/>
+                <a:cs typeface="Microsoft YaHei"/>
+              </a:rPr>
+              <a:t>三类资产 → 唯一归宿</a:t>
+            </a:r>
+          </a:p>
+          <a:p>
+            <a:pPr algn="ctr">
+              <a:spcBef>
+                <a:spcPts val="0"/>
+              </a:spcBef>
+              <a:spcAft>
+                <a:spcPts val="300"/>
+              </a:spcAft>
+            </a:pPr>
+            <a:r>
+              <a:rPr sz="880" b="0">
                 <a:solidFill>
                   <a:srgbClr val="6B7280"/>
                 </a:solidFill>
@@ -10814,225 +10946,21 @@
                 <a:ea typeface="Microsoft YaHei"/>
                 <a:cs typeface="Microsoft YaHei"/>
               </a:rPr>
-              <a:t># 选中即读:何时用 + 怎么用</a:t>
-            </a:r>
-          </a:p>
-          <a:p>
-            <a:pPr algn="l">
-              <a:spcBef>
-                <a:spcPts val="0"/>
-              </a:spcBef>
-              <a:spcAft>
-                <a:spcPts val="140"/>
-              </a:spcAft>
-            </a:pPr>
-            <a:r>
-              <a:rPr sz="830" b="0">
-                <a:solidFill>
-                  <a:srgbClr val="1F2937"/>
-                </a:solidFill>
-                <a:latin typeface="Consolas"/>
-                <a:ea typeface="Consolas"/>
-                <a:cs typeface="Consolas"/>
-              </a:rPr>
-              <a:t>best_skill.md </a:t>
-            </a:r>
-            <a:r>
-              <a:rPr sz="790" b="0">
-                <a:solidFill>
-                  <a:srgbClr val="6B7280"/>
-                </a:solidFill>
-                <a:latin typeface="Microsoft YaHei"/>
-                <a:ea typeface="Microsoft YaHei"/>
-                <a:cs typeface="Microsoft YaHei"/>
-              </a:rPr>
-              <a:t># SkillOpt 优化出的“正本”</a:t>
-            </a:r>
-          </a:p>
-          <a:p>
-            <a:pPr algn="l">
-              <a:spcBef>
-                <a:spcPts val="0"/>
-              </a:spcBef>
-              <a:spcAft>
-                <a:spcPts val="140"/>
-              </a:spcAft>
-            </a:pPr>
-            <a:r>
-              <a:rPr sz="830" b="0">
-                <a:solidFill>
-                  <a:srgbClr val="1F2937"/>
-                </a:solidFill>
-                <a:latin typeface="Consolas"/>
-                <a:ea typeface="Consolas"/>
-                <a:cs typeface="Consolas"/>
-              </a:rPr>
-              <a:t>evals/        </a:t>
-            </a:r>
-            <a:r>
-              <a:rPr sz="790" b="0">
-                <a:solidFill>
-                  <a:srgbClr val="6B7280"/>
-                </a:solidFill>
-                <a:latin typeface="Microsoft YaHei"/>
-                <a:ea typeface="Microsoft YaHei"/>
-                <a:cs typeface="Microsoft YaHei"/>
-              </a:rPr>
-              <a:t># 本技能评测:绑定哪套题 + 留出用例</a:t>
-            </a:r>
-          </a:p>
-          <a:p>
-            <a:pPr algn="l">
-              <a:spcBef>
-                <a:spcPts val="0"/>
-              </a:spcBef>
-              <a:spcAft>
-                <a:spcPts val="140"/>
-              </a:spcAft>
-            </a:pPr>
-            <a:r>
-              <a:rPr sz="830" b="0">
-                <a:solidFill>
-                  <a:srgbClr val="1F2937"/>
-                </a:solidFill>
-                <a:latin typeface="Consolas"/>
-                <a:ea typeface="Consolas"/>
-                <a:cs typeface="Consolas"/>
-              </a:rPr>
-              <a:t>candidates/   </a:t>
-            </a:r>
-            <a:r>
-              <a:rPr sz="790" b="0">
-                <a:solidFill>
-                  <a:srgbClr val="6B7280"/>
-                </a:solidFill>
-                <a:latin typeface="Microsoft YaHei"/>
-                <a:ea typeface="Microsoft YaHei"/>
-                <a:cs typeface="Microsoft YaHei"/>
-              </a:rPr>
-              <a:t># Pareto 前沿:互补候选</a:t>
-            </a:r>
-          </a:p>
-          <a:p>
-            <a:pPr algn="l">
-              <a:spcBef>
-                <a:spcPts val="0"/>
-              </a:spcBef>
-              <a:spcAft>
-                <a:spcPts val="140"/>
-              </a:spcAft>
-            </a:pPr>
-            <a:r>
-              <a:rPr sz="830" b="0">
-                <a:solidFill>
-                  <a:srgbClr val="1F2937"/>
-                </a:solidFill>
-                <a:latin typeface="Consolas"/>
-                <a:ea typeface="Consolas"/>
-                <a:cs typeface="Consolas"/>
-              </a:rPr>
-              <a:t>scorecards/   </a:t>
-            </a:r>
-            <a:r>
-              <a:rPr sz="790" b="0">
-                <a:solidFill>
-                  <a:srgbClr val="6B7280"/>
-                </a:solidFill>
-                <a:latin typeface="Microsoft YaHei"/>
-                <a:ea typeface="Microsoft YaHei"/>
-                <a:cs typeface="Microsoft YaHei"/>
-              </a:rPr>
-              <a:t># 本技能历次 A/B 跑分</a:t>
-            </a:r>
-          </a:p>
-          <a:p>
-            <a:pPr algn="l">
-              <a:spcBef>
-                <a:spcPts val="0"/>
-              </a:spcBef>
-              <a:spcAft>
-                <a:spcPts val="140"/>
-              </a:spcAft>
-            </a:pPr>
-            <a:r>
-              <a:rPr sz="830" b="0">
-                <a:solidFill>
-                  <a:srgbClr val="1F2937"/>
-                </a:solidFill>
-                <a:latin typeface="Consolas"/>
-                <a:ea typeface="Consolas"/>
-                <a:cs typeface="Consolas"/>
-              </a:rPr>
-              <a:t>references/   </a:t>
-            </a:r>
-            <a:r>
-              <a:rPr sz="790" b="0">
-                <a:solidFill>
-                  <a:srgbClr val="6B7280"/>
-                </a:solidFill>
-                <a:latin typeface="Microsoft YaHei"/>
-                <a:ea typeface="Microsoft YaHei"/>
-                <a:cs typeface="Microsoft YaHei"/>
-              </a:rPr>
-              <a:t># 重材料(按需加载)</a:t>
-            </a:r>
-          </a:p>
-        </p:txBody>
-      </p:sp>
-      <p:sp>
-        <p:nvSpPr>
-          <p:cNvPr id="16" name="TextBox 15"/>
-          <p:cNvSpPr txBox="1"/>
-          <p:nvPr/>
-        </p:nvSpPr>
-        <p:spPr>
-          <a:xfrm>
-            <a:off x="6995160" y="4809744"/>
-            <a:ext cx="4782312" cy="256032"/>
-          </a:xfrm>
-          <a:prstGeom prst="rect">
-            <a:avLst/>
-          </a:prstGeom>
-          <a:noFill/>
-        </p:spPr>
-        <p:txBody>
-          <a:bodyPr wrap="square" anchor="t" lIns="73152" rIns="73152" tIns="27432" bIns="27432">
-            <a:spAutoFit/>
-          </a:bodyPr>
-          <a:lstStyle/>
-          <a:p>
-            <a:pPr algn="l">
-              <a:spcBef>
-                <a:spcPts val="0"/>
-              </a:spcBef>
-              <a:spcAft>
-                <a:spcPts val="300"/>
-              </a:spcAft>
-            </a:pPr>
-            <a:r>
-              <a:rPr sz="950" b="1">
-                <a:solidFill>
-                  <a:srgbClr val="0F1E3D"/>
-                </a:solidFill>
-                <a:latin typeface="Microsoft YaHei"/>
-                <a:ea typeface="Microsoft YaHei"/>
-                <a:cs typeface="Microsoft YaHei"/>
-              </a:rPr>
-              <a:t>易混淆：eval/（顶层共享题库） 与 evals/（技能内考卷）</a:t>
-            </a:r>
-          </a:p>
-        </p:txBody>
-      </p:sp>
-      <p:sp>
-        <p:nvSpPr>
-          <p:cNvPr id="17" name="Rounded Rectangle 16"/>
+              <a:t>做法/流程→hub skills；事实/教训→hub knowledge；运行证据→local/</a:t>
+            </a:r>
+          </a:p>
+        </p:txBody>
+      </p:sp>
+      <p:sp>
+        <p:nvSpPr>
+          <p:cNvPr id="14" name="Rounded Rectangle 13"/>
           <p:cNvSpPr/>
           <p:nvPr/>
         </p:nvSpPr>
         <p:spPr>
           <a:xfrm>
-            <a:off x="6995160" y="5084064"/>
-            <a:ext cx="2331720" cy="1225296"/>
+            <a:off x="7452360" y="4645152"/>
+            <a:ext cx="4325112" cy="548640"/>
           </a:xfrm>
           <a:prstGeom prst="roundRect">
             <a:avLst>
@@ -11084,7 +11012,7 @@
                 <a:ea typeface="Microsoft YaHei"/>
                 <a:cs typeface="Microsoft YaHei"/>
               </a:rPr>
-              <a:t>eval/  顶层 · 共享</a:t>
+              <a:t>资产面 / 执行面分离</a:t>
             </a:r>
           </a:p>
           <a:p>
@@ -11105,21 +11033,21 @@
                 <a:ea typeface="Microsoft YaHei"/>
                 <a:cs typeface="Microsoft YaHei"/>
               </a:rPr>
-              <a:t>共享题库 task_suites/ + 发布评分 scorecards/</a:t>
-            </a:r>
-          </a:p>
-        </p:txBody>
-      </p:sp>
-      <p:sp>
-        <p:nvSpPr>
-          <p:cNvPr id="18" name="Rounded Rectangle 17"/>
+              <a:t>hub 只读·共享·版本化；local 个人·在途</a:t>
+            </a:r>
+          </a:p>
+        </p:txBody>
+      </p:sp>
+      <p:sp>
+        <p:nvSpPr>
+          <p:cNvPr id="15" name="Rounded Rectangle 14"/>
           <p:cNvSpPr/>
           <p:nvPr/>
         </p:nvSpPr>
         <p:spPr>
           <a:xfrm>
-            <a:off x="9445752" y="5084064"/>
-            <a:ext cx="2331720" cy="1225296"/>
+            <a:off x="7452360" y="5230368"/>
+            <a:ext cx="4325112" cy="548640"/>
           </a:xfrm>
           <a:prstGeom prst="roundRect">
             <a:avLst>
@@ -11127,11 +11055,11 @@
             </a:avLst>
           </a:prstGeom>
           <a:solidFill>
-            <a:srgbClr val="E2F7F3"/>
+            <a:srgbClr val="FFECDC"/>
           </a:solidFill>
           <a:ln w="12700">
             <a:solidFill>
-              <a:srgbClr val="0D9488"/>
+              <a:srgbClr val="EA580C"/>
             </a:solidFill>
           </a:ln>
           <a:effectLst/>
@@ -11165,13 +11093,13 @@
             <a:r>
               <a:rPr sz="1100" b="1">
                 <a:solidFill>
-                  <a:srgbClr val="0D9488"/>
-                </a:solidFill>
-                <a:latin typeface="Microsoft YaHei"/>
-                <a:ea typeface="Microsoft YaHei"/>
-                <a:cs typeface="Microsoft YaHei"/>
-              </a:rPr>
-              <a:t>evals/  技能内 · 私有</a:t>
+                  <a:srgbClr val="EA580C"/>
+                </a:solidFill>
+                <a:latin typeface="Microsoft YaHei"/>
+                <a:ea typeface="Microsoft YaHei"/>
+                <a:cs typeface="Microsoft YaHei"/>
+              </a:rPr>
+              <a:t>每条知识 = 一文件 + 稳定 ID</a:t>
             </a:r>
           </a:p>
           <a:p>
@@ -11192,14 +11120,101 @@
                 <a:ea typeface="Microsoft YaHei"/>
                 <a:cs typeface="Microsoft YaHei"/>
               </a:rPr>
-              <a:t>引用 eval_id 指向某 suite + 本技能用例/跑分</a:t>
-            </a:r>
-          </a:p>
-        </p:txBody>
-      </p:sp>
-      <p:sp>
-        <p:nvSpPr>
-          <p:cNvPr id="19" name="TextBox 18"/>
+              <a:t>规避 git 行级冲突，热点文件不争用</a:t>
+            </a:r>
+          </a:p>
+        </p:txBody>
+      </p:sp>
+      <p:sp>
+        <p:nvSpPr>
+          <p:cNvPr id="16" name="Rounded Rectangle 15"/>
+          <p:cNvSpPr/>
+          <p:nvPr/>
+        </p:nvSpPr>
+        <p:spPr>
+          <a:xfrm>
+            <a:off x="7452360" y="5815584"/>
+            <a:ext cx="4325112" cy="530352"/>
+          </a:xfrm>
+          <a:prstGeom prst="roundRect">
+            <a:avLst>
+              <a:gd name="adj" fmla="val 10000"/>
+            </a:avLst>
+          </a:prstGeom>
+          <a:solidFill>
+            <a:srgbClr val="DDF3E5"/>
+          </a:solidFill>
+          <a:ln w="12700">
+            <a:solidFill>
+              <a:srgbClr val="16A34A"/>
+            </a:solidFill>
+          </a:ln>
+          <a:effectLst/>
+        </p:spPr>
+        <p:style>
+          <a:lnRef idx="1">
+            <a:schemeClr val="accent1"/>
+          </a:lnRef>
+          <a:fillRef idx="3">
+            <a:schemeClr val="accent1"/>
+          </a:fillRef>
+          <a:effectRef idx="2">
+            <a:schemeClr val="accent1"/>
+          </a:effectRef>
+          <a:fontRef idx="minor">
+            <a:schemeClr val="lt1"/>
+          </a:fontRef>
+        </p:style>
+        <p:txBody>
+          <a:bodyPr rtlCol="0" anchor="t" wrap="square" lIns="73152" rIns="73152" tIns="27432" bIns="27432"/>
+          <a:lstStyle/>
+          <a:p>
+            <a:pPr algn="ctr">
+              <a:spcBef>
+                <a:spcPts val="0"/>
+              </a:spcBef>
+              <a:spcAft>
+                <a:spcPts val="300"/>
+              </a:spcAft>
+            </a:pPr>
+            <a:r>
+              <a:rPr sz="1100" b="1">
+                <a:solidFill>
+                  <a:srgbClr val="16A34A"/>
+                </a:solidFill>
+                <a:latin typeface="Microsoft YaHei"/>
+                <a:ea typeface="Microsoft YaHei"/>
+                <a:cs typeface="Microsoft YaHei"/>
+              </a:rPr>
+              <a:t>子模块锁定 + 版本锁文件</a:t>
+            </a:r>
+          </a:p>
+          <a:p>
+            <a:pPr algn="ctr">
+              <a:spcBef>
+                <a:spcPts val="0"/>
+              </a:spcBef>
+              <a:spcAft>
+                <a:spcPts val="300"/>
+              </a:spcAft>
+            </a:pPr>
+            <a:r>
+              <a:rPr sz="950" b="0">
+                <a:solidFill>
+                  <a:srgbClr val="1F2937"/>
+                </a:solidFill>
+                <a:latin typeface="Microsoft YaHei"/>
+                <a:ea typeface="Microsoft YaHei"/>
+                <a:cs typeface="Microsoft YaHei"/>
+              </a:rPr>
+              <a:t>可复现·防漂移·中央仓宕机本地兜底</a:t>
+            </a:r>
+          </a:p>
+        </p:txBody>
+      </p:sp>
+      <p:sp>
+        <p:nvSpPr>
+          <p:cNvPr id="17" name="TextBox 16"/>
           <p:cNvSpPr txBox="1"/>
           <p:nvPr/>
         </p:nvSpPr>

</xml_diff>

<commit_message>
docs(slides): slide 6 → frameless full-canvas detailed directory listing
Per feedback, make slide 6 a complete reference page:
- Expand agents/ commands/ pipelines/ docs/ with their real children
  (os-opt-manager/kernel-code-agent/kernel-reviewer/... ; optimize_*/research/
  plan/review_sync ; the 5 pipeline profiles ; harness_engineer_system.md /
  memory_system.md).
- Drop the card frames and the page footer; slim the header; use the full
  canvas with a smaller 7.2pt hub-tree font so the whole layout is listed.
- Right column (also frameless) keeps the .opencode/ tree plus labeled
  sections: 归宿 / 布局要点 / 治理(谁过 eval-gate) / 消费·高可用.
- Remove the now-unused minicard helper.

Verified all shapes in-bounds, ruff clean, 47-line hub tree fits the canvas.

https://claude.ai/code/session_01SfNMKzdmMz69A2VBTPNR92
</commit_message>
<xml_diff>
--- a/docs/Team_Skill_Hub_Design_Slides.pptx
+++ b/docs/Team_Skill_Hub_Design_Slides.pptx
@@ -9058,7 +9058,7 @@
         <p:spPr>
           <a:xfrm>
             <a:off x="0" y="0"/>
-            <a:ext cx="12191695" cy="914400"/>
+            <a:ext cx="12191695" cy="530352"/>
           </a:xfrm>
           <a:prstGeom prst="rect">
             <a:avLst/>
@@ -9101,8 +9101,8 @@
         </p:nvSpPr>
         <p:spPr>
           <a:xfrm>
-            <a:off x="0" y="914400"/>
-            <a:ext cx="12191695" cy="64008"/>
+            <a:off x="0" y="530352"/>
+            <a:ext cx="12191695" cy="41148"/>
           </a:xfrm>
           <a:prstGeom prst="rect">
             <a:avLst/>
@@ -9145,8 +9145,8 @@
         </p:nvSpPr>
         <p:spPr>
           <a:xfrm>
-            <a:off x="457200" y="91440"/>
-            <a:ext cx="10241280" cy="502920"/>
+            <a:off x="256032" y="27432"/>
+            <a:ext cx="10789920" cy="457200"/>
           </a:xfrm>
           <a:prstGeom prst="rect">
             <a:avLst/>
@@ -9168,7 +9168,7 @@
               </a:spcAft>
             </a:pPr>
             <a:r>
-              <a:rPr sz="2300" b="1">
+              <a:rPr sz="1600" b="1">
                 <a:solidFill>
                   <a:srgbClr val="FFFFFF"/>
                 </a:solidFill>
@@ -9176,7 +9176,7 @@
                 <a:ea typeface="Microsoft YaHei"/>
                 <a:cs typeface="Microsoft YaHei"/>
               </a:rPr>
-              <a:t>完整工程目录 Layout：两仓职责划清</a:t>
+              <a:t>完整工程目录 Layout · hm-skill-hub（团队共享） + .opencode（执行面）</a:t>
             </a:r>
           </a:p>
         </p:txBody>
@@ -9189,8 +9189,52 @@
         </p:nvSpPr>
         <p:spPr>
           <a:xfrm>
-            <a:off x="475488" y="548640"/>
-            <a:ext cx="10241280" cy="310896"/>
+            <a:off x="11430000" y="73152"/>
+            <a:ext cx="548640" cy="365760"/>
+          </a:xfrm>
+          <a:prstGeom prst="rect">
+            <a:avLst/>
+          </a:prstGeom>
+          <a:noFill/>
+        </p:spPr>
+        <p:txBody>
+          <a:bodyPr wrap="square" anchor="ctr" lIns="73152" rIns="73152" tIns="27432" bIns="27432">
+            <a:spAutoFit/>
+          </a:bodyPr>
+          <a:lstStyle/>
+          <a:p>
+            <a:pPr algn="r">
+              <a:spcBef>
+                <a:spcPts val="0"/>
+              </a:spcBef>
+              <a:spcAft>
+                <a:spcPts val="300"/>
+              </a:spcAft>
+            </a:pPr>
+            <a:r>
+              <a:rPr sz="1200" b="1">
+                <a:solidFill>
+                  <a:srgbClr val="C8D2E0"/>
+                </a:solidFill>
+                <a:latin typeface="Microsoft YaHei"/>
+                <a:ea typeface="Microsoft YaHei"/>
+                <a:cs typeface="Microsoft YaHei"/>
+              </a:rPr>
+              <a:t>06</a:t>
+            </a:r>
+          </a:p>
+        </p:txBody>
+      </p:sp>
+      <p:sp>
+        <p:nvSpPr>
+          <p:cNvPr id="6" name="TextBox 5"/>
+          <p:cNvSpPr txBox="1"/>
+          <p:nvPr/>
+        </p:nvSpPr>
+        <p:spPr>
+          <a:xfrm>
+            <a:off x="256032" y="585216"/>
+            <a:ext cx="7223760" cy="219456"/>
           </a:xfrm>
           <a:prstGeom prst="rect">
             <a:avLst/>
@@ -9212,29 +9256,1523 @@
               </a:spcAft>
             </a:pPr>
             <a:r>
-              <a:rPr sz="1100" b="0">
-                <a:solidFill>
-                  <a:srgbClr val="C8D2E0"/>
-                </a:solidFill>
-                <a:latin typeface="Microsoft YaHei"/>
-                <a:ea typeface="Microsoft YaHei"/>
-                <a:cs typeface="Microsoft YaHei"/>
-              </a:rPr>
-              <a:t>两仓分工：hm-skill-hub = 团队共享资产（版本化、只读消费）｜ .opencode/ = 各成员执行面（本地叠加 + 在途沉淀）</a:t>
-            </a:r>
-          </a:p>
-        </p:txBody>
-      </p:sp>
-      <p:sp>
-        <p:nvSpPr>
-          <p:cNvPr id="6" name="TextBox 5"/>
+              <a:rPr sz="1050" b="1">
+                <a:solidFill>
+                  <a:srgbClr val="4F46E5"/>
+                </a:solidFill>
+                <a:latin typeface="Microsoft YaHei"/>
+                <a:ea typeface="Microsoft YaHei"/>
+                <a:cs typeface="Microsoft YaHei"/>
+              </a:rPr>
+              <a:t>① 中央资产仓 hm-skill-hub/  ·  团队共享 · 版本化(semver) · 只读消费</a:t>
+            </a:r>
+          </a:p>
+        </p:txBody>
+      </p:sp>
+      <p:sp>
+        <p:nvSpPr>
+          <p:cNvPr id="7" name="TextBox 6"/>
           <p:cNvSpPr txBox="1"/>
           <p:nvPr/>
         </p:nvSpPr>
         <p:spPr>
           <a:xfrm>
-            <a:off x="11155680" y="274320"/>
-            <a:ext cx="822960" cy="457200"/>
+            <a:off x="256032" y="804672"/>
+            <a:ext cx="7223760" cy="5989320"/>
+          </a:xfrm>
+          <a:prstGeom prst="rect">
+            <a:avLst/>
+          </a:prstGeom>
+          <a:noFill/>
+        </p:spPr>
+        <p:txBody>
+          <a:bodyPr wrap="none" anchor="t" lIns="128016" rIns="54864" tIns="91440">
+            <a:spAutoFit/>
+          </a:bodyPr>
+          <a:lstStyle/>
+          <a:p>
+            <a:pPr algn="l">
+              <a:spcBef>
+                <a:spcPts val="0"/>
+              </a:spcBef>
+              <a:spcAft>
+                <a:spcPts val="75"/>
+              </a:spcAft>
+            </a:pPr>
+            <a:r>
+              <a:rPr sz="720" b="0">
+                <a:solidFill>
+                  <a:srgbClr val="1F2937"/>
+                </a:solidFill>
+                <a:latin typeface="Consolas"/>
+                <a:ea typeface="Consolas"/>
+                <a:cs typeface="Consolas"/>
+              </a:rPr>
+              <a:t>hm-skill-hub/                             </a:t>
+            </a:r>
+            <a:r>
+              <a:rPr sz="680" b="0">
+                <a:solidFill>
+                  <a:srgbClr val="6B7280"/>
+                </a:solidFill>
+                <a:latin typeface="Microsoft YaHei"/>
+                <a:ea typeface="Microsoft YaHei"/>
+                <a:cs typeface="Microsoft YaHei"/>
+              </a:rPr>
+              <a:t># 团队共享 · 版本化(semver)</a:t>
+            </a:r>
+          </a:p>
+          <a:p>
+            <a:pPr algn="l">
+              <a:spcBef>
+                <a:spcPts val="0"/>
+              </a:spcBef>
+              <a:spcAft>
+                <a:spcPts val="75"/>
+              </a:spcAft>
+            </a:pPr>
+            <a:r>
+              <a:rPr sz="720" b="0">
+                <a:solidFill>
+                  <a:srgbClr val="1F2937"/>
+                </a:solidFill>
+                <a:latin typeface="Consolas"/>
+                <a:ea typeface="Consolas"/>
+                <a:cs typeface="Consolas"/>
+              </a:rPr>
+              <a:t>├─ registry.yaml                          </a:t>
+            </a:r>
+            <a:r>
+              <a:rPr sz="680" b="0">
+                <a:solidFill>
+                  <a:srgbClr val="6B7280"/>
+                </a:solidFill>
+                <a:latin typeface="Microsoft YaHei"/>
+                <a:ea typeface="Microsoft YaHei"/>
+                <a:cs typeface="Microsoft YaHei"/>
+              </a:rPr>
+              <a:t># 总清单:技能/版本/评测状态/负责人</a:t>
+            </a:r>
+          </a:p>
+          <a:p>
+            <a:pPr algn="l">
+              <a:spcBef>
+                <a:spcPts val="0"/>
+              </a:spcBef>
+              <a:spcAft>
+                <a:spcPts val="75"/>
+              </a:spcAft>
+            </a:pPr>
+            <a:r>
+              <a:rPr sz="720" b="0">
+                <a:solidFill>
+                  <a:srgbClr val="1F2937"/>
+                </a:solidFill>
+                <a:latin typeface="Consolas"/>
+                <a:ea typeface="Consolas"/>
+                <a:cs typeface="Consolas"/>
+              </a:rPr>
+              <a:t>├─ schemas/                               </a:t>
+            </a:r>
+            <a:r>
+              <a:rPr sz="680" b="0">
+                <a:solidFill>
+                  <a:srgbClr val="6B7280"/>
+                </a:solidFill>
+                <a:latin typeface="Microsoft YaHei"/>
+                <a:ea typeface="Microsoft YaHei"/>
+                <a:cs typeface="Microsoft YaHei"/>
+              </a:rPr>
+              <a:t># 各类记录的 JSON-Schema(校验门)</a:t>
+            </a:r>
+          </a:p>
+          <a:p>
+            <a:pPr algn="l">
+              <a:spcBef>
+                <a:spcPts val="0"/>
+              </a:spcBef>
+              <a:spcAft>
+                <a:spcPts val="75"/>
+              </a:spcAft>
+            </a:pPr>
+            <a:r>
+              <a:rPr sz="720" b="0">
+                <a:solidFill>
+                  <a:srgbClr val="1F2937"/>
+                </a:solidFill>
+                <a:latin typeface="Consolas"/>
+                <a:ea typeface="Consolas"/>
+                <a:cs typeface="Consolas"/>
+              </a:rPr>
+              <a:t>├─ skills/                                </a:t>
+            </a:r>
+            <a:r>
+              <a:rPr sz="680" b="0">
+                <a:solidFill>
+                  <a:srgbClr val="6B7280"/>
+                </a:solidFill>
+                <a:latin typeface="Microsoft YaHei"/>
+                <a:ea typeface="Microsoft YaHei"/>
+                <a:cs typeface="Microsoft YaHei"/>
+              </a:rPr>
+              <a:t># 技能(引擎B · 过 eval-gate 竞争式优化)</a:t>
+            </a:r>
+          </a:p>
+          <a:p>
+            <a:pPr algn="l">
+              <a:spcBef>
+                <a:spcPts val="0"/>
+              </a:spcBef>
+              <a:spcAft>
+                <a:spcPts val="75"/>
+              </a:spcAft>
+            </a:pPr>
+            <a:r>
+              <a:rPr sz="720" b="0">
+                <a:solidFill>
+                  <a:srgbClr val="1F2937"/>
+                </a:solidFill>
+                <a:latin typeface="Consolas"/>
+                <a:ea typeface="Consolas"/>
+                <a:cs typeface="Consolas"/>
+              </a:rPr>
+              <a:t>│  ├─ core/                               </a:t>
+            </a:r>
+            <a:r>
+              <a:rPr sz="680" b="0">
+                <a:solidFill>
+                  <a:srgbClr val="6B7280"/>
+                </a:solidFill>
+                <a:latin typeface="Microsoft YaHei"/>
+                <a:ea typeface="Microsoft YaHei"/>
+                <a:cs typeface="Microsoft YaHei"/>
+              </a:rPr>
+              <a:t># 流程·跨切面(全子系统通用)</a:t>
+            </a:r>
+          </a:p>
+          <a:p>
+            <a:pPr algn="l">
+              <a:spcBef>
+                <a:spcPts val="0"/>
+              </a:spcBef>
+              <a:spcAft>
+                <a:spcPts val="75"/>
+              </a:spcAft>
+            </a:pPr>
+            <a:r>
+              <a:rPr sz="720" b="0">
+                <a:solidFill>
+                  <a:srgbClr val="1F2937"/>
+                </a:solidFill>
+                <a:latin typeface="Consolas"/>
+                <a:ea typeface="Consolas"/>
+                <a:cs typeface="Consolas"/>
+              </a:rPr>
+              <a:t>│  │  ├─ optimization-funnel/             </a:t>
+            </a:r>
+            <a:r>
+              <a:rPr sz="680" b="0">
+                <a:solidFill>
+                  <a:srgbClr val="6B7280"/>
+                </a:solidFill>
+                <a:latin typeface="Microsoft YaHei"/>
+                <a:ea typeface="Microsoft YaHei"/>
+                <a:cs typeface="Microsoft YaHei"/>
+              </a:rPr>
+              <a:t># 例:优化漏斗主流程 — 内容如下</a:t>
+            </a:r>
+          </a:p>
+          <a:p>
+            <a:pPr algn="l">
+              <a:spcBef>
+                <a:spcPts val="0"/>
+              </a:spcBef>
+              <a:spcAft>
+                <a:spcPts val="75"/>
+              </a:spcAft>
+            </a:pPr>
+            <a:r>
+              <a:rPr sz="720" b="0">
+                <a:solidFill>
+                  <a:srgbClr val="1F2937"/>
+                </a:solidFill>
+                <a:latin typeface="Consolas"/>
+                <a:ea typeface="Consolas"/>
+                <a:cs typeface="Consolas"/>
+              </a:rPr>
+              <a:t>│  │  │   ├─ SKILL.md                     </a:t>
+            </a:r>
+            <a:r>
+              <a:rPr sz="680" b="0">
+                <a:solidFill>
+                  <a:srgbClr val="6B7280"/>
+                </a:solidFill>
+                <a:latin typeface="Microsoft YaHei"/>
+                <a:ea typeface="Microsoft YaHei"/>
+                <a:cs typeface="Microsoft YaHei"/>
+              </a:rPr>
+              <a:t># 选中即读:何时用 + 怎么用</a:t>
+            </a:r>
+          </a:p>
+          <a:p>
+            <a:pPr algn="l">
+              <a:spcBef>
+                <a:spcPts val="0"/>
+              </a:spcBef>
+              <a:spcAft>
+                <a:spcPts val="75"/>
+              </a:spcAft>
+            </a:pPr>
+            <a:r>
+              <a:rPr sz="720" b="0">
+                <a:solidFill>
+                  <a:srgbClr val="1F2937"/>
+                </a:solidFill>
+                <a:latin typeface="Consolas"/>
+                <a:ea typeface="Consolas"/>
+                <a:cs typeface="Consolas"/>
+              </a:rPr>
+              <a:t>│  │  │   ├─ best_skill.md                </a:t>
+            </a:r>
+            <a:r>
+              <a:rPr sz="680" b="0">
+                <a:solidFill>
+                  <a:srgbClr val="6B7280"/>
+                </a:solidFill>
+                <a:latin typeface="Microsoft YaHei"/>
+                <a:ea typeface="Microsoft YaHei"/>
+                <a:cs typeface="Microsoft YaHei"/>
+              </a:rPr>
+              <a:t># SkillOpt 优化出的“正本”</a:t>
+            </a:r>
+          </a:p>
+          <a:p>
+            <a:pPr algn="l">
+              <a:spcBef>
+                <a:spcPts val="0"/>
+              </a:spcBef>
+              <a:spcAft>
+                <a:spcPts val="75"/>
+              </a:spcAft>
+            </a:pPr>
+            <a:r>
+              <a:rPr sz="720" b="0">
+                <a:solidFill>
+                  <a:srgbClr val="1F2937"/>
+                </a:solidFill>
+                <a:latin typeface="Consolas"/>
+                <a:ea typeface="Consolas"/>
+                <a:cs typeface="Consolas"/>
+              </a:rPr>
+              <a:t>│  │  │   ├─ evals/                       </a:t>
+            </a:r>
+            <a:r>
+              <a:rPr sz="680" b="0">
+                <a:solidFill>
+                  <a:srgbClr val="6B7280"/>
+                </a:solidFill>
+                <a:latin typeface="Microsoft YaHei"/>
+                <a:ea typeface="Microsoft YaHei"/>
+                <a:cs typeface="Microsoft YaHei"/>
+              </a:rPr>
+              <a:t># 技能内·私有评测:用哪套题 + 留出用例</a:t>
+            </a:r>
+          </a:p>
+          <a:p>
+            <a:pPr algn="l">
+              <a:spcBef>
+                <a:spcPts val="0"/>
+              </a:spcBef>
+              <a:spcAft>
+                <a:spcPts val="75"/>
+              </a:spcAft>
+            </a:pPr>
+            <a:r>
+              <a:rPr sz="720" b="0">
+                <a:solidFill>
+                  <a:srgbClr val="1F2937"/>
+                </a:solidFill>
+                <a:latin typeface="Consolas"/>
+                <a:ea typeface="Consolas"/>
+                <a:cs typeface="Consolas"/>
+              </a:rPr>
+              <a:t>│  │  │   ├─ candidates/                  </a:t>
+            </a:r>
+            <a:r>
+              <a:rPr sz="680" b="0">
+                <a:solidFill>
+                  <a:srgbClr val="6B7280"/>
+                </a:solidFill>
+                <a:latin typeface="Microsoft YaHei"/>
+                <a:ea typeface="Microsoft YaHei"/>
+                <a:cs typeface="Microsoft YaHei"/>
+              </a:rPr>
+              <a:t># Pareto 前沿:互补候选(防塌缩)</a:t>
+            </a:r>
+          </a:p>
+          <a:p>
+            <a:pPr algn="l">
+              <a:spcBef>
+                <a:spcPts val="0"/>
+              </a:spcBef>
+              <a:spcAft>
+                <a:spcPts val="75"/>
+              </a:spcAft>
+            </a:pPr>
+            <a:r>
+              <a:rPr sz="720" b="0">
+                <a:solidFill>
+                  <a:srgbClr val="1F2937"/>
+                </a:solidFill>
+                <a:latin typeface="Consolas"/>
+                <a:ea typeface="Consolas"/>
+                <a:cs typeface="Consolas"/>
+              </a:rPr>
+              <a:t>│  │  │   ├─ scorecards/                  </a:t>
+            </a:r>
+            <a:r>
+              <a:rPr sz="680" b="0">
+                <a:solidFill>
+                  <a:srgbClr val="6B7280"/>
+                </a:solidFill>
+                <a:latin typeface="Microsoft YaHei"/>
+                <a:ea typeface="Microsoft YaHei"/>
+                <a:cs typeface="Microsoft YaHei"/>
+              </a:rPr>
+              <a:t># 本技能历次 A/B 跑分</a:t>
+            </a:r>
+          </a:p>
+          <a:p>
+            <a:pPr algn="l">
+              <a:spcBef>
+                <a:spcPts val="0"/>
+              </a:spcBef>
+              <a:spcAft>
+                <a:spcPts val="75"/>
+              </a:spcAft>
+            </a:pPr>
+            <a:r>
+              <a:rPr sz="720" b="0">
+                <a:solidFill>
+                  <a:srgbClr val="1F2937"/>
+                </a:solidFill>
+                <a:latin typeface="Consolas"/>
+                <a:ea typeface="Consolas"/>
+                <a:cs typeface="Consolas"/>
+              </a:rPr>
+              <a:t>│  │  │   └─ references/                  </a:t>
+            </a:r>
+            <a:r>
+              <a:rPr sz="680" b="0">
+                <a:solidFill>
+                  <a:srgbClr val="6B7280"/>
+                </a:solidFill>
+                <a:latin typeface="Microsoft YaHei"/>
+                <a:ea typeface="Microsoft YaHei"/>
+                <a:cs typeface="Microsoft YaHei"/>
+              </a:rPr>
+              <a:t># 重材料(按需加载)</a:t>
+            </a:r>
+          </a:p>
+          <a:p>
+            <a:pPr algn="l">
+              <a:spcBef>
+                <a:spcPts val="0"/>
+              </a:spcBef>
+              <a:spcAft>
+                <a:spcPts val="75"/>
+              </a:spcAft>
+            </a:pPr>
+            <a:r>
+              <a:rPr sz="720" b="0">
+                <a:solidFill>
+                  <a:srgbClr val="1F2937"/>
+                </a:solidFill>
+                <a:latin typeface="Consolas"/>
+                <a:ea typeface="Consolas"/>
+                <a:cs typeface="Consolas"/>
+              </a:rPr>
+              <a:t>│  │  └─ stage-gate-enforcement/          </a:t>
+            </a:r>
+            <a:r>
+              <a:rPr sz="680" b="0">
+                <a:solidFill>
+                  <a:srgbClr val="6B7280"/>
+                </a:solidFill>
+                <a:latin typeface="Microsoft YaHei"/>
+                <a:ea typeface="Microsoft YaHei"/>
+                <a:cs typeface="Microsoft YaHei"/>
+              </a:rPr>
+              <a:t># 例:阶段门禁强制</a:t>
+            </a:r>
+          </a:p>
+          <a:p>
+            <a:pPr algn="l">
+              <a:spcBef>
+                <a:spcPts val="0"/>
+              </a:spcBef>
+              <a:spcAft>
+                <a:spcPts val="75"/>
+              </a:spcAft>
+            </a:pPr>
+            <a:r>
+              <a:rPr sz="720" b="0">
+                <a:solidFill>
+                  <a:srgbClr val="1F2937"/>
+                </a:solidFill>
+                <a:latin typeface="Consolas"/>
+                <a:ea typeface="Consolas"/>
+                <a:cs typeface="Consolas"/>
+              </a:rPr>
+              <a:t>│  ├─ technique/                          </a:t>
+            </a:r>
+            <a:r>
+              <a:rPr sz="680" b="0">
+                <a:solidFill>
+                  <a:srgbClr val="6B7280"/>
+                </a:solidFill>
+                <a:latin typeface="Microsoft YaHei"/>
+                <a:ea typeface="Microsoft YaHei"/>
+                <a:cs typeface="Microsoft YaHei"/>
+              </a:rPr>
+              <a:t># 优化招式 · 按 mechanism 命名</a:t>
+            </a:r>
+          </a:p>
+          <a:p>
+            <a:pPr algn="l">
+              <a:spcBef>
+                <a:spcPts val="0"/>
+              </a:spcBef>
+              <a:spcAft>
+                <a:spcPts val="75"/>
+              </a:spcAft>
+            </a:pPr>
+            <a:r>
+              <a:rPr sz="720" b="0">
+                <a:solidFill>
+                  <a:srgbClr val="1F2937"/>
+                </a:solidFill>
+                <a:latin typeface="Consolas"/>
+                <a:ea typeface="Consolas"/>
+                <a:cs typeface="Consolas"/>
+              </a:rPr>
+              <a:t>│  │  ├─ hoist-loop-invariant/            </a:t>
+            </a:r>
+            <a:r>
+              <a:rPr sz="680" b="0">
+                <a:solidFill>
+                  <a:srgbClr val="6B7280"/>
+                </a:solidFill>
+                <a:latin typeface="Microsoft YaHei"/>
+                <a:ea typeface="Microsoft YaHei"/>
+                <a:cs typeface="Microsoft YaHei"/>
+              </a:rPr>
+              <a:t># 例:循环不变量外提</a:t>
+            </a:r>
+          </a:p>
+          <a:p>
+            <a:pPr algn="l">
+              <a:spcBef>
+                <a:spcPts val="0"/>
+              </a:spcBef>
+              <a:spcAft>
+                <a:spcPts val="75"/>
+              </a:spcAft>
+            </a:pPr>
+            <a:r>
+              <a:rPr sz="720" b="0">
+                <a:solidFill>
+                  <a:srgbClr val="1F2937"/>
+                </a:solidFill>
+                <a:latin typeface="Consolas"/>
+                <a:ea typeface="Consolas"/>
+                <a:cs typeface="Consolas"/>
+              </a:rPr>
+              <a:t>│  │  └─ batch-coalescing/                </a:t>
+            </a:r>
+            <a:r>
+              <a:rPr sz="680" b="0">
+                <a:solidFill>
+                  <a:srgbClr val="6B7280"/>
+                </a:solidFill>
+                <a:latin typeface="Microsoft YaHei"/>
+                <a:ea typeface="Microsoft YaHei"/>
+                <a:cs typeface="Microsoft YaHei"/>
+              </a:rPr>
+              <a:t># 例:批量合并写</a:t>
+            </a:r>
+          </a:p>
+          <a:p>
+            <a:pPr algn="l">
+              <a:spcBef>
+                <a:spcPts val="0"/>
+              </a:spcBef>
+              <a:spcAft>
+                <a:spcPts val="75"/>
+              </a:spcAft>
+            </a:pPr>
+            <a:r>
+              <a:rPr sz="720" b="0">
+                <a:solidFill>
+                  <a:srgbClr val="1F2937"/>
+                </a:solidFill>
+                <a:latin typeface="Consolas"/>
+                <a:ea typeface="Consolas"/>
+                <a:cs typeface="Consolas"/>
+              </a:rPr>
+              <a:t>│  ├─ domain/                             </a:t>
+            </a:r>
+            <a:r>
+              <a:rPr sz="680" b="0">
+                <a:solidFill>
+                  <a:srgbClr val="6B7280"/>
+                </a:solidFill>
+                <a:latin typeface="Microsoft YaHei"/>
+                <a:ea typeface="Microsoft YaHei"/>
+                <a:cs typeface="Microsoft YaHei"/>
+              </a:rPr>
+              <a:t># 按子系统(唯一触及代码结构)</a:t>
+            </a:r>
+          </a:p>
+          <a:p>
+            <a:pPr algn="l">
+              <a:spcBef>
+                <a:spcPts val="0"/>
+              </a:spcBef>
+              <a:spcAft>
+                <a:spcPts val="75"/>
+              </a:spcAft>
+            </a:pPr>
+            <a:r>
+              <a:rPr sz="720" b="0">
+                <a:solidFill>
+                  <a:srgbClr val="1F2937"/>
+                </a:solidFill>
+                <a:latin typeface="Consolas"/>
+                <a:ea typeface="Consolas"/>
+                <a:cs typeface="Consolas"/>
+              </a:rPr>
+              <a:t>│  │  ├─ mm-reclaim/                      </a:t>
+            </a:r>
+            <a:r>
+              <a:rPr sz="680" b="0">
+                <a:solidFill>
+                  <a:srgbClr val="6B7280"/>
+                </a:solidFill>
+                <a:latin typeface="Microsoft YaHei"/>
+                <a:ea typeface="Microsoft YaHei"/>
+                <a:cs typeface="Microsoft YaHei"/>
+              </a:rPr>
+              <a:t># 例:内存回收(SKILL.md + references/)</a:t>
+            </a:r>
+          </a:p>
+          <a:p>
+            <a:pPr algn="l">
+              <a:spcBef>
+                <a:spcPts val="0"/>
+              </a:spcBef>
+              <a:spcAft>
+                <a:spcPts val="75"/>
+              </a:spcAft>
+            </a:pPr>
+            <a:r>
+              <a:rPr sz="720" b="0">
+                <a:solidFill>
+                  <a:srgbClr val="1F2937"/>
+                </a:solidFill>
+                <a:latin typeface="Consolas"/>
+                <a:ea typeface="Consolas"/>
+                <a:cs typeface="Consolas"/>
+              </a:rPr>
+              <a:t>│  │  └─ hyperhold-io/                    </a:t>
+            </a:r>
+            <a:r>
+              <a:rPr sz="680" b="0">
+                <a:solidFill>
+                  <a:srgbClr val="6B7280"/>
+                </a:solidFill>
+                <a:latin typeface="Microsoft YaHei"/>
+                <a:ea typeface="Microsoft YaHei"/>
+                <a:cs typeface="Microsoft YaHei"/>
+              </a:rPr>
+              <a:t># 例:hyperhold I/O 路径</a:t>
+            </a:r>
+          </a:p>
+          <a:p>
+            <a:pPr algn="l">
+              <a:spcBef>
+                <a:spcPts val="0"/>
+              </a:spcBef>
+              <a:spcAft>
+                <a:spcPts val="75"/>
+              </a:spcAft>
+            </a:pPr>
+            <a:r>
+              <a:rPr sz="720" b="0">
+                <a:solidFill>
+                  <a:srgbClr val="1F2937"/>
+                </a:solidFill>
+                <a:latin typeface="Consolas"/>
+                <a:ea typeface="Consolas"/>
+                <a:cs typeface="Consolas"/>
+              </a:rPr>
+              <a:t>│  └─ _registry/skills.yaml               </a:t>
+            </a:r>
+            <a:r>
+              <a:rPr sz="680" b="0">
+                <a:solidFill>
+                  <a:srgbClr val="6B7280"/>
+                </a:solidFill>
+                <a:latin typeface="Microsoft YaHei"/>
+                <a:ea typeface="Microsoft YaHei"/>
+                <a:cs typeface="Microsoft YaHei"/>
+              </a:rPr>
+              <a:t># 全量索引 + 子系统选择器</a:t>
+            </a:r>
+          </a:p>
+          <a:p>
+            <a:pPr algn="l">
+              <a:spcBef>
+                <a:spcPts val="0"/>
+              </a:spcBef>
+              <a:spcAft>
+                <a:spcPts val="75"/>
+              </a:spcAft>
+            </a:pPr>
+            <a:r>
+              <a:rPr sz="720" b="0">
+                <a:solidFill>
+                  <a:srgbClr val="1F2937"/>
+                </a:solidFill>
+                <a:latin typeface="Consolas"/>
+                <a:ea typeface="Consolas"/>
+                <a:cs typeface="Consolas"/>
+              </a:rPr>
+              <a:t>├─ agents/                                </a:t>
+            </a:r>
+            <a:r>
+              <a:rPr sz="680" b="0">
+                <a:solidFill>
+                  <a:srgbClr val="6B7280"/>
+                </a:solidFill>
+                <a:latin typeface="Microsoft YaHei"/>
+                <a:ea typeface="Microsoft YaHei"/>
+                <a:cs typeface="Microsoft YaHei"/>
+              </a:rPr>
+              <a:t># 角色定义(procedural · 评审制·非 eval)</a:t>
+            </a:r>
+          </a:p>
+          <a:p>
+            <a:pPr algn="l">
+              <a:spcBef>
+                <a:spcPts val="0"/>
+              </a:spcBef>
+              <a:spcAft>
+                <a:spcPts val="75"/>
+              </a:spcAft>
+            </a:pPr>
+            <a:r>
+              <a:rPr sz="720" b="0">
+                <a:solidFill>
+                  <a:srgbClr val="1F2937"/>
+                </a:solidFill>
+                <a:latin typeface="Consolas"/>
+                <a:ea typeface="Consolas"/>
+                <a:cs typeface="Consolas"/>
+              </a:rPr>
+              <a:t>│  ├─ os-opt-manager.md                   </a:t>
+            </a:r>
+            <a:r>
+              <a:rPr sz="680" b="0">
+                <a:solidFill>
+                  <a:srgbClr val="6B7280"/>
+                </a:solidFill>
+                <a:latin typeface="Microsoft YaHei"/>
+                <a:ea typeface="Microsoft YaHei"/>
+                <a:cs typeface="Microsoft YaHei"/>
+              </a:rPr>
+              <a:t># Conductor 总调度</a:t>
+            </a:r>
+          </a:p>
+          <a:p>
+            <a:pPr algn="l">
+              <a:spcBef>
+                <a:spcPts val="0"/>
+              </a:spcBef>
+              <a:spcAft>
+                <a:spcPts val="75"/>
+              </a:spcAft>
+            </a:pPr>
+            <a:r>
+              <a:rPr sz="720" b="0">
+                <a:solidFill>
+                  <a:srgbClr val="1F2937"/>
+                </a:solidFill>
+                <a:latin typeface="Consolas"/>
+                <a:ea typeface="Consolas"/>
+                <a:cs typeface="Consolas"/>
+              </a:rPr>
+              <a:t>│  ├─ kernel-code-agent.md                </a:t>
+            </a:r>
+            <a:r>
+              <a:rPr sz="680" b="0">
+                <a:solidFill>
+                  <a:srgbClr val="6B7280"/>
+                </a:solidFill>
+                <a:latin typeface="Microsoft YaHei"/>
+                <a:ea typeface="Microsoft YaHei"/>
+                <a:cs typeface="Microsoft YaHei"/>
+              </a:rPr>
+              <a:t># Coder 改代码</a:t>
+            </a:r>
+          </a:p>
+          <a:p>
+            <a:pPr algn="l">
+              <a:spcBef>
+                <a:spcPts val="0"/>
+              </a:spcBef>
+              <a:spcAft>
+                <a:spcPts val="75"/>
+              </a:spcAft>
+            </a:pPr>
+            <a:r>
+              <a:rPr sz="720" b="0">
+                <a:solidFill>
+                  <a:srgbClr val="1F2937"/>
+                </a:solidFill>
+                <a:latin typeface="Consolas"/>
+                <a:ea typeface="Consolas"/>
+                <a:cs typeface="Consolas"/>
+              </a:rPr>
+              <a:t>│  ├─ kernel-reviewer.md                  </a:t>
+            </a:r>
+            <a:r>
+              <a:rPr sz="680" b="0">
+                <a:solidFill>
+                  <a:srgbClr val="6B7280"/>
+                </a:solidFill>
+                <a:latin typeface="Microsoft YaHei"/>
+                <a:ea typeface="Microsoft YaHei"/>
+                <a:cs typeface="Microsoft YaHei"/>
+              </a:rPr>
+              <a:t># Reviewer 代码评审</a:t>
+            </a:r>
+          </a:p>
+          <a:p>
+            <a:pPr algn="l">
+              <a:spcBef>
+                <a:spcPts val="0"/>
+              </a:spcBef>
+              <a:spcAft>
+                <a:spcPts val="75"/>
+              </a:spcAft>
+            </a:pPr>
+            <a:r>
+              <a:rPr sz="720" b="0">
+                <a:solidFill>
+                  <a:srgbClr val="1F2937"/>
+                </a:solidFill>
+                <a:latin typeface="Consolas"/>
+                <a:ea typeface="Consolas"/>
+                <a:cs typeface="Consolas"/>
+              </a:rPr>
+              <a:t>│  ├─ kernel-research.md                  </a:t>
+            </a:r>
+            <a:r>
+              <a:rPr sz="680" b="0">
+                <a:solidFill>
+                  <a:srgbClr val="6B7280"/>
+                </a:solidFill>
+                <a:latin typeface="Microsoft YaHei"/>
+                <a:ea typeface="Microsoft YaHei"/>
+                <a:cs typeface="Microsoft YaHei"/>
+              </a:rPr>
+              <a:t># 研究 / 溯源</a:t>
+            </a:r>
+          </a:p>
+          <a:p>
+            <a:pPr algn="l">
+              <a:spcBef>
+                <a:spcPts val="0"/>
+              </a:spcBef>
+              <a:spcAft>
+                <a:spcPts val="75"/>
+              </a:spcAft>
+            </a:pPr>
+            <a:r>
+              <a:rPr sz="720" b="0">
+                <a:solidFill>
+                  <a:srgbClr val="1F2937"/>
+                </a:solidFill>
+                <a:latin typeface="Consolas"/>
+                <a:ea typeface="Consolas"/>
+                <a:cs typeface="Consolas"/>
+              </a:rPr>
+              <a:t>│  └─ kernel-tester-agent.md · *-opt.md   </a:t>
+            </a:r>
+            <a:r>
+              <a:rPr sz="680" b="0">
+                <a:solidFill>
+                  <a:srgbClr val="6B7280"/>
+                </a:solidFill>
+                <a:latin typeface="Microsoft YaHei"/>
+                <a:ea typeface="Microsoft YaHei"/>
+                <a:cs typeface="Microsoft YaHei"/>
+              </a:rPr>
+              <a:t># Verifier + 各子系统角色</a:t>
+            </a:r>
+          </a:p>
+          <a:p>
+            <a:pPr algn="l">
+              <a:spcBef>
+                <a:spcPts val="0"/>
+              </a:spcBef>
+              <a:spcAft>
+                <a:spcPts val="75"/>
+              </a:spcAft>
+            </a:pPr>
+            <a:r>
+              <a:rPr sz="720" b="0">
+                <a:solidFill>
+                  <a:srgbClr val="1F2937"/>
+                </a:solidFill>
+                <a:latin typeface="Consolas"/>
+                <a:ea typeface="Consolas"/>
+                <a:cs typeface="Consolas"/>
+              </a:rPr>
+              <a:t>├─ commands/                              </a:t>
+            </a:r>
+            <a:r>
+              <a:rPr sz="680" b="0">
+                <a:solidFill>
+                  <a:srgbClr val="6B7280"/>
+                </a:solidFill>
+                <a:latin typeface="Microsoft YaHei"/>
+                <a:ea typeface="Microsoft YaHei"/>
+                <a:cs typeface="Microsoft YaHei"/>
+              </a:rPr>
+              <a:t># slash 命令入口(procedural)</a:t>
+            </a:r>
+          </a:p>
+          <a:p>
+            <a:pPr algn="l">
+              <a:spcBef>
+                <a:spcPts val="0"/>
+              </a:spcBef>
+              <a:spcAft>
+                <a:spcPts val="75"/>
+              </a:spcAft>
+            </a:pPr>
+            <a:r>
+              <a:rPr sz="720" b="0">
+                <a:solidFill>
+                  <a:srgbClr val="1F2937"/>
+                </a:solidFill>
+                <a:latin typeface="Consolas"/>
+                <a:ea typeface="Consolas"/>
+                <a:cs typeface="Consolas"/>
+              </a:rPr>
+              <a:t>│  ├─ optimize_*.md                       </a:t>
+            </a:r>
+            <a:r>
+              <a:rPr sz="680" b="0">
+                <a:solidFill>
+                  <a:srgbClr val="6B7280"/>
+                </a:solidFill>
+                <a:latin typeface="Microsoft YaHei"/>
+                <a:ea typeface="Microsoft YaHei"/>
+                <a:cs typeface="Microsoft YaHei"/>
+              </a:rPr>
+              <a:t># generic/hyperhold/memmgr/workqueue</a:t>
+            </a:r>
+          </a:p>
+          <a:p>
+            <a:pPr algn="l">
+              <a:spcBef>
+                <a:spcPts val="0"/>
+              </a:spcBef>
+              <a:spcAft>
+                <a:spcPts val="75"/>
+              </a:spcAft>
+            </a:pPr>
+            <a:r>
+              <a:rPr sz="720" b="0">
+                <a:solidFill>
+                  <a:srgbClr val="1F2937"/>
+                </a:solidFill>
+                <a:latin typeface="Consolas"/>
+                <a:ea typeface="Consolas"/>
+                <a:cs typeface="Consolas"/>
+              </a:rPr>
+              <a:t>│  └─ research.md · plan.md · review_sync.md · function_detail.md</a:t>
+            </a:r>
+          </a:p>
+          <a:p>
+            <a:pPr algn="l">
+              <a:spcBef>
+                <a:spcPts val="0"/>
+              </a:spcBef>
+              <a:spcAft>
+                <a:spcPts val="75"/>
+              </a:spcAft>
+            </a:pPr>
+            <a:r>
+              <a:rPr sz="720" b="0">
+                <a:solidFill>
+                  <a:srgbClr val="1F2937"/>
+                </a:solidFill>
+                <a:latin typeface="Consolas"/>
+                <a:ea typeface="Consolas"/>
+                <a:cs typeface="Consolas"/>
+              </a:rPr>
+              <a:t>├─ pipelines/                             </a:t>
+            </a:r>
+            <a:r>
+              <a:rPr sz="680" b="0">
+                <a:solidFill>
+                  <a:srgbClr val="6B7280"/>
+                </a:solidFill>
+                <a:latin typeface="Microsoft YaHei"/>
+                <a:ea typeface="Microsoft YaHei"/>
+                <a:cs typeface="Microsoft YaHei"/>
+              </a:rPr>
+              <a:t># 流水线预设 profile(procedural)</a:t>
+            </a:r>
+          </a:p>
+          <a:p>
+            <a:pPr algn="l">
+              <a:spcBef>
+                <a:spcPts val="0"/>
+              </a:spcBef>
+              <a:spcAft>
+                <a:spcPts val="75"/>
+              </a:spcAft>
+            </a:pPr>
+            <a:r>
+              <a:rPr sz="720" b="0">
+                <a:solidFill>
+                  <a:srgbClr val="1F2937"/>
+                </a:solidFill>
+                <a:latin typeface="Consolas"/>
+                <a:ea typeface="Consolas"/>
+                <a:cs typeface="Consolas"/>
+              </a:rPr>
+              <a:t>│  └─ generic_full · hyperhold_full · memmgr_reclaim_full · sync_review · workqueue_full</a:t>
+            </a:r>
+          </a:p>
+          <a:p>
+            <a:pPr algn="l">
+              <a:spcBef>
+                <a:spcPts val="0"/>
+              </a:spcBef>
+              <a:spcAft>
+                <a:spcPts val="75"/>
+              </a:spcAft>
+            </a:pPr>
+            <a:r>
+              <a:rPr sz="720" b="0">
+                <a:solidFill>
+                  <a:srgbClr val="1F2937"/>
+                </a:solidFill>
+                <a:latin typeface="Consolas"/>
+                <a:ea typeface="Consolas"/>
+                <a:cs typeface="Consolas"/>
+              </a:rPr>
+              <a:t>├─ docs/                                  </a:t>
+            </a:r>
+            <a:r>
+              <a:rPr sz="680" b="0">
+                <a:solidFill>
+                  <a:srgbClr val="6B7280"/>
+                </a:solidFill>
+                <a:latin typeface="Microsoft YaHei"/>
+                <a:ea typeface="Microsoft YaHei"/>
+                <a:cs typeface="Microsoft YaHei"/>
+              </a:rPr>
+              <a:t># harness 规范(procedural · 原 .opencode/CLAUDE.md)</a:t>
+            </a:r>
+          </a:p>
+          <a:p>
+            <a:pPr algn="l">
+              <a:spcBef>
+                <a:spcPts val="0"/>
+              </a:spcBef>
+              <a:spcAft>
+                <a:spcPts val="75"/>
+              </a:spcAft>
+            </a:pPr>
+            <a:r>
+              <a:rPr sz="720" b="0">
+                <a:solidFill>
+                  <a:srgbClr val="1F2937"/>
+                </a:solidFill>
+                <a:latin typeface="Consolas"/>
+                <a:ea typeface="Consolas"/>
+                <a:cs typeface="Consolas"/>
+              </a:rPr>
+              <a:t>│  ├─ harness_engineer_system.md          </a:t>
+            </a:r>
+            <a:r>
+              <a:rPr sz="680" b="0">
+                <a:solidFill>
+                  <a:srgbClr val="6B7280"/>
+                </a:solidFill>
+                <a:latin typeface="Microsoft YaHei"/>
+                <a:ea typeface="Microsoft YaHei"/>
+                <a:cs typeface="Microsoft YaHei"/>
+              </a:rPr>
+              <a:t># 工程系统规范</a:t>
+            </a:r>
+          </a:p>
+          <a:p>
+            <a:pPr algn="l">
+              <a:spcBef>
+                <a:spcPts val="0"/>
+              </a:spcBef>
+              <a:spcAft>
+                <a:spcPts val="75"/>
+              </a:spcAft>
+            </a:pPr>
+            <a:r>
+              <a:rPr sz="720" b="0">
+                <a:solidFill>
+                  <a:srgbClr val="1F2937"/>
+                </a:solidFill>
+                <a:latin typeface="Consolas"/>
+                <a:ea typeface="Consolas"/>
+                <a:cs typeface="Consolas"/>
+              </a:rPr>
+              <a:t>│  └─ memory_system.md                    </a:t>
+            </a:r>
+            <a:r>
+              <a:rPr sz="680" b="0">
+                <a:solidFill>
+                  <a:srgbClr val="6B7280"/>
+                </a:solidFill>
+                <a:latin typeface="Microsoft YaHei"/>
+                <a:ea typeface="Microsoft YaHei"/>
+                <a:cs typeface="Microsoft YaHei"/>
+              </a:rPr>
+              <a:t># 记忆系统规范</a:t>
+            </a:r>
+          </a:p>
+          <a:p>
+            <a:pPr algn="l">
+              <a:spcBef>
+                <a:spcPts val="0"/>
+              </a:spcBef>
+              <a:spcAft>
+                <a:spcPts val="75"/>
+              </a:spcAft>
+            </a:pPr>
+            <a:r>
+              <a:rPr sz="720" b="0">
+                <a:solidFill>
+                  <a:srgbClr val="1F2937"/>
+                </a:solidFill>
+                <a:latin typeface="Consolas"/>
+                <a:ea typeface="Consolas"/>
+                <a:cs typeface="Consolas"/>
+              </a:rPr>
+              <a:t>├─ knowledge/                             </a:t>
+            </a:r>
+            <a:r>
+              <a:rPr sz="680" b="0">
+                <a:solidFill>
+                  <a:srgbClr val="6B7280"/>
+                </a:solidFill>
+                <a:latin typeface="Microsoft YaHei"/>
+                <a:ea typeface="Microsoft YaHei"/>
+                <a:cs typeface="Microsoft YaHei"/>
+              </a:rPr>
+              <a:t># 知识(引擎A · 分层 · 每条一文件)</a:t>
+            </a:r>
+          </a:p>
+          <a:p>
+            <a:pPr algn="l">
+              <a:spcBef>
+                <a:spcPts val="0"/>
+              </a:spcBef>
+              <a:spcAft>
+                <a:spcPts val="75"/>
+              </a:spcAft>
+            </a:pPr>
+            <a:r>
+              <a:rPr sz="720" b="0">
+                <a:solidFill>
+                  <a:srgbClr val="1F2937"/>
+                </a:solidFill>
+                <a:latin typeface="Consolas"/>
+                <a:ea typeface="Consolas"/>
+                <a:cs typeface="Consolas"/>
+              </a:rPr>
+              <a:t>│  ├─ global/{lessons,anti_patterns}/     </a:t>
+            </a:r>
+            <a:r>
+              <a:rPr sz="680" b="0">
+                <a:solidFill>
+                  <a:srgbClr val="6B7280"/>
+                </a:solidFill>
+                <a:latin typeface="Microsoft YaHei"/>
+                <a:ea typeface="Microsoft YaHei"/>
+                <a:cs typeface="Microsoft YaHei"/>
+              </a:rPr>
+              <a:t># 例:G012_* / A007_*</a:t>
+            </a:r>
+          </a:p>
+          <a:p>
+            <a:pPr algn="l">
+              <a:spcBef>
+                <a:spcPts val="0"/>
+              </a:spcBef>
+              <a:spcAft>
+                <a:spcPts val="75"/>
+              </a:spcAft>
+            </a:pPr>
+            <a:r>
+              <a:rPr sz="720" b="0">
+                <a:solidFill>
+                  <a:srgbClr val="1F2937"/>
+                </a:solidFill>
+                <a:latin typeface="Consolas"/>
+                <a:ea typeface="Consolas"/>
+                <a:cs typeface="Consolas"/>
+              </a:rPr>
+              <a:t>│  ├─ subsystems/&lt;s&gt;.md · targets/&lt;slug&gt;/{facts,decisions,idea_ledger}</a:t>
+            </a:r>
+          </a:p>
+          <a:p>
+            <a:pPr algn="l">
+              <a:spcBef>
+                <a:spcPts val="0"/>
+              </a:spcBef>
+              <a:spcAft>
+                <a:spcPts val="75"/>
+              </a:spcAft>
+            </a:pPr>
+            <a:r>
+              <a:rPr sz="720" b="0">
+                <a:solidFill>
+                  <a:srgbClr val="1F2937"/>
+                </a:solidFill>
+                <a:latin typeface="Consolas"/>
+                <a:ea typeface="Consolas"/>
+                <a:cs typeface="Consolas"/>
+              </a:rPr>
+              <a:t>│  └─ index/                              </a:t>
+            </a:r>
+            <a:r>
+              <a:rPr sz="680" b="0">
+                <a:solidFill>
+                  <a:srgbClr val="6B7280"/>
+                </a:solidFill>
+                <a:latin typeface="Microsoft YaHei"/>
+                <a:ea typeface="Microsoft YaHei"/>
+                <a:cs typeface="Microsoft YaHei"/>
+              </a:rPr>
+              <a:t># 向量检索索引</a:t>
+            </a:r>
+          </a:p>
+          <a:p>
+            <a:pPr algn="l">
+              <a:spcBef>
+                <a:spcPts val="0"/>
+              </a:spcBef>
+              <a:spcAft>
+                <a:spcPts val="75"/>
+              </a:spcAft>
+            </a:pPr>
+            <a:r>
+              <a:rPr sz="720" b="0">
+                <a:solidFill>
+                  <a:srgbClr val="1F2937"/>
+                </a:solidFill>
+                <a:latin typeface="Consolas"/>
+                <a:ea typeface="Consolas"/>
+                <a:cs typeface="Consolas"/>
+              </a:rPr>
+              <a:t>├─ evidence/                              </a:t>
+            </a:r>
+            <a:r>
+              <a:rPr sz="680" b="0">
+                <a:solidFill>
+                  <a:srgbClr val="6B7280"/>
+                </a:solidFill>
+                <a:latin typeface="Microsoft YaHei"/>
+                <a:ea typeface="Microsoft YaHei"/>
+                <a:cs typeface="Microsoft YaHei"/>
+              </a:rPr>
+              <a:t># 可复核证据(每条回链来源)</a:t>
+            </a:r>
+          </a:p>
+          <a:p>
+            <a:pPr algn="l">
+              <a:spcBef>
+                <a:spcPts val="0"/>
+              </a:spcBef>
+              <a:spcAft>
+                <a:spcPts val="75"/>
+              </a:spcAft>
+            </a:pPr>
+            <a:r>
+              <a:rPr sz="720" b="0">
+                <a:solidFill>
+                  <a:srgbClr val="1F2937"/>
+                </a:solidFill>
+                <a:latin typeface="Consolas"/>
+                <a:ea typeface="Consolas"/>
+                <a:cs typeface="Consolas"/>
+              </a:rPr>
+              <a:t>│  ├─ benchmarks/                         </a:t>
+            </a:r>
+            <a:r>
+              <a:rPr sz="680" b="0">
+                <a:solidFill>
+                  <a:srgbClr val="6B7280"/>
+                </a:solidFill>
+                <a:latin typeface="Microsoft YaHei"/>
+                <a:ea typeface="Microsoft YaHei"/>
+                <a:cs typeface="Microsoft YaHei"/>
+              </a:rPr>
+              <a:t># 例:mm-reclaim_2026Q2.json</a:t>
+            </a:r>
+          </a:p>
+          <a:p>
+            <a:pPr algn="l">
+              <a:spcBef>
+                <a:spcPts val="0"/>
+              </a:spcBef>
+              <a:spcAft>
+                <a:spcPts val="75"/>
+              </a:spcAft>
+            </a:pPr>
+            <a:r>
+              <a:rPr sz="720" b="0">
+                <a:solidFill>
+                  <a:srgbClr val="1F2937"/>
+                </a:solidFill>
+                <a:latin typeface="Consolas"/>
+                <a:ea typeface="Consolas"/>
+                <a:cs typeface="Consolas"/>
+              </a:rPr>
+              <a:t>│  └─ regressions/                        </a:t>
+            </a:r>
+            <a:r>
+              <a:rPr sz="680" b="0">
+                <a:solidFill>
+                  <a:srgbClr val="6B7280"/>
+                </a:solidFill>
+                <a:latin typeface="Microsoft YaHei"/>
+                <a:ea typeface="Microsoft YaHei"/>
+                <a:cs typeface="Microsoft YaHei"/>
+              </a:rPr>
+              <a:t># 例:R031_shrink_node.json</a:t>
+            </a:r>
+          </a:p>
+          <a:p>
+            <a:pPr algn="l">
+              <a:spcBef>
+                <a:spcPts val="0"/>
+              </a:spcBef>
+              <a:spcAft>
+                <a:spcPts val="75"/>
+              </a:spcAft>
+            </a:pPr>
+            <a:r>
+              <a:rPr sz="720" b="0">
+                <a:solidFill>
+                  <a:srgbClr val="1F2937"/>
+                </a:solidFill>
+                <a:latin typeface="Consolas"/>
+                <a:ea typeface="Consolas"/>
+                <a:cs typeface="Consolas"/>
+              </a:rPr>
+              <a:t>├─ eval/                                  </a:t>
+            </a:r>
+            <a:r>
+              <a:rPr sz="680" b="0">
+                <a:solidFill>
+                  <a:srgbClr val="6B7280"/>
+                </a:solidFill>
+                <a:latin typeface="Microsoft YaHei"/>
+                <a:ea typeface="Microsoft YaHei"/>
+                <a:cs typeface="Microsoft YaHei"/>
+              </a:rPr>
+              <a:t># 顶层·团队共享评测(≠ 技能内 evals/)</a:t>
+            </a:r>
+          </a:p>
+          <a:p>
+            <a:pPr algn="l">
+              <a:spcBef>
+                <a:spcPts val="0"/>
+              </a:spcBef>
+              <a:spcAft>
+                <a:spcPts val="75"/>
+              </a:spcAft>
+            </a:pPr>
+            <a:r>
+              <a:rPr sz="720" b="0">
+                <a:solidFill>
+                  <a:srgbClr val="1F2937"/>
+                </a:solidFill>
+                <a:latin typeface="Consolas"/>
+                <a:ea typeface="Consolas"/>
+                <a:cs typeface="Consolas"/>
+              </a:rPr>
+              <a:t>│  ├─ task_suites/                        </a:t>
+            </a:r>
+            <a:r>
+              <a:rPr sz="680" b="0">
+                <a:solidFill>
+                  <a:srgbClr val="6B7280"/>
+                </a:solidFill>
+                <a:latin typeface="Microsoft YaHei"/>
+                <a:ea typeface="Microsoft YaHei"/>
+                <a:cs typeface="Microsoft YaHei"/>
+              </a:rPr>
+              <a:t># 可复用任务集 例:mm_reclaim_suite/</a:t>
+            </a:r>
+          </a:p>
+          <a:p>
+            <a:pPr algn="l">
+              <a:spcBef>
+                <a:spcPts val="0"/>
+              </a:spcBef>
+              <a:spcAft>
+                <a:spcPts val="75"/>
+              </a:spcAft>
+            </a:pPr>
+            <a:r>
+              <a:rPr sz="720" b="0">
+                <a:solidFill>
+                  <a:srgbClr val="1F2937"/>
+                </a:solidFill>
+                <a:latin typeface="Consolas"/>
+                <a:ea typeface="Consolas"/>
+                <a:cs typeface="Consolas"/>
+              </a:rPr>
+              <a:t>│  └─ scorecards/                         </a:t>
+            </a:r>
+            <a:r>
+              <a:rPr sz="680" b="0">
+                <a:solidFill>
+                  <a:srgbClr val="6B7280"/>
+                </a:solidFill>
+                <a:latin typeface="Microsoft YaHei"/>
+                <a:ea typeface="Microsoft YaHei"/>
+                <a:cs typeface="Microsoft YaHei"/>
+              </a:rPr>
+              <a:t># 发布级评分 例:funnel_v3_*.md</a:t>
+            </a:r>
+          </a:p>
+          <a:p>
+            <a:pPr algn="l">
+              <a:spcBef>
+                <a:spcPts val="0"/>
+              </a:spcBef>
+              <a:spcAft>
+                <a:spcPts val="75"/>
+              </a:spcAft>
+            </a:pPr>
+            <a:r>
+              <a:rPr sz="720" b="0">
+                <a:solidFill>
+                  <a:srgbClr val="1F2937"/>
+                </a:solidFill>
+                <a:latin typeface="Consolas"/>
+                <a:ea typeface="Consolas"/>
+                <a:cs typeface="Consolas"/>
+              </a:rPr>
+              <a:t>├─ policies/                              </a:t>
+            </a:r>
+            <a:r>
+              <a:rPr sz="680" b="0">
+                <a:solidFill>
+                  <a:srgbClr val="6B7280"/>
+                </a:solidFill>
+                <a:latin typeface="Microsoft YaHei"/>
+                <a:ea typeface="Microsoft YaHei"/>
+                <a:cs typeface="Microsoft YaHei"/>
+              </a:rPr>
+              <a:t># promotion / merge / deprecation 规则</a:t>
+            </a:r>
+          </a:p>
+          <a:p>
+            <a:pPr algn="l">
+              <a:spcBef>
+                <a:spcPts val="0"/>
+              </a:spcBef>
+              <a:spcAft>
+                <a:spcPts val="75"/>
+              </a:spcAft>
+            </a:pPr>
+            <a:r>
+              <a:rPr sz="720" b="0">
+                <a:solidFill>
+                  <a:srgbClr val="1F2937"/>
+                </a:solidFill>
+                <a:latin typeface="Consolas"/>
+                <a:ea typeface="Consolas"/>
+                <a:cs typeface="Consolas"/>
+              </a:rPr>
+              <a:t>├─ staging/&lt;member&gt;/&lt;date&gt;/*.json         </a:t>
+            </a:r>
+            <a:r>
+              <a:rPr sz="680" b="0">
+                <a:solidFill>
+                  <a:srgbClr val="6B7280"/>
+                </a:solidFill>
+                <a:latin typeface="Microsoft YaHei"/>
+                <a:ea typeface="Microsoft YaHei"/>
+                <a:cs typeface="Microsoft YaHei"/>
+              </a:rPr>
+              <a:t># 入站候选(Tier1)</a:t>
+            </a:r>
+          </a:p>
+          <a:p>
+            <a:pPr algn="l">
+              <a:spcBef>
+                <a:spcPts val="0"/>
+              </a:spcBef>
+              <a:spcAft>
+                <a:spcPts val="75"/>
+              </a:spcAft>
+            </a:pPr>
+            <a:r>
+              <a:rPr sz="720" b="0">
+                <a:solidFill>
+                  <a:srgbClr val="1F2937"/>
+                </a:solidFill>
+                <a:latin typeface="Consolas"/>
+                <a:ea typeface="Consolas"/>
+                <a:cs typeface="Consolas"/>
+              </a:rPr>
+              <a:t>└─ tools/ · .github/workflows/ci.yml      </a:t>
+            </a:r>
+            <a:r>
+              <a:rPr sz="680" b="0">
+                <a:solidFill>
+                  <a:srgbClr val="6B7280"/>
+                </a:solidFill>
+                <a:latin typeface="Microsoft YaHei"/>
+                <a:ea typeface="Microsoft YaHei"/>
+                <a:cs typeface="Microsoft YaHei"/>
+              </a:rPr>
+              <a:t># 脚本 + CI(校验/去敏/评测闸门)</a:t>
+            </a:r>
+          </a:p>
+        </p:txBody>
+      </p:sp>
+      <p:sp>
+        <p:nvSpPr>
+          <p:cNvPr id="8" name="TextBox 7"/>
+          <p:cNvSpPr txBox="1"/>
+          <p:nvPr/>
+        </p:nvSpPr>
+        <p:spPr>
+          <a:xfrm>
+            <a:off x="7635240" y="585216"/>
+            <a:ext cx="4389120" cy="219456"/>
           </a:xfrm>
           <a:prstGeom prst="rect">
             <a:avLst/>
@@ -9247,86 +10785,381 @@
           </a:bodyPr>
           <a:lstStyle/>
           <a:p>
-            <a:pPr algn="r">
-              <a:spcBef>
-                <a:spcPts val="0"/>
-              </a:spcBef>
-              <a:spcAft>
-                <a:spcPts val="300"/>
-              </a:spcAft>
-            </a:pPr>
-            <a:r>
-              <a:rPr sz="1200" b="1">
-                <a:solidFill>
-                  <a:srgbClr val="C8D2E0"/>
-                </a:solidFill>
-                <a:latin typeface="Microsoft YaHei"/>
-                <a:ea typeface="Microsoft YaHei"/>
-                <a:cs typeface="Microsoft YaHei"/>
-              </a:rPr>
-              <a:t>06</a:t>
-            </a:r>
-          </a:p>
-        </p:txBody>
-      </p:sp>
-      <p:sp>
-        <p:nvSpPr>
-          <p:cNvPr id="7" name="Rounded Rectangle 6"/>
-          <p:cNvSpPr/>
-          <p:nvPr/>
-        </p:nvSpPr>
-        <p:spPr>
-          <a:xfrm>
-            <a:off x="411480" y="1033271"/>
-            <a:ext cx="6903720" cy="5358384"/>
-          </a:xfrm>
-          <a:prstGeom prst="roundRect">
-            <a:avLst>
-              <a:gd name="adj" fmla="val 3000"/>
-            </a:avLst>
-          </a:prstGeom>
-          <a:solidFill>
-            <a:srgbClr val="FFFFFF"/>
-          </a:solidFill>
-          <a:ln w="12700">
-            <a:solidFill>
-              <a:srgbClr val="4F46E5"/>
-            </a:solidFill>
-          </a:ln>
-          <a:effectLst/>
-        </p:spPr>
-        <p:style>
-          <a:lnRef idx="1">
-            <a:schemeClr val="accent1"/>
-          </a:lnRef>
-          <a:fillRef idx="3">
-            <a:schemeClr val="accent1"/>
-          </a:fillRef>
-          <a:effectRef idx="2">
-            <a:schemeClr val="accent1"/>
-          </a:effectRef>
-          <a:fontRef idx="minor">
-            <a:schemeClr val="lt1"/>
-          </a:fontRef>
-        </p:style>
-        <p:txBody>
-          <a:bodyPr rtlCol="0" anchor="ctr"/>
-          <a:lstStyle/>
-          <a:p>
-            <a:pPr algn="ctr"/>
-          </a:p>
-        </p:txBody>
-      </p:sp>
-      <p:sp>
-        <p:nvSpPr>
-          <p:cNvPr id="8" name="TextBox 7"/>
+            <a:pPr algn="l">
+              <a:spcBef>
+                <a:spcPts val="0"/>
+              </a:spcBef>
+              <a:spcAft>
+                <a:spcPts val="300"/>
+              </a:spcAft>
+            </a:pPr>
+            <a:r>
+              <a:rPr sz="1050" b="1">
+                <a:solidFill>
+                  <a:srgbClr val="0D9488"/>
+                </a:solidFill>
+                <a:latin typeface="Microsoft YaHei"/>
+                <a:ea typeface="Microsoft YaHei"/>
+                <a:cs typeface="Microsoft YaHei"/>
+              </a:rPr>
+              <a:t>② 业务仓 .opencode/  ·  执行面（本地叠加 + 在途沉淀）</a:t>
+            </a:r>
+          </a:p>
+        </p:txBody>
+      </p:sp>
+      <p:sp>
+        <p:nvSpPr>
+          <p:cNvPr id="9" name="TextBox 8"/>
           <p:cNvSpPr txBox="1"/>
           <p:nvPr/>
         </p:nvSpPr>
         <p:spPr>
           <a:xfrm>
-            <a:off x="566928" y="1078992"/>
-            <a:ext cx="6675120" cy="274320"/>
+            <a:off x="7589519" y="822960"/>
+            <a:ext cx="4480560" cy="1737360"/>
+          </a:xfrm>
+          <a:prstGeom prst="rect">
+            <a:avLst/>
+          </a:prstGeom>
+          <a:noFill/>
+        </p:spPr>
+        <p:txBody>
+          <a:bodyPr wrap="none" anchor="t" lIns="128016" rIns="54864" tIns="91440">
+            <a:spAutoFit/>
+          </a:bodyPr>
+          <a:lstStyle/>
+          <a:p>
+            <a:pPr algn="l">
+              <a:spcBef>
+                <a:spcPts val="0"/>
+              </a:spcBef>
+              <a:spcAft>
+                <a:spcPts val="110"/>
+              </a:spcAft>
+            </a:pPr>
+            <a:r>
+              <a:rPr sz="800" b="0">
+                <a:solidFill>
+                  <a:srgbClr val="1F2937"/>
+                </a:solidFill>
+                <a:latin typeface="Consolas"/>
+                <a:ea typeface="Consolas"/>
+                <a:cs typeface="Consolas"/>
+              </a:rPr>
+              <a:t>.opencode/                  </a:t>
+            </a:r>
+            <a:r>
+              <a:rPr sz="760" b="0">
+                <a:solidFill>
+                  <a:srgbClr val="6B7280"/>
+                </a:solidFill>
+                <a:latin typeface="Microsoft YaHei"/>
+                <a:ea typeface="Microsoft YaHei"/>
+                <a:cs typeface="Microsoft YaHei"/>
+              </a:rPr>
+              <a:t># 在业务仓 hm-kernel-llm-opt 内</a:t>
+            </a:r>
+          </a:p>
+          <a:p>
+            <a:pPr algn="l">
+              <a:spcBef>
+                <a:spcPts val="0"/>
+              </a:spcBef>
+              <a:spcAft>
+                <a:spcPts val="110"/>
+              </a:spcAft>
+            </a:pPr>
+            <a:r>
+              <a:rPr sz="800" b="0">
+                <a:solidFill>
+                  <a:srgbClr val="1F2937"/>
+                </a:solidFill>
+                <a:latin typeface="Consolas"/>
+                <a:ea typeface="Consolas"/>
+                <a:cs typeface="Consolas"/>
+              </a:rPr>
+              <a:t>├─ hub/                     </a:t>
+            </a:r>
+            <a:r>
+              <a:rPr sz="760" b="0">
+                <a:solidFill>
+                  <a:srgbClr val="6B7280"/>
+                </a:solidFill>
+                <a:latin typeface="Microsoft YaHei"/>
+                <a:ea typeface="Microsoft YaHei"/>
+                <a:cs typeface="Microsoft YaHei"/>
+              </a:rPr>
+              <a:t># submodule · 锁定 hub 版本(只读)</a:t>
+            </a:r>
+          </a:p>
+          <a:p>
+            <a:pPr algn="l">
+              <a:spcBef>
+                <a:spcPts val="0"/>
+              </a:spcBef>
+              <a:spcAft>
+                <a:spcPts val="110"/>
+              </a:spcAft>
+            </a:pPr>
+            <a:r>
+              <a:rPr sz="800" b="0">
+                <a:solidFill>
+                  <a:srgbClr val="1F2937"/>
+                </a:solidFill>
+                <a:latin typeface="Consolas"/>
+                <a:ea typeface="Consolas"/>
+                <a:cs typeface="Consolas"/>
+              </a:rPr>
+              <a:t>├─ local/                   </a:t>
+            </a:r>
+            <a:r>
+              <a:rPr sz="760" b="0">
+                <a:solidFill>
+                  <a:srgbClr val="6B7280"/>
+                </a:solidFill>
+                <a:latin typeface="Microsoft YaHei"/>
+                <a:ea typeface="Microsoft YaHei"/>
+                <a:cs typeface="Microsoft YaHei"/>
+              </a:rPr>
+              <a:t># 本成员执行面产物</a:t>
+            </a:r>
+          </a:p>
+          <a:p>
+            <a:pPr algn="l">
+              <a:spcBef>
+                <a:spcPts val="0"/>
+              </a:spcBef>
+              <a:spcAft>
+                <a:spcPts val="110"/>
+              </a:spcAft>
+            </a:pPr>
+            <a:r>
+              <a:rPr sz="800" b="0">
+                <a:solidFill>
+                  <a:srgbClr val="1F2937"/>
+                </a:solidFill>
+                <a:latin typeface="Consolas"/>
+                <a:ea typeface="Consolas"/>
+                <a:cs typeface="Consolas"/>
+              </a:rPr>
+              <a:t>│  ├─ runs/&lt;run_id&gt;/        </a:t>
+            </a:r>
+            <a:r>
+              <a:rPr sz="760" b="0">
+                <a:solidFill>
+                  <a:srgbClr val="6B7280"/>
+                </a:solidFill>
+                <a:latin typeface="Microsoft YaHei"/>
+                <a:ea typeface="Microsoft YaHei"/>
+                <a:cs typeface="Microsoft YaHei"/>
+              </a:rPr>
+              <a:t># plans·reviews·bench·patches</a:t>
+            </a:r>
+          </a:p>
+          <a:p>
+            <a:pPr algn="l">
+              <a:spcBef>
+                <a:spcPts val="0"/>
+              </a:spcBef>
+              <a:spcAft>
+                <a:spcPts val="110"/>
+              </a:spcAft>
+            </a:pPr>
+            <a:r>
+              <a:rPr sz="800" b="0">
+                <a:solidFill>
+                  <a:srgbClr val="1F2937"/>
+                </a:solidFill>
+                <a:latin typeface="Consolas"/>
+                <a:ea typeface="Consolas"/>
+                <a:cs typeface="Consolas"/>
+              </a:rPr>
+              <a:t>│  │   └─ &lt;target&gt;_design.md</a:t>
+            </a:r>
+            <a:r>
+              <a:rPr sz="760" b="0">
+                <a:solidFill>
+                  <a:srgbClr val="6B7280"/>
+                </a:solidFill>
+                <a:latin typeface="Microsoft YaHei"/>
+                <a:ea typeface="Microsoft YaHei"/>
+                <a:cs typeface="Microsoft YaHei"/>
+              </a:rPr>
+              <a:t># 每次运行设计(建议留存)</a:t>
+            </a:r>
+          </a:p>
+          <a:p>
+            <a:pPr algn="l">
+              <a:spcBef>
+                <a:spcPts val="0"/>
+              </a:spcBef>
+              <a:spcAft>
+                <a:spcPts val="110"/>
+              </a:spcAft>
+            </a:pPr>
+            <a:r>
+              <a:rPr sz="800" b="0">
+                <a:solidFill>
+                  <a:srgbClr val="1F2937"/>
+                </a:solidFill>
+                <a:latin typeface="Consolas"/>
+                <a:ea typeface="Consolas"/>
+                <a:cs typeface="Consolas"/>
+              </a:rPr>
+              <a:t>│  ├─ memory/               </a:t>
+            </a:r>
+            <a:r>
+              <a:rPr sz="760" b="0">
+                <a:solidFill>
+                  <a:srgbClr val="6B7280"/>
+                </a:solidFill>
+                <a:latin typeface="Microsoft YaHei"/>
+                <a:ea typeface="Microsoft YaHei"/>
+                <a:cs typeface="Microsoft YaHei"/>
+              </a:rPr>
+              <a:t># 在途工作记忆(Tier1)</a:t>
+            </a:r>
+          </a:p>
+          <a:p>
+            <a:pPr algn="l">
+              <a:spcBef>
+                <a:spcPts val="0"/>
+              </a:spcBef>
+              <a:spcAft>
+                <a:spcPts val="110"/>
+              </a:spcAft>
+            </a:pPr>
+            <a:r>
+              <a:rPr sz="800" b="0">
+                <a:solidFill>
+                  <a:srgbClr val="1F2937"/>
+                </a:solidFill>
+                <a:latin typeface="Consolas"/>
+                <a:ea typeface="Consolas"/>
+                <a:cs typeface="Consolas"/>
+              </a:rPr>
+              <a:t>│  └─ sediment_staging/     </a:t>
+            </a:r>
+            <a:r>
+              <a:rPr sz="760" b="0">
+                <a:solidFill>
+                  <a:srgbClr val="6B7280"/>
+                </a:solidFill>
+                <a:latin typeface="Microsoft YaHei"/>
+                <a:ea typeface="Microsoft YaHei"/>
+                <a:cs typeface="Microsoft YaHei"/>
+              </a:rPr>
+              <a:t># 蒸馏候选 → PR 到 hub</a:t>
+            </a:r>
+          </a:p>
+          <a:p>
+            <a:pPr algn="l">
+              <a:spcBef>
+                <a:spcPts val="0"/>
+              </a:spcBef>
+              <a:spcAft>
+                <a:spcPts val="110"/>
+              </a:spcAft>
+            </a:pPr>
+            <a:r>
+              <a:rPr sz="800" b="0">
+                <a:solidFill>
+                  <a:srgbClr val="1F2937"/>
+                </a:solidFill>
+                <a:latin typeface="Consolas"/>
+                <a:ea typeface="Consolas"/>
+                <a:cs typeface="Consolas"/>
+              </a:rPr>
+              <a:t>├─ state/current_task.json  </a:t>
+            </a:r>
+            <a:r>
+              <a:rPr sz="760" b="0">
+                <a:solidFill>
+                  <a:srgbClr val="6B7280"/>
+                </a:solidFill>
+                <a:latin typeface="Microsoft YaHei"/>
+                <a:ea typeface="Microsoft YaHei"/>
+                <a:cs typeface="Microsoft YaHei"/>
+              </a:rPr>
+              <a:t># 纯运行态(gitignore)</a:t>
+            </a:r>
+          </a:p>
+          <a:p>
+            <a:pPr algn="l">
+              <a:spcBef>
+                <a:spcPts val="0"/>
+              </a:spcBef>
+              <a:spcAft>
+                <a:spcPts val="110"/>
+              </a:spcAft>
+            </a:pPr>
+            <a:r>
+              <a:rPr sz="800" b="0">
+                <a:solidFill>
+                  <a:srgbClr val="1F2937"/>
+                </a:solidFill>
+                <a:latin typeface="Consolas"/>
+                <a:ea typeface="Consolas"/>
+                <a:cs typeface="Consolas"/>
+              </a:rPr>
+              <a:t>├─ skill-memory.lock        </a:t>
+            </a:r>
+            <a:r>
+              <a:rPr sz="760" b="0">
+                <a:solidFill>
+                  <a:srgbClr val="6B7280"/>
+                </a:solidFill>
+                <a:latin typeface="Microsoft YaHei"/>
+                <a:ea typeface="Microsoft YaHei"/>
+                <a:cs typeface="Microsoft YaHei"/>
+              </a:rPr>
+              <a:t># 锁定 hub 版本(semver+SHA)</a:t>
+            </a:r>
+          </a:p>
+          <a:p>
+            <a:pPr algn="l">
+              <a:spcBef>
+                <a:spcPts val="0"/>
+              </a:spcBef>
+              <a:spcAft>
+                <a:spcPts val="110"/>
+              </a:spcAft>
+            </a:pPr>
+            <a:r>
+              <a:rPr sz="800" b="0">
+                <a:solidFill>
+                  <a:srgbClr val="1F2937"/>
+                </a:solidFill>
+                <a:latin typeface="Consolas"/>
+                <a:ea typeface="Consolas"/>
+                <a:cs typeface="Consolas"/>
+              </a:rPr>
+              <a:t>└─ resolver.py              </a:t>
+            </a:r>
+            <a:r>
+              <a:rPr sz="760" b="0">
+                <a:solidFill>
+                  <a:srgbClr val="6B7280"/>
+                </a:solidFill>
+                <a:latin typeface="Microsoft YaHei"/>
+                <a:ea typeface="Microsoft YaHei"/>
+                <a:cs typeface="Microsoft YaHei"/>
+              </a:rPr>
+              <a:t># 先 hub 共享, 再叠加 local</a:t>
+            </a:r>
+          </a:p>
+        </p:txBody>
+      </p:sp>
+      <p:sp>
+        <p:nvSpPr>
+          <p:cNvPr id="10" name="TextBox 9"/>
+          <p:cNvSpPr txBox="1"/>
+          <p:nvPr/>
+        </p:nvSpPr>
+        <p:spPr>
+          <a:xfrm>
+            <a:off x="7635240" y="2542032"/>
+            <a:ext cx="4389120" cy="219456"/>
           </a:xfrm>
           <a:prstGeom prst="rect">
             <a:avLst/>
@@ -9348,1196 +11181,16 @@
               </a:spcAft>
             </a:pPr>
             <a:r>
-              <a:rPr sz="1100" b="1">
-                <a:solidFill>
-                  <a:srgbClr val="4F46E5"/>
-                </a:solidFill>
-                <a:latin typeface="Microsoft YaHei"/>
-                <a:ea typeface="Microsoft YaHei"/>
-                <a:cs typeface="Microsoft YaHei"/>
-              </a:rPr>
-              <a:t>① 中央资产仓 hm-skill-hub/ — 团队共享 · 版本化（举例展开）</a:t>
-            </a:r>
-          </a:p>
-        </p:txBody>
-      </p:sp>
-      <p:sp>
-        <p:nvSpPr>
-          <p:cNvPr id="9" name="TextBox 8"/>
-          <p:cNvSpPr txBox="1"/>
-          <p:nvPr/>
-        </p:nvSpPr>
-        <p:spPr>
-          <a:xfrm>
-            <a:off x="457200" y="1371600"/>
-            <a:ext cx="6858000" cy="4992624"/>
-          </a:xfrm>
-          <a:prstGeom prst="rect">
-            <a:avLst/>
-          </a:prstGeom>
-          <a:noFill/>
-        </p:spPr>
-        <p:txBody>
-          <a:bodyPr wrap="none" anchor="t" lIns="128016" rIns="54864" tIns="91440">
-            <a:spAutoFit/>
-          </a:bodyPr>
-          <a:lstStyle/>
-          <a:p>
-            <a:pPr algn="l">
-              <a:spcBef>
-                <a:spcPts val="0"/>
-              </a:spcBef>
-              <a:spcAft>
-                <a:spcPts val="95"/>
-              </a:spcAft>
-            </a:pPr>
-            <a:r>
-              <a:rPr sz="800" b="0">
-                <a:solidFill>
-                  <a:srgbClr val="1F2937"/>
-                </a:solidFill>
-                <a:latin typeface="Consolas"/>
-                <a:ea typeface="Consolas"/>
-                <a:cs typeface="Consolas"/>
-              </a:rPr>
-              <a:t>hm-skill-hub/                           </a:t>
-            </a:r>
-            <a:r>
-              <a:rPr sz="760" b="0">
-                <a:solidFill>
-                  <a:srgbClr val="6B7280"/>
-                </a:solidFill>
-                <a:latin typeface="Microsoft YaHei"/>
-                <a:ea typeface="Microsoft YaHei"/>
-                <a:cs typeface="Microsoft YaHei"/>
-              </a:rPr>
-              <a:t># 团队共享 · 版本化(semver)</a:t>
-            </a:r>
-          </a:p>
-          <a:p>
-            <a:pPr algn="l">
-              <a:spcBef>
-                <a:spcPts val="0"/>
-              </a:spcBef>
-              <a:spcAft>
-                <a:spcPts val="95"/>
-              </a:spcAft>
-            </a:pPr>
-            <a:r>
-              <a:rPr sz="800" b="0">
-                <a:solidFill>
-                  <a:srgbClr val="1F2937"/>
-                </a:solidFill>
-                <a:latin typeface="Consolas"/>
-                <a:ea typeface="Consolas"/>
-                <a:cs typeface="Consolas"/>
-              </a:rPr>
-              <a:t>├─ registry.yaml                        </a:t>
-            </a:r>
-            <a:r>
-              <a:rPr sz="760" b="0">
-                <a:solidFill>
-                  <a:srgbClr val="6B7280"/>
-                </a:solidFill>
-                <a:latin typeface="Microsoft YaHei"/>
-                <a:ea typeface="Microsoft YaHei"/>
-                <a:cs typeface="Microsoft YaHei"/>
-              </a:rPr>
-              <a:t># 总清单:技能/版本/评测/负责人</a:t>
-            </a:r>
-          </a:p>
-          <a:p>
-            <a:pPr algn="l">
-              <a:spcBef>
-                <a:spcPts val="0"/>
-              </a:spcBef>
-              <a:spcAft>
-                <a:spcPts val="95"/>
-              </a:spcAft>
-            </a:pPr>
-            <a:r>
-              <a:rPr sz="800" b="0">
-                <a:solidFill>
-                  <a:srgbClr val="1F2937"/>
-                </a:solidFill>
-                <a:latin typeface="Consolas"/>
-                <a:ea typeface="Consolas"/>
-                <a:cs typeface="Consolas"/>
-              </a:rPr>
-              <a:t>├─ schemas/                             </a:t>
-            </a:r>
-            <a:r>
-              <a:rPr sz="760" b="0">
-                <a:solidFill>
-                  <a:srgbClr val="6B7280"/>
-                </a:solidFill>
-                <a:latin typeface="Microsoft YaHei"/>
-                <a:ea typeface="Microsoft YaHei"/>
-                <a:cs typeface="Microsoft YaHei"/>
-              </a:rPr>
-              <a:t># 各类记录的格式约束(校验用)</a:t>
-            </a:r>
-          </a:p>
-          <a:p>
-            <a:pPr algn="l">
-              <a:spcBef>
-                <a:spcPts val="0"/>
-              </a:spcBef>
-              <a:spcAft>
-                <a:spcPts val="95"/>
-              </a:spcAft>
-            </a:pPr>
-            <a:r>
-              <a:rPr sz="800" b="0">
-                <a:solidFill>
-                  <a:srgbClr val="1F2937"/>
-                </a:solidFill>
-                <a:latin typeface="Consolas"/>
-                <a:ea typeface="Consolas"/>
-                <a:cs typeface="Consolas"/>
-              </a:rPr>
-              <a:t>├─ skills/                              </a:t>
-            </a:r>
-            <a:r>
-              <a:rPr sz="760" b="0">
-                <a:solidFill>
-                  <a:srgbClr val="6B7280"/>
-                </a:solidFill>
-                <a:latin typeface="Microsoft YaHei"/>
-                <a:ea typeface="Microsoft YaHei"/>
-                <a:cs typeface="Microsoft YaHei"/>
-              </a:rPr>
-              <a:t># 技能(引擎B·过 eval-gate 优化) · 三层见上页</a:t>
-            </a:r>
-          </a:p>
-          <a:p>
-            <a:pPr algn="l">
-              <a:spcBef>
-                <a:spcPts val="0"/>
-              </a:spcBef>
-              <a:spcAft>
-                <a:spcPts val="95"/>
-              </a:spcAft>
-            </a:pPr>
-            <a:r>
-              <a:rPr sz="800" b="0">
-                <a:solidFill>
-                  <a:srgbClr val="1F2937"/>
-                </a:solidFill>
-                <a:latin typeface="Consolas"/>
-                <a:ea typeface="Consolas"/>
-                <a:cs typeface="Consolas"/>
-              </a:rPr>
-              <a:t>│  ├─ core/                             </a:t>
-            </a:r>
-            <a:r>
-              <a:rPr sz="760" b="0">
-                <a:solidFill>
-                  <a:srgbClr val="6B7280"/>
-                </a:solidFill>
-                <a:latin typeface="Microsoft YaHei"/>
-                <a:ea typeface="Microsoft YaHei"/>
-                <a:cs typeface="Microsoft YaHei"/>
-              </a:rPr>
-              <a:t># 流程·跨切面(全子系统通用)</a:t>
-            </a:r>
-          </a:p>
-          <a:p>
-            <a:pPr algn="l">
-              <a:spcBef>
-                <a:spcPts val="0"/>
-              </a:spcBef>
-              <a:spcAft>
-                <a:spcPts val="95"/>
-              </a:spcAft>
-            </a:pPr>
-            <a:r>
-              <a:rPr sz="800" b="0">
-                <a:solidFill>
-                  <a:srgbClr val="1F2937"/>
-                </a:solidFill>
-                <a:latin typeface="Consolas"/>
-                <a:ea typeface="Consolas"/>
-                <a:cs typeface="Consolas"/>
-              </a:rPr>
-              <a:t>│  │  ├─ optimization-funnel/           </a:t>
-            </a:r>
-            <a:r>
-              <a:rPr sz="760" b="0">
-                <a:solidFill>
-                  <a:srgbClr val="6B7280"/>
-                </a:solidFill>
-                <a:latin typeface="Microsoft YaHei"/>
-                <a:ea typeface="Microsoft YaHei"/>
-                <a:cs typeface="Microsoft YaHei"/>
-              </a:rPr>
-              <a:t># 例:优化漏斗主流程 — 文件夹内容如下</a:t>
-            </a:r>
-          </a:p>
-          <a:p>
-            <a:pPr algn="l">
-              <a:spcBef>
-                <a:spcPts val="0"/>
-              </a:spcBef>
-              <a:spcAft>
-                <a:spcPts val="95"/>
-              </a:spcAft>
-            </a:pPr>
-            <a:r>
-              <a:rPr sz="800" b="0">
-                <a:solidFill>
-                  <a:srgbClr val="1F2937"/>
-                </a:solidFill>
-                <a:latin typeface="Consolas"/>
-                <a:ea typeface="Consolas"/>
-                <a:cs typeface="Consolas"/>
-              </a:rPr>
-              <a:t>│  │  │   ├─ SKILL.md                   </a:t>
-            </a:r>
-            <a:r>
-              <a:rPr sz="760" b="0">
-                <a:solidFill>
-                  <a:srgbClr val="6B7280"/>
-                </a:solidFill>
-                <a:latin typeface="Microsoft YaHei"/>
-                <a:ea typeface="Microsoft YaHei"/>
-                <a:cs typeface="Microsoft YaHei"/>
-              </a:rPr>
-              <a:t># 选中即读:何时用 + 怎么用</a:t>
-            </a:r>
-          </a:p>
-          <a:p>
-            <a:pPr algn="l">
-              <a:spcBef>
-                <a:spcPts val="0"/>
-              </a:spcBef>
-              <a:spcAft>
-                <a:spcPts val="95"/>
-              </a:spcAft>
-            </a:pPr>
-            <a:r>
-              <a:rPr sz="800" b="0">
-                <a:solidFill>
-                  <a:srgbClr val="1F2937"/>
-                </a:solidFill>
-                <a:latin typeface="Consolas"/>
-                <a:ea typeface="Consolas"/>
-                <a:cs typeface="Consolas"/>
-              </a:rPr>
-              <a:t>│  │  │   ├─ best_skill.md              </a:t>
-            </a:r>
-            <a:r>
-              <a:rPr sz="760" b="0">
-                <a:solidFill>
-                  <a:srgbClr val="6B7280"/>
-                </a:solidFill>
-                <a:latin typeface="Microsoft YaHei"/>
-                <a:ea typeface="Microsoft YaHei"/>
-                <a:cs typeface="Microsoft YaHei"/>
-              </a:rPr>
-              <a:t># SkillOpt 优化出的“正本”</a:t>
-            </a:r>
-          </a:p>
-          <a:p>
-            <a:pPr algn="l">
-              <a:spcBef>
-                <a:spcPts val="0"/>
-              </a:spcBef>
-              <a:spcAft>
-                <a:spcPts val="95"/>
-              </a:spcAft>
-            </a:pPr>
-            <a:r>
-              <a:rPr sz="800" b="0">
-                <a:solidFill>
-                  <a:srgbClr val="1F2937"/>
-                </a:solidFill>
-                <a:latin typeface="Consolas"/>
-                <a:ea typeface="Consolas"/>
-                <a:cs typeface="Consolas"/>
-              </a:rPr>
-              <a:t>│  │  │   ├─ evals/                     </a:t>
-            </a:r>
-            <a:r>
-              <a:rPr sz="760" b="0">
-                <a:solidFill>
-                  <a:srgbClr val="6B7280"/>
-                </a:solidFill>
-                <a:latin typeface="Microsoft YaHei"/>
-                <a:ea typeface="Microsoft YaHei"/>
-                <a:cs typeface="Microsoft YaHei"/>
-              </a:rPr>
-              <a:t># 技能内·私有评测:用哪套题 + 留出用例</a:t>
-            </a:r>
-          </a:p>
-          <a:p>
-            <a:pPr algn="l">
-              <a:spcBef>
-                <a:spcPts val="0"/>
-              </a:spcBef>
-              <a:spcAft>
-                <a:spcPts val="95"/>
-              </a:spcAft>
-            </a:pPr>
-            <a:r>
-              <a:rPr sz="800" b="0">
-                <a:solidFill>
-                  <a:srgbClr val="1F2937"/>
-                </a:solidFill>
-                <a:latin typeface="Consolas"/>
-                <a:ea typeface="Consolas"/>
-                <a:cs typeface="Consolas"/>
-              </a:rPr>
-              <a:t>│  │  │   ├─ candidates/                </a:t>
-            </a:r>
-            <a:r>
-              <a:rPr sz="760" b="0">
-                <a:solidFill>
-                  <a:srgbClr val="6B7280"/>
-                </a:solidFill>
-                <a:latin typeface="Microsoft YaHei"/>
-                <a:ea typeface="Microsoft YaHei"/>
-                <a:cs typeface="Microsoft YaHei"/>
-              </a:rPr>
-              <a:t># Pareto 前沿:互补候选</a:t>
-            </a:r>
-          </a:p>
-          <a:p>
-            <a:pPr algn="l">
-              <a:spcBef>
-                <a:spcPts val="0"/>
-              </a:spcBef>
-              <a:spcAft>
-                <a:spcPts val="95"/>
-              </a:spcAft>
-            </a:pPr>
-            <a:r>
-              <a:rPr sz="800" b="0">
-                <a:solidFill>
-                  <a:srgbClr val="1F2937"/>
-                </a:solidFill>
-                <a:latin typeface="Consolas"/>
-                <a:ea typeface="Consolas"/>
-                <a:cs typeface="Consolas"/>
-              </a:rPr>
-              <a:t>│  │  │   ├─ scorecards/                </a:t>
-            </a:r>
-            <a:r>
-              <a:rPr sz="760" b="0">
-                <a:solidFill>
-                  <a:srgbClr val="6B7280"/>
-                </a:solidFill>
-                <a:latin typeface="Microsoft YaHei"/>
-                <a:ea typeface="Microsoft YaHei"/>
-                <a:cs typeface="Microsoft YaHei"/>
-              </a:rPr>
-              <a:t># 本技能历次 A/B 跑分</a:t>
-            </a:r>
-          </a:p>
-          <a:p>
-            <a:pPr algn="l">
-              <a:spcBef>
-                <a:spcPts val="0"/>
-              </a:spcBef>
-              <a:spcAft>
-                <a:spcPts val="95"/>
-              </a:spcAft>
-            </a:pPr>
-            <a:r>
-              <a:rPr sz="800" b="0">
-                <a:solidFill>
-                  <a:srgbClr val="1F2937"/>
-                </a:solidFill>
-                <a:latin typeface="Consolas"/>
-                <a:ea typeface="Consolas"/>
-                <a:cs typeface="Consolas"/>
-              </a:rPr>
-              <a:t>│  │  │   └─ references/                </a:t>
-            </a:r>
-            <a:r>
-              <a:rPr sz="760" b="0">
-                <a:solidFill>
-                  <a:srgbClr val="6B7280"/>
-                </a:solidFill>
-                <a:latin typeface="Microsoft YaHei"/>
-                <a:ea typeface="Microsoft YaHei"/>
-                <a:cs typeface="Microsoft YaHei"/>
-              </a:rPr>
-              <a:t># 重材料(按需加载)</a:t>
-            </a:r>
-          </a:p>
-          <a:p>
-            <a:pPr algn="l">
-              <a:spcBef>
-                <a:spcPts val="0"/>
-              </a:spcBef>
-              <a:spcAft>
-                <a:spcPts val="95"/>
-              </a:spcAft>
-            </a:pPr>
-            <a:r>
-              <a:rPr sz="800" b="0">
-                <a:solidFill>
-                  <a:srgbClr val="1F2937"/>
-                </a:solidFill>
-                <a:latin typeface="Consolas"/>
-                <a:ea typeface="Consolas"/>
-                <a:cs typeface="Consolas"/>
-              </a:rPr>
-              <a:t>│  │  └─ stage-gate-enforcement/        </a:t>
-            </a:r>
-            <a:r>
-              <a:rPr sz="760" b="0">
-                <a:solidFill>
-                  <a:srgbClr val="6B7280"/>
-                </a:solidFill>
-                <a:latin typeface="Microsoft YaHei"/>
-                <a:ea typeface="Microsoft YaHei"/>
-                <a:cs typeface="Microsoft YaHei"/>
-              </a:rPr>
-              <a:t># 例:阶段门禁强制</a:t>
-            </a:r>
-          </a:p>
-          <a:p>
-            <a:pPr algn="l">
-              <a:spcBef>
-                <a:spcPts val="0"/>
-              </a:spcBef>
-              <a:spcAft>
-                <a:spcPts val="95"/>
-              </a:spcAft>
-            </a:pPr>
-            <a:r>
-              <a:rPr sz="800" b="0">
-                <a:solidFill>
-                  <a:srgbClr val="1F2937"/>
-                </a:solidFill>
-                <a:latin typeface="Consolas"/>
-                <a:ea typeface="Consolas"/>
-                <a:cs typeface="Consolas"/>
-              </a:rPr>
-              <a:t>│  ├─ technique/                        </a:t>
-            </a:r>
-            <a:r>
-              <a:rPr sz="760" b="0">
-                <a:solidFill>
-                  <a:srgbClr val="6B7280"/>
-                </a:solidFill>
-                <a:latin typeface="Microsoft YaHei"/>
-                <a:ea typeface="Microsoft YaHei"/>
-                <a:cs typeface="Microsoft YaHei"/>
-              </a:rPr>
-              <a:t># 优化招式 · 按 mechanism 命名</a:t>
-            </a:r>
-          </a:p>
-          <a:p>
-            <a:pPr algn="l">
-              <a:spcBef>
-                <a:spcPts val="0"/>
-              </a:spcBef>
-              <a:spcAft>
-                <a:spcPts val="95"/>
-              </a:spcAft>
-            </a:pPr>
-            <a:r>
-              <a:rPr sz="800" b="0">
-                <a:solidFill>
-                  <a:srgbClr val="1F2937"/>
-                </a:solidFill>
-                <a:latin typeface="Consolas"/>
-                <a:ea typeface="Consolas"/>
-                <a:cs typeface="Consolas"/>
-              </a:rPr>
-              <a:t>│  │  ├─ hoist-loop-invariant/          </a:t>
-            </a:r>
-            <a:r>
-              <a:rPr sz="760" b="0">
-                <a:solidFill>
-                  <a:srgbClr val="6B7280"/>
-                </a:solidFill>
-                <a:latin typeface="Microsoft YaHei"/>
-                <a:ea typeface="Microsoft YaHei"/>
-                <a:cs typeface="Microsoft YaHei"/>
-              </a:rPr>
-              <a:t># 例:循环不变量外提</a:t>
-            </a:r>
-          </a:p>
-          <a:p>
-            <a:pPr algn="l">
-              <a:spcBef>
-                <a:spcPts val="0"/>
-              </a:spcBef>
-              <a:spcAft>
-                <a:spcPts val="95"/>
-              </a:spcAft>
-            </a:pPr>
-            <a:r>
-              <a:rPr sz="800" b="0">
-                <a:solidFill>
-                  <a:srgbClr val="1F2937"/>
-                </a:solidFill>
-                <a:latin typeface="Consolas"/>
-                <a:ea typeface="Consolas"/>
-                <a:cs typeface="Consolas"/>
-              </a:rPr>
-              <a:t>│  │  └─ batch-coalescing/              </a:t>
-            </a:r>
-            <a:r>
-              <a:rPr sz="760" b="0">
-                <a:solidFill>
-                  <a:srgbClr val="6B7280"/>
-                </a:solidFill>
-                <a:latin typeface="Microsoft YaHei"/>
-                <a:ea typeface="Microsoft YaHei"/>
-                <a:cs typeface="Microsoft YaHei"/>
-              </a:rPr>
-              <a:t># 例:批量合并写</a:t>
-            </a:r>
-          </a:p>
-          <a:p>
-            <a:pPr algn="l">
-              <a:spcBef>
-                <a:spcPts val="0"/>
-              </a:spcBef>
-              <a:spcAft>
-                <a:spcPts val="95"/>
-              </a:spcAft>
-            </a:pPr>
-            <a:r>
-              <a:rPr sz="800" b="0">
-                <a:solidFill>
-                  <a:srgbClr val="1F2937"/>
-                </a:solidFill>
-                <a:latin typeface="Consolas"/>
-                <a:ea typeface="Consolas"/>
-                <a:cs typeface="Consolas"/>
-              </a:rPr>
-              <a:t>│  ├─ domain/                           </a:t>
-            </a:r>
-            <a:r>
-              <a:rPr sz="760" b="0">
-                <a:solidFill>
-                  <a:srgbClr val="6B7280"/>
-                </a:solidFill>
-                <a:latin typeface="Microsoft YaHei"/>
-                <a:ea typeface="Microsoft YaHei"/>
-                <a:cs typeface="Microsoft YaHei"/>
-              </a:rPr>
-              <a:t># 按子系统(唯一触及代码结构)</a:t>
-            </a:r>
-          </a:p>
-          <a:p>
-            <a:pPr algn="l">
-              <a:spcBef>
-                <a:spcPts val="0"/>
-              </a:spcBef>
-              <a:spcAft>
-                <a:spcPts val="95"/>
-              </a:spcAft>
-            </a:pPr>
-            <a:r>
-              <a:rPr sz="800" b="0">
-                <a:solidFill>
-                  <a:srgbClr val="1F2937"/>
-                </a:solidFill>
-                <a:latin typeface="Consolas"/>
-                <a:ea typeface="Consolas"/>
-                <a:cs typeface="Consolas"/>
-              </a:rPr>
-              <a:t>│  │  ├─ mm-reclaim/                    </a:t>
-            </a:r>
-            <a:r>
-              <a:rPr sz="760" b="0">
-                <a:solidFill>
-                  <a:srgbClr val="6B7280"/>
-                </a:solidFill>
-                <a:latin typeface="Microsoft YaHei"/>
-                <a:ea typeface="Microsoft YaHei"/>
-                <a:cs typeface="Microsoft YaHei"/>
-              </a:rPr>
-              <a:t># 例:内存回收(含 references/)</a:t>
-            </a:r>
-          </a:p>
-          <a:p>
-            <a:pPr algn="l">
-              <a:spcBef>
-                <a:spcPts val="0"/>
-              </a:spcBef>
-              <a:spcAft>
-                <a:spcPts val="95"/>
-              </a:spcAft>
-            </a:pPr>
-            <a:r>
-              <a:rPr sz="800" b="0">
-                <a:solidFill>
-                  <a:srgbClr val="1F2937"/>
-                </a:solidFill>
-                <a:latin typeface="Consolas"/>
-                <a:ea typeface="Consolas"/>
-                <a:cs typeface="Consolas"/>
-              </a:rPr>
-              <a:t>│  │  └─ hyperhold-io/                  </a:t>
-            </a:r>
-            <a:r>
-              <a:rPr sz="760" b="0">
-                <a:solidFill>
-                  <a:srgbClr val="6B7280"/>
-                </a:solidFill>
-                <a:latin typeface="Microsoft YaHei"/>
-                <a:ea typeface="Microsoft YaHei"/>
-                <a:cs typeface="Microsoft YaHei"/>
-              </a:rPr>
-              <a:t># 例:hyperhold I/O 路径</a:t>
-            </a:r>
-          </a:p>
-          <a:p>
-            <a:pPr algn="l">
-              <a:spcBef>
-                <a:spcPts val="0"/>
-              </a:spcBef>
-              <a:spcAft>
-                <a:spcPts val="95"/>
-              </a:spcAft>
-            </a:pPr>
-            <a:r>
-              <a:rPr sz="800" b="0">
-                <a:solidFill>
-                  <a:srgbClr val="1F2937"/>
-                </a:solidFill>
-                <a:latin typeface="Consolas"/>
-                <a:ea typeface="Consolas"/>
-                <a:cs typeface="Consolas"/>
-              </a:rPr>
-              <a:t>│  └─ _registry/skills.yaml             </a:t>
-            </a:r>
-            <a:r>
-              <a:rPr sz="760" b="0">
-                <a:solidFill>
-                  <a:srgbClr val="6B7280"/>
-                </a:solidFill>
-                <a:latin typeface="Microsoft YaHei"/>
-                <a:ea typeface="Microsoft YaHei"/>
-                <a:cs typeface="Microsoft YaHei"/>
-              </a:rPr>
-              <a:t># 全量索引 + 子系统选择器</a:t>
-            </a:r>
-          </a:p>
-          <a:p>
-            <a:pPr algn="l">
-              <a:spcBef>
-                <a:spcPts val="0"/>
-              </a:spcBef>
-              <a:spcAft>
-                <a:spcPts val="95"/>
-              </a:spcAft>
-            </a:pPr>
-            <a:r>
-              <a:rPr sz="800" b="0">
-                <a:solidFill>
-                  <a:srgbClr val="1F2937"/>
-                </a:solidFill>
-                <a:latin typeface="Consolas"/>
-                <a:ea typeface="Consolas"/>
-                <a:cs typeface="Consolas"/>
-              </a:rPr>
-              <a:t>├─ agents/  ·  commands/                </a:t>
-            </a:r>
-            <a:r>
-              <a:rPr sz="760" b="0">
-                <a:solidFill>
-                  <a:srgbClr val="6B7280"/>
-                </a:solidFill>
-                <a:latin typeface="Microsoft YaHei"/>
-                <a:ea typeface="Microsoft YaHei"/>
-                <a:cs typeface="Microsoft YaHei"/>
-              </a:rPr>
-              <a:t># 角色定义 + slash 命令(评审制·非 eval)</a:t>
-            </a:r>
-          </a:p>
-          <a:p>
-            <a:pPr algn="l">
-              <a:spcBef>
-                <a:spcPts val="0"/>
-              </a:spcBef>
-              <a:spcAft>
-                <a:spcPts val="95"/>
-              </a:spcAft>
-            </a:pPr>
-            <a:r>
-              <a:rPr sz="800" b="0">
-                <a:solidFill>
-                  <a:srgbClr val="1F2937"/>
-                </a:solidFill>
-                <a:latin typeface="Consolas"/>
-                <a:ea typeface="Consolas"/>
-                <a:cs typeface="Consolas"/>
-              </a:rPr>
-              <a:t>├─ pipelines/  ·  docs/                 </a:t>
-            </a:r>
-            <a:r>
-              <a:rPr sz="760" b="0">
-                <a:solidFill>
-                  <a:srgbClr val="6B7280"/>
-                </a:solidFill>
-                <a:latin typeface="Microsoft YaHei"/>
-                <a:ea typeface="Microsoft YaHei"/>
-                <a:cs typeface="Microsoft YaHei"/>
-              </a:rPr>
-              <a:t># 流水线预设 + harness 规范(原 CLAUDE.md)</a:t>
-            </a:r>
-          </a:p>
-          <a:p>
-            <a:pPr algn="l">
-              <a:spcBef>
-                <a:spcPts val="0"/>
-              </a:spcBef>
-              <a:spcAft>
-                <a:spcPts val="95"/>
-              </a:spcAft>
-            </a:pPr>
-            <a:r>
-              <a:rPr sz="800" b="0">
-                <a:solidFill>
-                  <a:srgbClr val="1F2937"/>
-                </a:solidFill>
-                <a:latin typeface="Consolas"/>
-                <a:ea typeface="Consolas"/>
-                <a:cs typeface="Consolas"/>
-              </a:rPr>
-              <a:t>├─ knowledge/                           </a:t>
-            </a:r>
-            <a:r>
-              <a:rPr sz="760" b="0">
-                <a:solidFill>
-                  <a:srgbClr val="6B7280"/>
-                </a:solidFill>
-                <a:latin typeface="Microsoft YaHei"/>
-                <a:ea typeface="Microsoft YaHei"/>
-                <a:cs typeface="Microsoft YaHei"/>
-              </a:rPr>
-              <a:t># 知识(引擎A·分层·每条一文件)</a:t>
-            </a:r>
-          </a:p>
-          <a:p>
-            <a:pPr algn="l">
-              <a:spcBef>
-                <a:spcPts val="0"/>
-              </a:spcBef>
-              <a:spcAft>
-                <a:spcPts val="95"/>
-              </a:spcAft>
-            </a:pPr>
-            <a:r>
-              <a:rPr sz="800" b="0">
-                <a:solidFill>
-                  <a:srgbClr val="1F2937"/>
-                </a:solidFill>
-                <a:latin typeface="Consolas"/>
-                <a:ea typeface="Consolas"/>
-                <a:cs typeface="Consolas"/>
-              </a:rPr>
-              <a:t>│  ├─ global/                           </a:t>
-            </a:r>
-            <a:r>
-              <a:rPr sz="760" b="0">
-                <a:solidFill>
-                  <a:srgbClr val="6B7280"/>
-                </a:solidFill>
-                <a:latin typeface="Microsoft YaHei"/>
-                <a:ea typeface="Microsoft YaHei"/>
-                <a:cs typeface="Microsoft YaHei"/>
-              </a:rPr>
-              <a:t># 全局教训 / 反模式</a:t>
-            </a:r>
-          </a:p>
-          <a:p>
-            <a:pPr algn="l">
-              <a:spcBef>
-                <a:spcPts val="0"/>
-              </a:spcBef>
-              <a:spcAft>
-                <a:spcPts val="95"/>
-              </a:spcAft>
-            </a:pPr>
-            <a:r>
-              <a:rPr sz="800" b="0">
-                <a:solidFill>
-                  <a:srgbClr val="1F2937"/>
-                </a:solidFill>
-                <a:latin typeface="Consolas"/>
-                <a:ea typeface="Consolas"/>
-                <a:cs typeface="Consolas"/>
-              </a:rPr>
-              <a:t>│  │  ├─ lessons/                       </a:t>
-            </a:r>
-            <a:r>
-              <a:rPr sz="760" b="0">
-                <a:solidFill>
-                  <a:srgbClr val="6B7280"/>
-                </a:solidFill>
-                <a:latin typeface="Microsoft YaHei"/>
-                <a:ea typeface="Microsoft YaHei"/>
-                <a:cs typeface="Microsoft YaHei"/>
-              </a:rPr>
-              <a:t># 例:G012_reclaim-twice.md</a:t>
-            </a:r>
-          </a:p>
-          <a:p>
-            <a:pPr algn="l">
-              <a:spcBef>
-                <a:spcPts val="0"/>
-              </a:spcBef>
-              <a:spcAft>
-                <a:spcPts val="95"/>
-              </a:spcAft>
-            </a:pPr>
-            <a:r>
-              <a:rPr sz="800" b="0">
-                <a:solidFill>
-                  <a:srgbClr val="1F2937"/>
-                </a:solidFill>
-                <a:latin typeface="Consolas"/>
-                <a:ea typeface="Consolas"/>
-                <a:cs typeface="Consolas"/>
-              </a:rPr>
-              <a:t>│  │  └─ anti_patterns/                 </a:t>
-            </a:r>
-            <a:r>
-              <a:rPr sz="760" b="0">
-                <a:solidFill>
-                  <a:srgbClr val="6B7280"/>
-                </a:solidFill>
-                <a:latin typeface="Microsoft YaHei"/>
-                <a:ea typeface="Microsoft YaHei"/>
-                <a:cs typeface="Microsoft YaHei"/>
-              </a:rPr>
-              <a:t># 例:A007_busy-wait.md</a:t>
-            </a:r>
-          </a:p>
-          <a:p>
-            <a:pPr algn="l">
-              <a:spcBef>
-                <a:spcPts val="0"/>
-              </a:spcBef>
-              <a:spcAft>
-                <a:spcPts val="95"/>
-              </a:spcAft>
-            </a:pPr>
-            <a:r>
-              <a:rPr sz="800" b="0">
-                <a:solidFill>
-                  <a:srgbClr val="1F2937"/>
-                </a:solidFill>
-                <a:latin typeface="Consolas"/>
-                <a:ea typeface="Consolas"/>
-                <a:cs typeface="Consolas"/>
-              </a:rPr>
-              <a:t>│  ├─ subsystems/&lt;s&gt;.md  ·  targets/&lt;slug&gt;/{facts,decisions,idea_ledger}</a:t>
-            </a:r>
-          </a:p>
-          <a:p>
-            <a:pPr algn="l">
-              <a:spcBef>
-                <a:spcPts val="0"/>
-              </a:spcBef>
-              <a:spcAft>
-                <a:spcPts val="95"/>
-              </a:spcAft>
-            </a:pPr>
-            <a:r>
-              <a:rPr sz="800" b="0">
-                <a:solidFill>
-                  <a:srgbClr val="1F2937"/>
-                </a:solidFill>
-                <a:latin typeface="Consolas"/>
-                <a:ea typeface="Consolas"/>
-                <a:cs typeface="Consolas"/>
-              </a:rPr>
-              <a:t>│  └─ index/                            </a:t>
-            </a:r>
-            <a:r>
-              <a:rPr sz="760" b="0">
-                <a:solidFill>
-                  <a:srgbClr val="6B7280"/>
-                </a:solidFill>
-                <a:latin typeface="Microsoft YaHei"/>
-                <a:ea typeface="Microsoft YaHei"/>
-                <a:cs typeface="Microsoft YaHei"/>
-              </a:rPr>
-              <a:t># 向量检索索引</a:t>
-            </a:r>
-          </a:p>
-          <a:p>
-            <a:pPr algn="l">
-              <a:spcBef>
-                <a:spcPts val="0"/>
-              </a:spcBef>
-              <a:spcAft>
-                <a:spcPts val="95"/>
-              </a:spcAft>
-            </a:pPr>
-            <a:r>
-              <a:rPr sz="800" b="0">
-                <a:solidFill>
-                  <a:srgbClr val="1F2937"/>
-                </a:solidFill>
-                <a:latin typeface="Consolas"/>
-                <a:ea typeface="Consolas"/>
-                <a:cs typeface="Consolas"/>
-              </a:rPr>
-              <a:t>├─ evidence/                            </a:t>
-            </a:r>
-            <a:r>
-              <a:rPr sz="760" b="0">
-                <a:solidFill>
-                  <a:srgbClr val="6B7280"/>
-                </a:solidFill>
-                <a:latin typeface="Microsoft YaHei"/>
-                <a:ea typeface="Microsoft YaHei"/>
-                <a:cs typeface="Microsoft YaHei"/>
-              </a:rPr>
-              <a:t># 可复核证据(每条回链来源)</a:t>
-            </a:r>
-          </a:p>
-          <a:p>
-            <a:pPr algn="l">
-              <a:spcBef>
-                <a:spcPts val="0"/>
-              </a:spcBef>
-              <a:spcAft>
-                <a:spcPts val="95"/>
-              </a:spcAft>
-            </a:pPr>
-            <a:r>
-              <a:rPr sz="800" b="0">
-                <a:solidFill>
-                  <a:srgbClr val="1F2937"/>
-                </a:solidFill>
-                <a:latin typeface="Consolas"/>
-                <a:ea typeface="Consolas"/>
-                <a:cs typeface="Consolas"/>
-              </a:rPr>
-              <a:t>│  ├─ benchmarks/                       </a:t>
-            </a:r>
-            <a:r>
-              <a:rPr sz="760" b="0">
-                <a:solidFill>
-                  <a:srgbClr val="6B7280"/>
-                </a:solidFill>
-                <a:latin typeface="Microsoft YaHei"/>
-                <a:ea typeface="Microsoft YaHei"/>
-                <a:cs typeface="Microsoft YaHei"/>
-              </a:rPr>
-              <a:t># 例:mm-reclaim_2026Q2.json</a:t>
-            </a:r>
-          </a:p>
-          <a:p>
-            <a:pPr algn="l">
-              <a:spcBef>
-                <a:spcPts val="0"/>
-              </a:spcBef>
-              <a:spcAft>
-                <a:spcPts val="95"/>
-              </a:spcAft>
-            </a:pPr>
-            <a:r>
-              <a:rPr sz="800" b="0">
-                <a:solidFill>
-                  <a:srgbClr val="1F2937"/>
-                </a:solidFill>
-                <a:latin typeface="Consolas"/>
-                <a:ea typeface="Consolas"/>
-                <a:cs typeface="Consolas"/>
-              </a:rPr>
-              <a:t>│  └─ regressions/                      </a:t>
-            </a:r>
-            <a:r>
-              <a:rPr sz="760" b="0">
-                <a:solidFill>
-                  <a:srgbClr val="6B7280"/>
-                </a:solidFill>
-                <a:latin typeface="Microsoft YaHei"/>
-                <a:ea typeface="Microsoft YaHei"/>
-                <a:cs typeface="Microsoft YaHei"/>
-              </a:rPr>
-              <a:t># 例:R031_shrink_node.json</a:t>
-            </a:r>
-          </a:p>
-          <a:p>
-            <a:pPr algn="l">
-              <a:spcBef>
-                <a:spcPts val="0"/>
-              </a:spcBef>
-              <a:spcAft>
-                <a:spcPts val="95"/>
-              </a:spcAft>
-            </a:pPr>
-            <a:r>
-              <a:rPr sz="800" b="0">
-                <a:solidFill>
-                  <a:srgbClr val="1F2937"/>
-                </a:solidFill>
-                <a:latin typeface="Consolas"/>
-                <a:ea typeface="Consolas"/>
-                <a:cs typeface="Consolas"/>
-              </a:rPr>
-              <a:t>├─ eval/                                </a:t>
-            </a:r>
-            <a:r>
-              <a:rPr sz="760" b="0">
-                <a:solidFill>
-                  <a:srgbClr val="6B7280"/>
-                </a:solidFill>
-                <a:latin typeface="Microsoft YaHei"/>
-                <a:ea typeface="Microsoft YaHei"/>
-                <a:cs typeface="Microsoft YaHei"/>
-              </a:rPr>
-              <a:t># 顶层·团队共享评测(区别于技能内 evals/)</a:t>
-            </a:r>
-          </a:p>
-          <a:p>
-            <a:pPr algn="l">
-              <a:spcBef>
-                <a:spcPts val="0"/>
-              </a:spcBef>
-              <a:spcAft>
-                <a:spcPts val="95"/>
-              </a:spcAft>
-            </a:pPr>
-            <a:r>
-              <a:rPr sz="800" b="0">
-                <a:solidFill>
-                  <a:srgbClr val="1F2937"/>
-                </a:solidFill>
-                <a:latin typeface="Consolas"/>
-                <a:ea typeface="Consolas"/>
-                <a:cs typeface="Consolas"/>
-              </a:rPr>
-              <a:t>│  ├─ task_suites/                      </a:t>
-            </a:r>
-            <a:r>
-              <a:rPr sz="760" b="0">
-                <a:solidFill>
-                  <a:srgbClr val="6B7280"/>
-                </a:solidFill>
-                <a:latin typeface="Microsoft YaHei"/>
-                <a:ea typeface="Microsoft YaHei"/>
-                <a:cs typeface="Microsoft YaHei"/>
-              </a:rPr>
-              <a:t># 可复用任务集 例:mm_reclaim_suite/</a:t>
-            </a:r>
-          </a:p>
-          <a:p>
-            <a:pPr algn="l">
-              <a:spcBef>
-                <a:spcPts val="0"/>
-              </a:spcBef>
-              <a:spcAft>
-                <a:spcPts val="95"/>
-              </a:spcAft>
-            </a:pPr>
-            <a:r>
-              <a:rPr sz="800" b="0">
-                <a:solidFill>
-                  <a:srgbClr val="1F2937"/>
-                </a:solidFill>
-                <a:latin typeface="Consolas"/>
-                <a:ea typeface="Consolas"/>
-                <a:cs typeface="Consolas"/>
-              </a:rPr>
-              <a:t>│  └─ scorecards/                       </a:t>
-            </a:r>
-            <a:r>
-              <a:rPr sz="760" b="0">
-                <a:solidFill>
-                  <a:srgbClr val="6B7280"/>
-                </a:solidFill>
-                <a:latin typeface="Microsoft YaHei"/>
-                <a:ea typeface="Microsoft YaHei"/>
-                <a:cs typeface="Microsoft YaHei"/>
-              </a:rPr>
-              <a:t># 发布级评分 例:funnel_v3_*.md</a:t>
-            </a:r>
-          </a:p>
-          <a:p>
-            <a:pPr algn="l">
-              <a:spcBef>
-                <a:spcPts val="0"/>
-              </a:spcBef>
-              <a:spcAft>
-                <a:spcPts val="95"/>
-              </a:spcAft>
-            </a:pPr>
-            <a:r>
-              <a:rPr sz="800" b="0">
-                <a:solidFill>
-                  <a:srgbClr val="1F2937"/>
-                </a:solidFill>
-                <a:latin typeface="Consolas"/>
-                <a:ea typeface="Consolas"/>
-                <a:cs typeface="Consolas"/>
-              </a:rPr>
-              <a:t>└─ policies/ staging/ tools/ .github/   </a:t>
-            </a:r>
-            <a:r>
-              <a:rPr sz="760" b="0">
-                <a:solidFill>
-                  <a:srgbClr val="6B7280"/>
-                </a:solidFill>
-                <a:latin typeface="Microsoft YaHei"/>
-                <a:ea typeface="Microsoft YaHei"/>
-                <a:cs typeface="Microsoft YaHei"/>
-              </a:rPr>
-              <a:t># 规则·入站候选·脚本·CI 门</a:t>
-            </a:r>
-          </a:p>
-        </p:txBody>
-      </p:sp>
-      <p:sp>
-        <p:nvSpPr>
-          <p:cNvPr id="10" name="Rounded Rectangle 9"/>
-          <p:cNvSpPr/>
-          <p:nvPr/>
-        </p:nvSpPr>
-        <p:spPr>
-          <a:xfrm>
-            <a:off x="7452360" y="1078992"/>
-            <a:ext cx="4325112" cy="2505456"/>
-          </a:xfrm>
-          <a:prstGeom prst="roundRect">
-            <a:avLst>
-              <a:gd name="adj" fmla="val 3000"/>
-            </a:avLst>
-          </a:prstGeom>
-          <a:solidFill>
-            <a:srgbClr val="FFFFFF"/>
-          </a:solidFill>
-          <a:ln w="12700">
-            <a:solidFill>
-              <a:srgbClr val="0D9488"/>
-            </a:solidFill>
-          </a:ln>
-          <a:effectLst/>
-        </p:spPr>
-        <p:style>
-          <a:lnRef idx="1">
-            <a:schemeClr val="accent1"/>
-          </a:lnRef>
-          <a:fillRef idx="3">
-            <a:schemeClr val="accent1"/>
-          </a:fillRef>
-          <a:effectRef idx="2">
-            <a:schemeClr val="accent1"/>
-          </a:effectRef>
-          <a:fontRef idx="minor">
-            <a:schemeClr val="lt1"/>
-          </a:fontRef>
-        </p:style>
-        <p:txBody>
-          <a:bodyPr rtlCol="0" anchor="ctr"/>
-          <a:lstStyle/>
-          <a:p>
-            <a:pPr algn="ctr"/>
+              <a:rPr sz="1019" b="1">
+                <a:solidFill>
+                  <a:srgbClr val="0F1E3D"/>
+                </a:solidFill>
+                <a:latin typeface="Microsoft YaHei"/>
+                <a:ea typeface="Microsoft YaHei"/>
+                <a:cs typeface="Microsoft YaHei"/>
+              </a:rPr>
+              <a:t>三类资产 → 唯一归宿</a:t>
+            </a:r>
           </a:p>
         </p:txBody>
       </p:sp>
@@ -10549,8 +11202,8 @@
         </p:nvSpPr>
         <p:spPr>
           <a:xfrm>
-            <a:off x="7589520" y="1152144"/>
-            <a:ext cx="4114800" cy="292608"/>
+            <a:off x="7680960" y="2779776"/>
+            <a:ext cx="4370832" cy="676656"/>
           </a:xfrm>
           <a:prstGeom prst="rect">
             <a:avLst/>
@@ -10572,15 +11225,36 @@
               </a:spcAft>
             </a:pPr>
             <a:r>
-              <a:rPr sz="1100" b="1">
-                <a:solidFill>
-                  <a:srgbClr val="0D9488"/>
-                </a:solidFill>
-                <a:latin typeface="Microsoft YaHei"/>
-                <a:ea typeface="Microsoft YaHei"/>
-                <a:cs typeface="Microsoft YaHei"/>
-              </a:rPr>
-              <a:t>② 业务仓 .opencode/ — 每成员执行面</a:t>
+              <a:rPr sz="840" b="0">
+                <a:solidFill>
+                  <a:srgbClr val="1F2937"/>
+                </a:solidFill>
+                <a:latin typeface="Microsoft YaHei"/>
+                <a:ea typeface="Microsoft YaHei"/>
+                <a:cs typeface="Microsoft YaHei"/>
+              </a:rPr>
+              <a:t>做法/流程 → hub（skills · agents · commands · pipelines · docs）</a:t>
+            </a:r>
+          </a:p>
+          <a:p>
+            <a:pPr algn="l">
+              <a:spcBef>
+                <a:spcPts val="0"/>
+              </a:spcBef>
+              <a:spcAft>
+                <a:spcPts val="300"/>
+              </a:spcAft>
+            </a:pPr>
+            <a:r>
+              <a:rPr sz="840" b="0">
+                <a:solidFill>
+                  <a:srgbClr val="1F2937"/>
+                </a:solidFill>
+                <a:latin typeface="Microsoft YaHei"/>
+                <a:ea typeface="Microsoft YaHei"/>
+                <a:cs typeface="Microsoft YaHei"/>
+              </a:rPr>
+              <a:t>事实/教训 → hub knowledge ｜ 运行证据 → local/</a:t>
             </a:r>
           </a:p>
         </p:txBody>
@@ -10593,720 +11267,8 @@
         </p:nvSpPr>
         <p:spPr>
           <a:xfrm>
-            <a:off x="7498079" y="1444752"/>
-            <a:ext cx="4206240" cy="2103120"/>
-          </a:xfrm>
-          <a:prstGeom prst="rect">
-            <a:avLst/>
-          </a:prstGeom>
-          <a:noFill/>
-        </p:spPr>
-        <p:txBody>
-          <a:bodyPr wrap="none" anchor="t" lIns="128016" rIns="54864" tIns="91440">
-            <a:spAutoFit/>
-          </a:bodyPr>
-          <a:lstStyle/>
-          <a:p>
-            <a:pPr algn="l">
-              <a:spcBef>
-                <a:spcPts val="0"/>
-              </a:spcBef>
-              <a:spcAft>
-                <a:spcPts val="170"/>
-              </a:spcAft>
-            </a:pPr>
-            <a:r>
-              <a:rPr sz="830" b="0">
-                <a:solidFill>
-                  <a:srgbClr val="1F2937"/>
-                </a:solidFill>
-                <a:latin typeface="Consolas"/>
-                <a:ea typeface="Consolas"/>
-                <a:cs typeface="Consolas"/>
-              </a:rPr>
-              <a:t>.opencode/                 </a:t>
-            </a:r>
-            <a:r>
-              <a:rPr sz="790" b="0">
-                <a:solidFill>
-                  <a:srgbClr val="6B7280"/>
-                </a:solidFill>
-                <a:latin typeface="Microsoft YaHei"/>
-                <a:ea typeface="Microsoft YaHei"/>
-                <a:cs typeface="Microsoft YaHei"/>
-              </a:rPr>
-              <a:t># 在业务仓内 · 执行面</a:t>
-            </a:r>
-          </a:p>
-          <a:p>
-            <a:pPr algn="l">
-              <a:spcBef>
-                <a:spcPts val="0"/>
-              </a:spcBef>
-              <a:spcAft>
-                <a:spcPts val="170"/>
-              </a:spcAft>
-            </a:pPr>
-            <a:r>
-              <a:rPr sz="830" b="0">
-                <a:solidFill>
-                  <a:srgbClr val="1F2937"/>
-                </a:solidFill>
-                <a:latin typeface="Consolas"/>
-                <a:ea typeface="Consolas"/>
-                <a:cs typeface="Consolas"/>
-              </a:rPr>
-              <a:t>├─ hub/                    </a:t>
-            </a:r>
-            <a:r>
-              <a:rPr sz="790" b="0">
-                <a:solidFill>
-                  <a:srgbClr val="6B7280"/>
-                </a:solidFill>
-                <a:latin typeface="Microsoft YaHei"/>
-                <a:ea typeface="Microsoft YaHei"/>
-                <a:cs typeface="Microsoft YaHei"/>
-              </a:rPr>
-              <a:t># 子模块·锁定版本(只读)</a:t>
-            </a:r>
-          </a:p>
-          <a:p>
-            <a:pPr algn="l">
-              <a:spcBef>
-                <a:spcPts val="0"/>
-              </a:spcBef>
-              <a:spcAft>
-                <a:spcPts val="170"/>
-              </a:spcAft>
-            </a:pPr>
-            <a:r>
-              <a:rPr sz="830" b="0">
-                <a:solidFill>
-                  <a:srgbClr val="1F2937"/>
-                </a:solidFill>
-                <a:latin typeface="Consolas"/>
-                <a:ea typeface="Consolas"/>
-                <a:cs typeface="Consolas"/>
-              </a:rPr>
-              <a:t>├─ local/                  </a:t>
-            </a:r>
-            <a:r>
-              <a:rPr sz="790" b="0">
-                <a:solidFill>
-                  <a:srgbClr val="6B7280"/>
-                </a:solidFill>
-                <a:latin typeface="Microsoft YaHei"/>
-                <a:ea typeface="Microsoft YaHei"/>
-                <a:cs typeface="Microsoft YaHei"/>
-              </a:rPr>
-              <a:t># 本成员执行产物</a:t>
-            </a:r>
-          </a:p>
-          <a:p>
-            <a:pPr algn="l">
-              <a:spcBef>
-                <a:spcPts val="0"/>
-              </a:spcBef>
-              <a:spcAft>
-                <a:spcPts val="170"/>
-              </a:spcAft>
-            </a:pPr>
-            <a:r>
-              <a:rPr sz="830" b="0">
-                <a:solidFill>
-                  <a:srgbClr val="1F2937"/>
-                </a:solidFill>
-                <a:latin typeface="Consolas"/>
-                <a:ea typeface="Consolas"/>
-                <a:cs typeface="Consolas"/>
-              </a:rPr>
-              <a:t>│   runs/&lt;run_id&gt;/         </a:t>
-            </a:r>
-            <a:r>
-              <a:rPr sz="790" b="0">
-                <a:solidFill>
-                  <a:srgbClr val="6B7280"/>
-                </a:solidFill>
-                <a:latin typeface="Microsoft YaHei"/>
-                <a:ea typeface="Microsoft YaHei"/>
-                <a:cs typeface="Microsoft YaHei"/>
-              </a:rPr>
-              <a:t># plans/reviews/bench…</a:t>
-            </a:r>
-          </a:p>
-          <a:p>
-            <a:pPr algn="l">
-              <a:spcBef>
-                <a:spcPts val="0"/>
-              </a:spcBef>
-              <a:spcAft>
-                <a:spcPts val="170"/>
-              </a:spcAft>
-            </a:pPr>
-            <a:r>
-              <a:rPr sz="830" b="0">
-                <a:solidFill>
-                  <a:srgbClr val="1F2937"/>
-                </a:solidFill>
-                <a:latin typeface="Consolas"/>
-                <a:ea typeface="Consolas"/>
-                <a:cs typeface="Consolas"/>
-              </a:rPr>
-              <a:t>│     &lt;target&gt;_design.md   </a:t>
-            </a:r>
-            <a:r>
-              <a:rPr sz="790" b="0">
-                <a:solidFill>
-                  <a:srgbClr val="6B7280"/>
-                </a:solidFill>
-                <a:latin typeface="Microsoft YaHei"/>
-                <a:ea typeface="Microsoft YaHei"/>
-                <a:cs typeface="Microsoft YaHei"/>
-              </a:rPr>
-              <a:t># 运行证据(建议留存)</a:t>
-            </a:r>
-          </a:p>
-          <a:p>
-            <a:pPr algn="l">
-              <a:spcBef>
-                <a:spcPts val="0"/>
-              </a:spcBef>
-              <a:spcAft>
-                <a:spcPts val="170"/>
-              </a:spcAft>
-            </a:pPr>
-            <a:r>
-              <a:rPr sz="830" b="0">
-                <a:solidFill>
-                  <a:srgbClr val="1F2937"/>
-                </a:solidFill>
-                <a:latin typeface="Consolas"/>
-                <a:ea typeface="Consolas"/>
-                <a:cs typeface="Consolas"/>
-              </a:rPr>
-              <a:t>│   memory/                </a:t>
-            </a:r>
-            <a:r>
-              <a:rPr sz="790" b="0">
-                <a:solidFill>
-                  <a:srgbClr val="6B7280"/>
-                </a:solidFill>
-                <a:latin typeface="Microsoft YaHei"/>
-                <a:ea typeface="Microsoft YaHei"/>
-                <a:cs typeface="Microsoft YaHei"/>
-              </a:rPr>
-              <a:t># 在途记忆(Tier1)</a:t>
-            </a:r>
-          </a:p>
-          <a:p>
-            <a:pPr algn="l">
-              <a:spcBef>
-                <a:spcPts val="0"/>
-              </a:spcBef>
-              <a:spcAft>
-                <a:spcPts val="170"/>
-              </a:spcAft>
-            </a:pPr>
-            <a:r>
-              <a:rPr sz="830" b="0">
-                <a:solidFill>
-                  <a:srgbClr val="1F2937"/>
-                </a:solidFill>
-                <a:latin typeface="Consolas"/>
-                <a:ea typeface="Consolas"/>
-                <a:cs typeface="Consolas"/>
-              </a:rPr>
-              <a:t>│   sediment_staging/      </a:t>
-            </a:r>
-            <a:r>
-              <a:rPr sz="790" b="0">
-                <a:solidFill>
-                  <a:srgbClr val="6B7280"/>
-                </a:solidFill>
-                <a:latin typeface="Microsoft YaHei"/>
-                <a:ea typeface="Microsoft YaHei"/>
-                <a:cs typeface="Microsoft YaHei"/>
-              </a:rPr>
-              <a:t># 候选包 → PR 到 hub</a:t>
-            </a:r>
-          </a:p>
-          <a:p>
-            <a:pPr algn="l">
-              <a:spcBef>
-                <a:spcPts val="0"/>
-              </a:spcBef>
-              <a:spcAft>
-                <a:spcPts val="170"/>
-              </a:spcAft>
-            </a:pPr>
-            <a:r>
-              <a:rPr sz="830" b="0">
-                <a:solidFill>
-                  <a:srgbClr val="1F2937"/>
-                </a:solidFill>
-                <a:latin typeface="Consolas"/>
-                <a:ea typeface="Consolas"/>
-                <a:cs typeface="Consolas"/>
-              </a:rPr>
-              <a:t>├─ state/current_task.json </a:t>
-            </a:r>
-            <a:r>
-              <a:rPr sz="790" b="0">
-                <a:solidFill>
-                  <a:srgbClr val="6B7280"/>
-                </a:solidFill>
-                <a:latin typeface="Microsoft YaHei"/>
-                <a:ea typeface="Microsoft YaHei"/>
-                <a:cs typeface="Microsoft YaHei"/>
-              </a:rPr>
-              <a:t># 纯运行态(gitignore)</a:t>
-            </a:r>
-          </a:p>
-          <a:p>
-            <a:pPr algn="l">
-              <a:spcBef>
-                <a:spcPts val="0"/>
-              </a:spcBef>
-              <a:spcAft>
-                <a:spcPts val="170"/>
-              </a:spcAft>
-            </a:pPr>
-            <a:r>
-              <a:rPr sz="830" b="0">
-                <a:solidFill>
-                  <a:srgbClr val="1F2937"/>
-                </a:solidFill>
-                <a:latin typeface="Consolas"/>
-                <a:ea typeface="Consolas"/>
-                <a:cs typeface="Consolas"/>
-              </a:rPr>
-              <a:t>├─ skill-memory.lock       </a:t>
-            </a:r>
-            <a:r>
-              <a:rPr sz="790" b="0">
-                <a:solidFill>
-                  <a:srgbClr val="6B7280"/>
-                </a:solidFill>
-                <a:latin typeface="Microsoft YaHei"/>
-                <a:ea typeface="Microsoft YaHei"/>
-                <a:cs typeface="Microsoft YaHei"/>
-              </a:rPr>
-              <a:t># 锁定版本(semver+SHA)</a:t>
-            </a:r>
-          </a:p>
-          <a:p>
-            <a:pPr algn="l">
-              <a:spcBef>
-                <a:spcPts val="0"/>
-              </a:spcBef>
-              <a:spcAft>
-                <a:spcPts val="170"/>
-              </a:spcAft>
-            </a:pPr>
-            <a:r>
-              <a:rPr sz="830" b="0">
-                <a:solidFill>
-                  <a:srgbClr val="1F2937"/>
-                </a:solidFill>
-                <a:latin typeface="Consolas"/>
-                <a:ea typeface="Consolas"/>
-                <a:cs typeface="Consolas"/>
-              </a:rPr>
-              <a:t>└─ resolver.py             </a:t>
-            </a:r>
-            <a:r>
-              <a:rPr sz="790" b="0">
-                <a:solidFill>
-                  <a:srgbClr val="6B7280"/>
-                </a:solidFill>
-                <a:latin typeface="Microsoft YaHei"/>
-                <a:ea typeface="Microsoft YaHei"/>
-                <a:cs typeface="Microsoft YaHei"/>
-              </a:rPr>
-              <a:t># 先 hub 再叠加 local</a:t>
-            </a:r>
-          </a:p>
-        </p:txBody>
-      </p:sp>
-      <p:sp>
-        <p:nvSpPr>
-          <p:cNvPr id="13" name="Rounded Rectangle 12"/>
-          <p:cNvSpPr/>
-          <p:nvPr/>
-        </p:nvSpPr>
-        <p:spPr>
-          <a:xfrm>
-            <a:off x="7452360" y="3694176"/>
-            <a:ext cx="4325112" cy="877824"/>
-          </a:xfrm>
-          <a:prstGeom prst="roundRect">
-            <a:avLst>
-              <a:gd name="adj" fmla="val 8000"/>
-            </a:avLst>
-          </a:prstGeom>
-          <a:solidFill>
-            <a:srgbClr val="F1F5F9"/>
-          </a:solidFill>
-          <a:ln w="12700">
-            <a:solidFill>
-              <a:srgbClr val="CBD5E1"/>
-            </a:solidFill>
-          </a:ln>
-          <a:effectLst/>
-        </p:spPr>
-        <p:style>
-          <a:lnRef idx="1">
-            <a:schemeClr val="accent1"/>
-          </a:lnRef>
-          <a:fillRef idx="3">
-            <a:schemeClr val="accent1"/>
-          </a:fillRef>
-          <a:effectRef idx="2">
-            <a:schemeClr val="accent1"/>
-          </a:effectRef>
-          <a:fontRef idx="minor">
-            <a:schemeClr val="lt1"/>
-          </a:fontRef>
-        </p:style>
-        <p:txBody>
-          <a:bodyPr rtlCol="0" anchor="t" wrap="square" lIns="73152" rIns="73152" tIns="27432" bIns="27432"/>
-          <a:lstStyle/>
-          <a:p>
-            <a:pPr algn="ctr">
-              <a:spcBef>
-                <a:spcPts val="0"/>
-              </a:spcBef>
-              <a:spcAft>
-                <a:spcPts val="300"/>
-              </a:spcAft>
-            </a:pPr>
-            <a:r>
-              <a:rPr sz="1050" b="1">
-                <a:solidFill>
-                  <a:srgbClr val="1F2937"/>
-                </a:solidFill>
-                <a:latin typeface="Microsoft YaHei"/>
-                <a:ea typeface="Microsoft YaHei"/>
-                <a:cs typeface="Microsoft YaHei"/>
-              </a:rPr>
-              <a:t>三类资产 → 唯一归宿</a:t>
-            </a:r>
-          </a:p>
-          <a:p>
-            <a:pPr algn="ctr">
-              <a:spcBef>
-                <a:spcPts val="0"/>
-              </a:spcBef>
-              <a:spcAft>
-                <a:spcPts val="300"/>
-              </a:spcAft>
-            </a:pPr>
-            <a:r>
-              <a:rPr sz="840" b="0">
-                <a:solidFill>
-                  <a:srgbClr val="6B7280"/>
-                </a:solidFill>
-                <a:latin typeface="Microsoft YaHei"/>
-                <a:ea typeface="Microsoft YaHei"/>
-                <a:cs typeface="Microsoft YaHei"/>
-              </a:rPr>
-              <a:t>做法/流程 → hub（skills · agents · commands · pipelines · docs）</a:t>
-            </a:r>
-          </a:p>
-          <a:p>
-            <a:pPr algn="ctr">
-              <a:spcBef>
-                <a:spcPts val="0"/>
-              </a:spcBef>
-              <a:spcAft>
-                <a:spcPts val="300"/>
-              </a:spcAft>
-            </a:pPr>
-            <a:r>
-              <a:rPr sz="840" b="0">
-                <a:solidFill>
-                  <a:srgbClr val="6B7280"/>
-                </a:solidFill>
-                <a:latin typeface="Microsoft YaHei"/>
-                <a:ea typeface="Microsoft YaHei"/>
-                <a:cs typeface="Microsoft YaHei"/>
-              </a:rPr>
-              <a:t>事实/教训 → hub knowledge ｜ 运行证据 → local/</a:t>
-            </a:r>
-          </a:p>
-        </p:txBody>
-      </p:sp>
-      <p:sp>
-        <p:nvSpPr>
-          <p:cNvPr id="14" name="Rounded Rectangle 13"/>
-          <p:cNvSpPr/>
-          <p:nvPr/>
-        </p:nvSpPr>
-        <p:spPr>
-          <a:xfrm>
-            <a:off x="7452360" y="4645152"/>
-            <a:ext cx="4325112" cy="548640"/>
-          </a:xfrm>
-          <a:prstGeom prst="roundRect">
-            <a:avLst>
-              <a:gd name="adj" fmla="val 10000"/>
-            </a:avLst>
-          </a:prstGeom>
-          <a:solidFill>
-            <a:srgbClr val="EEF2FF"/>
-          </a:solidFill>
-          <a:ln w="12700">
-            <a:solidFill>
-              <a:srgbClr val="4F46E5"/>
-            </a:solidFill>
-          </a:ln>
-          <a:effectLst/>
-        </p:spPr>
-        <p:style>
-          <a:lnRef idx="1">
-            <a:schemeClr val="accent1"/>
-          </a:lnRef>
-          <a:fillRef idx="3">
-            <a:schemeClr val="accent1"/>
-          </a:fillRef>
-          <a:effectRef idx="2">
-            <a:schemeClr val="accent1"/>
-          </a:effectRef>
-          <a:fontRef idx="minor">
-            <a:schemeClr val="lt1"/>
-          </a:fontRef>
-        </p:style>
-        <p:txBody>
-          <a:bodyPr rtlCol="0" anchor="t" wrap="square" lIns="73152" rIns="73152" tIns="27432" bIns="27432"/>
-          <a:lstStyle/>
-          <a:p>
-            <a:pPr algn="ctr">
-              <a:spcBef>
-                <a:spcPts val="0"/>
-              </a:spcBef>
-              <a:spcAft>
-                <a:spcPts val="300"/>
-              </a:spcAft>
-            </a:pPr>
-            <a:r>
-              <a:rPr sz="1100" b="1">
-                <a:solidFill>
-                  <a:srgbClr val="4F46E5"/>
-                </a:solidFill>
-                <a:latin typeface="Microsoft YaHei"/>
-                <a:ea typeface="Microsoft YaHei"/>
-                <a:cs typeface="Microsoft YaHei"/>
-              </a:rPr>
-              <a:t>资产面 / 执行面分离</a:t>
-            </a:r>
-          </a:p>
-          <a:p>
-            <a:pPr algn="ctr">
-              <a:spcBef>
-                <a:spcPts val="0"/>
-              </a:spcBef>
-              <a:spcAft>
-                <a:spcPts val="300"/>
-              </a:spcAft>
-            </a:pPr>
-            <a:r>
-              <a:rPr sz="950" b="0">
-                <a:solidFill>
-                  <a:srgbClr val="1F2937"/>
-                </a:solidFill>
-                <a:latin typeface="Microsoft YaHei"/>
-                <a:ea typeface="Microsoft YaHei"/>
-                <a:cs typeface="Microsoft YaHei"/>
-              </a:rPr>
-              <a:t>hub 只读·共享·版本化；local 个人·在途</a:t>
-            </a:r>
-          </a:p>
-        </p:txBody>
-      </p:sp>
-      <p:sp>
-        <p:nvSpPr>
-          <p:cNvPr id="15" name="Rounded Rectangle 14"/>
-          <p:cNvSpPr/>
-          <p:nvPr/>
-        </p:nvSpPr>
-        <p:spPr>
-          <a:xfrm>
-            <a:off x="7452360" y="5230368"/>
-            <a:ext cx="4325112" cy="548640"/>
-          </a:xfrm>
-          <a:prstGeom prst="roundRect">
-            <a:avLst>
-              <a:gd name="adj" fmla="val 10000"/>
-            </a:avLst>
-          </a:prstGeom>
-          <a:solidFill>
-            <a:srgbClr val="FFECDC"/>
-          </a:solidFill>
-          <a:ln w="12700">
-            <a:solidFill>
-              <a:srgbClr val="EA580C"/>
-            </a:solidFill>
-          </a:ln>
-          <a:effectLst/>
-        </p:spPr>
-        <p:style>
-          <a:lnRef idx="1">
-            <a:schemeClr val="accent1"/>
-          </a:lnRef>
-          <a:fillRef idx="3">
-            <a:schemeClr val="accent1"/>
-          </a:fillRef>
-          <a:effectRef idx="2">
-            <a:schemeClr val="accent1"/>
-          </a:effectRef>
-          <a:fontRef idx="minor">
-            <a:schemeClr val="lt1"/>
-          </a:fontRef>
-        </p:style>
-        <p:txBody>
-          <a:bodyPr rtlCol="0" anchor="t" wrap="square" lIns="73152" rIns="73152" tIns="27432" bIns="27432"/>
-          <a:lstStyle/>
-          <a:p>
-            <a:pPr algn="ctr">
-              <a:spcBef>
-                <a:spcPts val="0"/>
-              </a:spcBef>
-              <a:spcAft>
-                <a:spcPts val="300"/>
-              </a:spcAft>
-            </a:pPr>
-            <a:r>
-              <a:rPr sz="1100" b="1">
-                <a:solidFill>
-                  <a:srgbClr val="EA580C"/>
-                </a:solidFill>
-                <a:latin typeface="Microsoft YaHei"/>
-                <a:ea typeface="Microsoft YaHei"/>
-                <a:cs typeface="Microsoft YaHei"/>
-              </a:rPr>
-              <a:t>每条知识 = 一文件 + 稳定 ID</a:t>
-            </a:r>
-          </a:p>
-          <a:p>
-            <a:pPr algn="ctr">
-              <a:spcBef>
-                <a:spcPts val="0"/>
-              </a:spcBef>
-              <a:spcAft>
-                <a:spcPts val="300"/>
-              </a:spcAft>
-            </a:pPr>
-            <a:r>
-              <a:rPr sz="950" b="0">
-                <a:solidFill>
-                  <a:srgbClr val="1F2937"/>
-                </a:solidFill>
-                <a:latin typeface="Microsoft YaHei"/>
-                <a:ea typeface="Microsoft YaHei"/>
-                <a:cs typeface="Microsoft YaHei"/>
-              </a:rPr>
-              <a:t>规避 git 行级冲突，热点文件不争用</a:t>
-            </a:r>
-          </a:p>
-        </p:txBody>
-      </p:sp>
-      <p:sp>
-        <p:nvSpPr>
-          <p:cNvPr id="16" name="Rounded Rectangle 15"/>
-          <p:cNvSpPr/>
-          <p:nvPr/>
-        </p:nvSpPr>
-        <p:spPr>
-          <a:xfrm>
-            <a:off x="7452360" y="5815584"/>
-            <a:ext cx="4325112" cy="530352"/>
-          </a:xfrm>
-          <a:prstGeom prst="roundRect">
-            <a:avLst>
-              <a:gd name="adj" fmla="val 10000"/>
-            </a:avLst>
-          </a:prstGeom>
-          <a:solidFill>
-            <a:srgbClr val="DDF3E5"/>
-          </a:solidFill>
-          <a:ln w="12700">
-            <a:solidFill>
-              <a:srgbClr val="16A34A"/>
-            </a:solidFill>
-          </a:ln>
-          <a:effectLst/>
-        </p:spPr>
-        <p:style>
-          <a:lnRef idx="1">
-            <a:schemeClr val="accent1"/>
-          </a:lnRef>
-          <a:fillRef idx="3">
-            <a:schemeClr val="accent1"/>
-          </a:fillRef>
-          <a:effectRef idx="2">
-            <a:schemeClr val="accent1"/>
-          </a:effectRef>
-          <a:fontRef idx="minor">
-            <a:schemeClr val="lt1"/>
-          </a:fontRef>
-        </p:style>
-        <p:txBody>
-          <a:bodyPr rtlCol="0" anchor="t" wrap="square" lIns="73152" rIns="73152" tIns="27432" bIns="27432"/>
-          <a:lstStyle/>
-          <a:p>
-            <a:pPr algn="ctr">
-              <a:spcBef>
-                <a:spcPts val="0"/>
-              </a:spcBef>
-              <a:spcAft>
-                <a:spcPts val="300"/>
-              </a:spcAft>
-            </a:pPr>
-            <a:r>
-              <a:rPr sz="1100" b="1">
-                <a:solidFill>
-                  <a:srgbClr val="16A34A"/>
-                </a:solidFill>
-                <a:latin typeface="Microsoft YaHei"/>
-                <a:ea typeface="Microsoft YaHei"/>
-                <a:cs typeface="Microsoft YaHei"/>
-              </a:rPr>
-              <a:t>子模块锁定 + 版本锁文件</a:t>
-            </a:r>
-          </a:p>
-          <a:p>
-            <a:pPr algn="ctr">
-              <a:spcBef>
-                <a:spcPts val="0"/>
-              </a:spcBef>
-              <a:spcAft>
-                <a:spcPts val="300"/>
-              </a:spcAft>
-            </a:pPr>
-            <a:r>
-              <a:rPr sz="950" b="0">
-                <a:solidFill>
-                  <a:srgbClr val="1F2937"/>
-                </a:solidFill>
-                <a:latin typeface="Microsoft YaHei"/>
-                <a:ea typeface="Microsoft YaHei"/>
-                <a:cs typeface="Microsoft YaHei"/>
-              </a:rPr>
-              <a:t>可复现·防漂移·中央仓宕机本地兜底</a:t>
-            </a:r>
-          </a:p>
-        </p:txBody>
-      </p:sp>
-      <p:sp>
-        <p:nvSpPr>
-          <p:cNvPr id="17" name="TextBox 16"/>
-          <p:cNvSpPr txBox="1"/>
-          <p:nvPr/>
-        </p:nvSpPr>
-        <p:spPr>
-          <a:xfrm>
-            <a:off x="457200" y="6537960"/>
-            <a:ext cx="11247120" cy="274320"/>
+            <a:off x="7635240" y="3419856"/>
+            <a:ext cx="4389120" cy="219456"/>
           </a:xfrm>
           <a:prstGeom prst="rect">
             <a:avLst/>
@@ -11328,15 +11290,340 @@
               </a:spcAft>
             </a:pPr>
             <a:r>
-              <a:rPr sz="900" b="0">
-                <a:solidFill>
-                  <a:srgbClr val="6B7280"/>
-                </a:solidFill>
-                <a:latin typeface="Microsoft YaHei"/>
-                <a:ea typeface="Microsoft YaHei"/>
-                <a:cs typeface="Microsoft YaHei"/>
-              </a:rPr>
-              <a:t>Team Skill Hub · Draft v2.2 · 2026-05</a:t>
+              <a:rPr sz="1019" b="1">
+                <a:solidFill>
+                  <a:srgbClr val="0F1E3D"/>
+                </a:solidFill>
+                <a:latin typeface="Microsoft YaHei"/>
+                <a:ea typeface="Microsoft YaHei"/>
+                <a:cs typeface="Microsoft YaHei"/>
+              </a:rPr>
+              <a:t>布局设计要点</a:t>
+            </a:r>
+          </a:p>
+        </p:txBody>
+      </p:sp>
+      <p:sp>
+        <p:nvSpPr>
+          <p:cNvPr id="13" name="TextBox 12"/>
+          <p:cNvSpPr txBox="1"/>
+          <p:nvPr/>
+        </p:nvSpPr>
+        <p:spPr>
+          <a:xfrm>
+            <a:off x="7680960" y="3657600"/>
+            <a:ext cx="4370832" cy="676656"/>
+          </a:xfrm>
+          <a:prstGeom prst="rect">
+            <a:avLst/>
+          </a:prstGeom>
+          <a:noFill/>
+        </p:spPr>
+        <p:txBody>
+          <a:bodyPr wrap="square" anchor="t" lIns="73152" rIns="73152" tIns="27432" bIns="27432">
+            <a:spAutoFit/>
+          </a:bodyPr>
+          <a:lstStyle/>
+          <a:p>
+            <a:pPr algn="l">
+              <a:spcBef>
+                <a:spcPts val="0"/>
+              </a:spcBef>
+              <a:spcAft>
+                <a:spcPts val="300"/>
+              </a:spcAft>
+            </a:pPr>
+            <a:r>
+              <a:rPr sz="840" b="0">
+                <a:solidFill>
+                  <a:srgbClr val="1F2937"/>
+                </a:solidFill>
+                <a:latin typeface="Microsoft YaHei"/>
+                <a:ea typeface="Microsoft YaHei"/>
+                <a:cs typeface="Microsoft YaHei"/>
+              </a:rPr>
+              <a:t>· 资产/执行面分离：hub 只读共享·版本化；local 个人在途</a:t>
+            </a:r>
+          </a:p>
+          <a:p>
+            <a:pPr algn="l">
+              <a:spcBef>
+                <a:spcPts val="0"/>
+              </a:spcBef>
+              <a:spcAft>
+                <a:spcPts val="300"/>
+              </a:spcAft>
+            </a:pPr>
+            <a:r>
+              <a:rPr sz="840" b="0">
+                <a:solidFill>
+                  <a:srgbClr val="1F2937"/>
+                </a:solidFill>
+                <a:latin typeface="Microsoft YaHei"/>
+                <a:ea typeface="Microsoft YaHei"/>
+                <a:cs typeface="Microsoft YaHei"/>
+              </a:rPr>
+              <a:t>· 每条知识 = 一文件 + 稳定 ID：规避 git 行级冲突</a:t>
+            </a:r>
+          </a:p>
+          <a:p>
+            <a:pPr algn="l">
+              <a:spcBef>
+                <a:spcPts val="0"/>
+              </a:spcBef>
+              <a:spcAft>
+                <a:spcPts val="300"/>
+              </a:spcAft>
+            </a:pPr>
+            <a:r>
+              <a:rPr sz="840" b="0">
+                <a:solidFill>
+                  <a:srgbClr val="1F2937"/>
+                </a:solidFill>
+                <a:latin typeface="Microsoft YaHei"/>
+                <a:ea typeface="Microsoft YaHei"/>
+                <a:cs typeface="Microsoft YaHei"/>
+              </a:rPr>
+              <a:t>· 子模块锁定 + 版本锁：可复现·防漂移·宕机本地兜底</a:t>
+            </a:r>
+          </a:p>
+        </p:txBody>
+      </p:sp>
+      <p:sp>
+        <p:nvSpPr>
+          <p:cNvPr id="14" name="TextBox 13"/>
+          <p:cNvSpPr txBox="1"/>
+          <p:nvPr/>
+        </p:nvSpPr>
+        <p:spPr>
+          <a:xfrm>
+            <a:off x="7635240" y="4736592"/>
+            <a:ext cx="4389120" cy="219456"/>
+          </a:xfrm>
+          <a:prstGeom prst="rect">
+            <a:avLst/>
+          </a:prstGeom>
+          <a:noFill/>
+        </p:spPr>
+        <p:txBody>
+          <a:bodyPr wrap="square" anchor="t" lIns="73152" rIns="73152" tIns="27432" bIns="27432">
+            <a:spAutoFit/>
+          </a:bodyPr>
+          <a:lstStyle/>
+          <a:p>
+            <a:pPr algn="l">
+              <a:spcBef>
+                <a:spcPts val="0"/>
+              </a:spcBef>
+              <a:spcAft>
+                <a:spcPts val="300"/>
+              </a:spcAft>
+            </a:pPr>
+            <a:r>
+              <a:rPr sz="1019" b="1">
+                <a:solidFill>
+                  <a:srgbClr val="0F1E3D"/>
+                </a:solidFill>
+                <a:latin typeface="Microsoft YaHei"/>
+                <a:ea typeface="Microsoft YaHei"/>
+                <a:cs typeface="Microsoft YaHei"/>
+              </a:rPr>
+              <a:t>治理差异 · 谁过 eval-gate</a:t>
+            </a:r>
+          </a:p>
+        </p:txBody>
+      </p:sp>
+      <p:sp>
+        <p:nvSpPr>
+          <p:cNvPr id="15" name="TextBox 14"/>
+          <p:cNvSpPr txBox="1"/>
+          <p:nvPr/>
+        </p:nvSpPr>
+        <p:spPr>
+          <a:xfrm>
+            <a:off x="7680960" y="4974336"/>
+            <a:ext cx="4370832" cy="676656"/>
+          </a:xfrm>
+          <a:prstGeom prst="rect">
+            <a:avLst/>
+          </a:prstGeom>
+          <a:noFill/>
+        </p:spPr>
+        <p:txBody>
+          <a:bodyPr wrap="square" anchor="t" lIns="73152" rIns="73152" tIns="27432" bIns="27432">
+            <a:spAutoFit/>
+          </a:bodyPr>
+          <a:lstStyle/>
+          <a:p>
+            <a:pPr algn="l">
+              <a:spcBef>
+                <a:spcPts val="0"/>
+              </a:spcBef>
+              <a:spcAft>
+                <a:spcPts val="300"/>
+              </a:spcAft>
+            </a:pPr>
+            <a:r>
+              <a:rPr sz="840" b="0">
+                <a:solidFill>
+                  <a:srgbClr val="1F2937"/>
+                </a:solidFill>
+                <a:latin typeface="Microsoft YaHei"/>
+                <a:ea typeface="Microsoft YaHei"/>
+                <a:cs typeface="Microsoft YaHei"/>
+              </a:rPr>
+              <a:t>· skills/ → 引擎B：eval-gate 竞争式优化（严格变好才合并）</a:t>
+            </a:r>
+          </a:p>
+          <a:p>
+            <a:pPr algn="l">
+              <a:spcBef>
+                <a:spcPts val="0"/>
+              </a:spcBef>
+              <a:spcAft>
+                <a:spcPts val="300"/>
+              </a:spcAft>
+            </a:pPr>
+            <a:r>
+              <a:rPr sz="840" b="0">
+                <a:solidFill>
+                  <a:srgbClr val="1F2937"/>
+                </a:solidFill>
+                <a:latin typeface="Microsoft YaHei"/>
+                <a:ea typeface="Microsoft YaHei"/>
+                <a:cs typeface="Microsoft YaHei"/>
+              </a:rPr>
+              <a:t>· agents/commands/pipelines/docs → 评审制 + semver（不过 eval）</a:t>
+            </a:r>
+          </a:p>
+          <a:p>
+            <a:pPr algn="l">
+              <a:spcBef>
+                <a:spcPts val="0"/>
+              </a:spcBef>
+              <a:spcAft>
+                <a:spcPts val="300"/>
+              </a:spcAft>
+            </a:pPr>
+            <a:r>
+              <a:rPr sz="840" b="0">
+                <a:solidFill>
+                  <a:srgbClr val="1F2937"/>
+                </a:solidFill>
+                <a:latin typeface="Microsoft YaHei"/>
+                <a:ea typeface="Microsoft YaHei"/>
+                <a:cs typeface="Microsoft YaHei"/>
+              </a:rPr>
+              <a:t>· knowledge → 引擎A 集合并去重；evidence/eval → 回链审计</a:t>
+            </a:r>
+          </a:p>
+        </p:txBody>
+      </p:sp>
+      <p:sp>
+        <p:nvSpPr>
+          <p:cNvPr id="16" name="TextBox 15"/>
+          <p:cNvSpPr txBox="1"/>
+          <p:nvPr/>
+        </p:nvSpPr>
+        <p:spPr>
+          <a:xfrm>
+            <a:off x="7635240" y="5943600"/>
+            <a:ext cx="4389120" cy="219456"/>
+          </a:xfrm>
+          <a:prstGeom prst="rect">
+            <a:avLst/>
+          </a:prstGeom>
+          <a:noFill/>
+        </p:spPr>
+        <p:txBody>
+          <a:bodyPr wrap="square" anchor="t" lIns="73152" rIns="73152" tIns="27432" bIns="27432">
+            <a:spAutoFit/>
+          </a:bodyPr>
+          <a:lstStyle/>
+          <a:p>
+            <a:pPr algn="l">
+              <a:spcBef>
+                <a:spcPts val="0"/>
+              </a:spcBef>
+              <a:spcAft>
+                <a:spcPts val="300"/>
+              </a:spcAft>
+            </a:pPr>
+            <a:r>
+              <a:rPr sz="1019" b="1">
+                <a:solidFill>
+                  <a:srgbClr val="0F1E3D"/>
+                </a:solidFill>
+                <a:latin typeface="Microsoft YaHei"/>
+                <a:ea typeface="Microsoft YaHei"/>
+                <a:cs typeface="Microsoft YaHei"/>
+              </a:rPr>
+              <a:t>消费 · 高可用</a:t>
+            </a:r>
+          </a:p>
+        </p:txBody>
+      </p:sp>
+      <p:sp>
+        <p:nvSpPr>
+          <p:cNvPr id="17" name="TextBox 16"/>
+          <p:cNvSpPr txBox="1"/>
+          <p:nvPr/>
+        </p:nvSpPr>
+        <p:spPr>
+          <a:xfrm>
+            <a:off x="7680960" y="6181344"/>
+            <a:ext cx="4370832" cy="676656"/>
+          </a:xfrm>
+          <a:prstGeom prst="rect">
+            <a:avLst/>
+          </a:prstGeom>
+          <a:noFill/>
+        </p:spPr>
+        <p:txBody>
+          <a:bodyPr wrap="square" anchor="t" lIns="73152" rIns="73152" tIns="27432" bIns="27432">
+            <a:spAutoFit/>
+          </a:bodyPr>
+          <a:lstStyle/>
+          <a:p>
+            <a:pPr algn="l">
+              <a:spcBef>
+                <a:spcPts val="0"/>
+              </a:spcBef>
+              <a:spcAft>
+                <a:spcPts val="300"/>
+              </a:spcAft>
+            </a:pPr>
+            <a:r>
+              <a:rPr sz="840" b="0">
+                <a:solidFill>
+                  <a:srgbClr val="1F2937"/>
+                </a:solidFill>
+                <a:latin typeface="Microsoft YaHei"/>
+                <a:ea typeface="Microsoft YaHei"/>
+                <a:cs typeface="Microsoft YaHei"/>
+              </a:rPr>
+              <a:t>· submodule pin + skill-memory.lock：可复现、防漂移</a:t>
+            </a:r>
+          </a:p>
+          <a:p>
+            <a:pPr algn="l">
+              <a:spcBef>
+                <a:spcPts val="0"/>
+              </a:spcBef>
+              <a:spcAft>
+                <a:spcPts val="300"/>
+              </a:spcAft>
+            </a:pPr>
+            <a:r>
+              <a:rPr sz="840" b="0">
+                <a:solidFill>
+                  <a:srgbClr val="1F2937"/>
+                </a:solidFill>
+                <a:latin typeface="Microsoft YaHei"/>
+                <a:ea typeface="Microsoft YaHei"/>
+                <a:cs typeface="Microsoft YaHei"/>
+              </a:rPr>
+              <a:t>· 中央仓宕机 → resolver 回退上次本地快照并告警</a:t>
             </a:r>
           </a:p>
         </p:txBody>

</xml_diff>